<commit_message>
Intersection-size sweep on real data; fill the deck's sweep slide
sweep_n.py: test MSE vs matched-set size n (nested subsets of the training
folds) for the revised protocol and AdaSSP at eps 0.5-4 on bike, elevators,
pol and protein, relative to non-private at the same n, with 95% CIs over
folds and the n needed to come within 10% / 25% of non-private.

Deck: slide 29 now shows the sweep and its crossover table; the OpenFHE
cost placeholder moves to the crypto-results slide; takeaways updated.

Co-Authored-By: Claude Opus 5.5 <noreply@anthropic.com>
Claude-Session: https://claude.ai/code/session_01S5iva9x8cxUsdLiDVN39vQ
</commit_message>
<xml_diff>
--- a/slides/vfl_scenarioB_deck.pptx
+++ b/slides/vfl_scenarioB_deck.pptx
@@ -4908,7 +4908,7 @@
           <a:p>
             <a:r>
               <a:rPr lang="en-US" dirty="0"/>
-              <a:t>Correctness of linkage and aggregation: exact alignment and 1e-10 agreement with plaintext OLS when noise is off.</a:t>
+              <a:t>Correctness of linkage and aggregation: exact alignment and 1e-10 agreement with plaintext OLS when noise is off. All error comes from the DP noise and the ridge it forces. The table is a placeholder: the revised protocol's sanitization (fresh encryption, modulus switch, flooding) is not yet implemented in OpenFHE.</a:t>
             </a:r>
             <a:endParaRPr lang="en-US" dirty="0"/>
           </a:p>
@@ -5612,7 +5612,7 @@
           <a:p>
             <a:r>
               <a:rPr lang="en-US" dirty="0"/>
-              <a:t>Placeholders for results that need new runs: real-data intersection sweeps, and runtime and communication of the revised protocol once implemented in OpenFHE.</a:t>
+              <a:t>Real-data analogue of Figure A. From reports/adassp/sweep (experiments/adassp/sweep_n.py): bike, elevators, pol and protein, the four of Wang's datasets with at least 15k rows and a real linear signal (kin40k has none: non-private is no better than predicting zero). For each fold, the training folds are shuffled once and the first n rows are the matched set; the held-out fold is the test set. Crossings are log-linear interpolations of the mean curve; '&gt;15k' means never within 10% at the sizes available.</a:t>
             </a:r>
             <a:endParaRPr lang="en-US" dirty="0"/>
           </a:p>
@@ -16089,12 +16089,12 @@
         </p:nvSpPr>
         <p:spPr>
           <a:xfrm>
-            <a:off x="548640" y="1737360"/>
-            <a:ext cx="3566160" cy="3291840"/>
+            <a:off x="548640" y="1600200"/>
+            <a:ext cx="3566160" cy="2240280"/>
           </a:xfrm>
           <a:prstGeom prst="roundRect">
             <a:avLst>
-              <a:gd name="adj" fmla="val 2222"/>
+              <a:gd name="adj" fmla="val 3265"/>
             </a:avLst>
           </a:prstGeom>
           <a:solidFill>
@@ -16116,8 +16116,8 @@
         </p:nvSpPr>
         <p:spPr>
           <a:xfrm>
-            <a:off x="822960" y="1965960"/>
-            <a:ext cx="3108960" cy="1005840"/>
+            <a:off x="822960" y="1737360"/>
+            <a:ext cx="3108960" cy="777240"/>
           </a:xfrm>
           <a:prstGeom prst="rect">
             <a:avLst/>
@@ -16133,7 +16133,7 @@
               <a:buNone/>
             </a:pPr>
             <a:r>
-              <a:rPr lang="en-US" sz="4800" b="1" dirty="0">
+              <a:rPr lang="en-US" sz="3800" b="1" dirty="0">
                 <a:solidFill>
                   <a:srgbClr val="14213D"/>
                 </a:solidFill>
@@ -16143,7 +16143,7 @@
               </a:rPr>
               <a:t>0</a:t>
             </a:r>
-            <a:endParaRPr lang="en-US" sz="4800" dirty="0"/>
+            <a:endParaRPr lang="en-US" sz="3800" dirty="0"/>
           </a:p>
         </p:txBody>
       </p:sp>
@@ -16155,8 +16155,8 @@
         </p:nvSpPr>
         <p:spPr>
           <a:xfrm>
-            <a:off x="822960" y="3017520"/>
-            <a:ext cx="3108960" cy="411480"/>
+            <a:off x="822960" y="2542032"/>
+            <a:ext cx="3108960" cy="365760"/>
           </a:xfrm>
           <a:prstGeom prst="rect">
             <a:avLst/>
@@ -16172,7 +16172,7 @@
               <a:buNone/>
             </a:pPr>
             <a:r>
-              <a:rPr lang="en-US" sz="1600" b="1" dirty="0">
+              <a:rPr lang="en-US" sz="1500" b="1" dirty="0">
                 <a:solidFill>
                   <a:srgbClr val="3D5A80"/>
                 </a:solidFill>
@@ -16182,7 +16182,7 @@
               </a:rPr>
               <a:t>misaligned rows</a:t>
             </a:r>
-            <a:endParaRPr lang="en-US" sz="1600" dirty="0"/>
+            <a:endParaRPr lang="en-US" sz="1500" dirty="0"/>
           </a:p>
         </p:txBody>
       </p:sp>
@@ -16194,8 +16194,8 @@
         </p:nvSpPr>
         <p:spPr>
           <a:xfrm>
-            <a:off x="822960" y="3474720"/>
-            <a:ext cx="3063240" cy="1371600"/>
+            <a:off x="822960" y="2926080"/>
+            <a:ext cx="3063240" cy="822960"/>
           </a:xfrm>
           <a:prstGeom prst="rect">
             <a:avLst/>
@@ -16211,7 +16211,7 @@
               <a:buNone/>
             </a:pPr>
             <a:r>
-              <a:rPr lang="en-US" sz="1400" dirty="0">
+              <a:rPr lang="en-US" sz="1300" dirty="0">
                 <a:solidFill>
                   <a:srgbClr val="5B6576"/>
                 </a:solidFill>
@@ -16221,7 +16221,7 @@
               </a:rPr>
               <a:t>PSI recovered exactly the true match set in all 6 cohorts, plaintext and OpenFHE</a:t>
             </a:r>
-            <a:endParaRPr lang="en-US" sz="1400" dirty="0"/>
+            <a:endParaRPr lang="en-US" sz="1300" dirty="0"/>
           </a:p>
         </p:txBody>
       </p:sp>
@@ -16233,12 +16233,12 @@
         </p:nvSpPr>
         <p:spPr>
           <a:xfrm>
-            <a:off x="4343400" y="1737360"/>
-            <a:ext cx="3566160" cy="3291840"/>
+            <a:off x="4343400" y="1600200"/>
+            <a:ext cx="3566160" cy="2240280"/>
           </a:xfrm>
           <a:prstGeom prst="roundRect">
             <a:avLst>
-              <a:gd name="adj" fmla="val 2222"/>
+              <a:gd name="adj" fmla="val 3265"/>
             </a:avLst>
           </a:prstGeom>
           <a:solidFill>
@@ -16260,8 +16260,8 @@
         </p:nvSpPr>
         <p:spPr>
           <a:xfrm>
-            <a:off x="4617720" y="1965960"/>
-            <a:ext cx="3108960" cy="1005840"/>
+            <a:off x="4617720" y="1737360"/>
+            <a:ext cx="3108960" cy="777240"/>
           </a:xfrm>
           <a:prstGeom prst="rect">
             <a:avLst/>
@@ -16277,7 +16277,7 @@
               <a:buNone/>
             </a:pPr>
             <a:r>
-              <a:rPr lang="en-US" sz="4800" b="1" dirty="0">
+              <a:rPr lang="en-US" sz="3800" b="1" dirty="0">
                 <a:solidFill>
                   <a:srgbClr val="C45A0C"/>
                 </a:solidFill>
@@ -16287,7 +16287,7 @@
               </a:rPr>
               <a:t>≈10⁻¹⁰</a:t>
             </a:r>
-            <a:endParaRPr lang="en-US" sz="4800" dirty="0"/>
+            <a:endParaRPr lang="en-US" sz="3800" dirty="0"/>
           </a:p>
         </p:txBody>
       </p:sp>
@@ -16299,8 +16299,8 @@
         </p:nvSpPr>
         <p:spPr>
           <a:xfrm>
-            <a:off x="4617720" y="3017520"/>
-            <a:ext cx="3108960" cy="411480"/>
+            <a:off x="4617720" y="2542032"/>
+            <a:ext cx="3108960" cy="365760"/>
           </a:xfrm>
           <a:prstGeom prst="rect">
             <a:avLst/>
@@ -16316,7 +16316,7 @@
               <a:buNone/>
             </a:pPr>
             <a:r>
-              <a:rPr lang="en-US" sz="1600" b="1" dirty="0">
+              <a:rPr lang="en-US" sz="1500" b="1" dirty="0">
                 <a:solidFill>
                   <a:srgbClr val="3D5A80"/>
                 </a:solidFill>
@@ -16326,7 +16326,7 @@
               </a:rPr>
               <a:t>max |β − β_OLS|</a:t>
             </a:r>
-            <a:endParaRPr lang="en-US" sz="1600" dirty="0"/>
+            <a:endParaRPr lang="en-US" sz="1500" dirty="0"/>
           </a:p>
         </p:txBody>
       </p:sp>
@@ -16338,8 +16338,8 @@
         </p:nvSpPr>
         <p:spPr>
           <a:xfrm>
-            <a:off x="4617720" y="3474720"/>
-            <a:ext cx="3063240" cy="1371600"/>
+            <a:off x="4617720" y="2926080"/>
+            <a:ext cx="3063240" cy="822960"/>
           </a:xfrm>
           <a:prstGeom prst="rect">
             <a:avLst/>
@@ -16355,7 +16355,7 @@
               <a:buNone/>
             </a:pPr>
             <a:r>
-              <a:rPr lang="en-US" sz="1400" dirty="0">
+              <a:rPr lang="en-US" sz="1300" dirty="0">
                 <a:solidFill>
                   <a:srgbClr val="5B6576"/>
                 </a:solidFill>
@@ -16365,7 +16365,7 @@
               </a:rPr>
               <a:t>with the noise switched off: encryption adds no error</a:t>
             </a:r>
-            <a:endParaRPr lang="en-US" sz="1400" dirty="0"/>
+            <a:endParaRPr lang="en-US" sz="1300" dirty="0"/>
           </a:p>
         </p:txBody>
       </p:sp>
@@ -16377,12 +16377,12 @@
         </p:nvSpPr>
         <p:spPr>
           <a:xfrm>
-            <a:off x="8138160" y="1737360"/>
-            <a:ext cx="3566160" cy="3291840"/>
+            <a:off x="8138160" y="1600200"/>
+            <a:ext cx="3566160" cy="2240280"/>
           </a:xfrm>
           <a:prstGeom prst="roundRect">
             <a:avLst>
-              <a:gd name="adj" fmla="val 2222"/>
+              <a:gd name="adj" fmla="val 3265"/>
             </a:avLst>
           </a:prstGeom>
           <a:solidFill>
@@ -16404,8 +16404,8 @@
         </p:nvSpPr>
         <p:spPr>
           <a:xfrm>
-            <a:off x="8412480" y="1965960"/>
-            <a:ext cx="3108960" cy="1005840"/>
+            <a:off x="8412480" y="1737360"/>
+            <a:ext cx="3108960" cy="777240"/>
           </a:xfrm>
           <a:prstGeom prst="rect">
             <a:avLst/>
@@ -16421,7 +16421,7 @@
               <a:buNone/>
             </a:pPr>
             <a:r>
-              <a:rPr lang="en-US" sz="4800" b="1" dirty="0">
+              <a:rPr lang="en-US" sz="3800" b="1" dirty="0">
                 <a:solidFill>
                   <a:srgbClr val="14213D"/>
                 </a:solidFill>
@@ -16431,7 +16431,7 @@
               </a:rPr>
               <a:t>13.8 s</a:t>
             </a:r>
-            <a:endParaRPr lang="en-US" sz="4800" dirty="0"/>
+            <a:endParaRPr lang="en-US" sz="3800" dirty="0"/>
           </a:p>
         </p:txBody>
       </p:sp>
@@ -16443,8 +16443,8 @@
         </p:nvSpPr>
         <p:spPr>
           <a:xfrm>
-            <a:off x="8412480" y="3017520"/>
-            <a:ext cx="3108960" cy="411480"/>
+            <a:off x="8412480" y="2542032"/>
+            <a:ext cx="3108960" cy="365760"/>
           </a:xfrm>
           <a:prstGeom prst="rect">
             <a:avLst/>
@@ -16460,7 +16460,7 @@
               <a:buNone/>
             </a:pPr>
             <a:r>
-              <a:rPr lang="en-US" sz="1600" b="1" dirty="0">
+              <a:rPr lang="en-US" sz="1500" b="1" dirty="0">
                 <a:solidFill>
                   <a:srgbClr val="3D5A80"/>
                 </a:solidFill>
@@ -16470,7 +16470,7 @@
               </a:rPr>
               <a:t>end-to-end on OpenFHE</a:t>
             </a:r>
-            <a:endParaRPr lang="en-US" sz="1600" dirty="0"/>
+            <a:endParaRPr lang="en-US" sz="1500" dirty="0"/>
           </a:p>
         </p:txBody>
       </p:sp>
@@ -16482,8 +16482,8 @@
         </p:nvSpPr>
         <p:spPr>
           <a:xfrm>
-            <a:off x="8412480" y="3474720"/>
-            <a:ext cx="3063240" cy="1371600"/>
+            <a:off x="8412480" y="2926080"/>
+            <a:ext cx="3063240" cy="822960"/>
           </a:xfrm>
           <a:prstGeom prst="rect">
             <a:avLst/>
@@ -16499,7 +16499,7 @@
               <a:buNone/>
             </a:pPr>
             <a:r>
-              <a:rPr lang="en-US" sz="1400" dirty="0">
+              <a:rPr lang="en-US" sz="1300" dirty="0">
                 <a:solidFill>
                   <a:srgbClr val="5B6576"/>
                 </a:solidFill>
@@ -16509,7 +16509,7 @@
               </a:rPr>
               <a:t>n_O = 4,000 records, n = 400 matched (plaintext backend: 3.2 s)</a:t>
             </a:r>
-            <a:endParaRPr lang="en-US" sz="1400" dirty="0"/>
+            <a:endParaRPr lang="en-US" sz="1300" dirty="0"/>
           </a:p>
         </p:txBody>
       </p:sp>
@@ -16521,8 +16521,8 @@
         </p:nvSpPr>
         <p:spPr>
           <a:xfrm>
-            <a:off x="548640" y="5349240"/>
-            <a:ext cx="11064240" cy="731520"/>
+            <a:off x="548640" y="4114800"/>
+            <a:ext cx="7315200" cy="411480"/>
           </a:xfrm>
           <a:prstGeom prst="rect">
             <a:avLst/>
@@ -16538,20 +16538,2098 @@
               <a:buNone/>
             </a:pPr>
             <a:r>
-              <a:rPr lang="en-US" sz="1450" i="1" dirty="0">
+              <a:rPr lang="en-US" sz="1800" b="1" dirty="0">
                 <a:solidFill>
-                  <a:srgbClr val="5B6576"/>
+                  <a:srgbClr val="14213D"/>
+                </a:solidFill>
+                <a:latin typeface="Cambria" pitchFamily="34" charset="0"/>
+                <a:ea typeface="Cambria" pitchFamily="34" charset="-122"/>
+                <a:cs typeface="Cambria" pitchFamily="34" charset="-120"/>
+              </a:rPr>
+              <a:t>Cost of the revised protocol in OpenFHE</a:t>
+            </a:r>
+            <a:endParaRPr lang="en-US" sz="1800" dirty="0"/>
+          </a:p>
+        </p:txBody>
+      </p:sp>
+      <p:sp>
+        <p:nvSpPr>
+          <p:cNvPr id="17" name="Shape 15"/>
+          <p:cNvSpPr/>
+          <p:nvPr/>
+        </p:nvSpPr>
+        <p:spPr>
+          <a:xfrm>
+            <a:off x="10058400" y="4160520"/>
+            <a:ext cx="1554480" cy="292608"/>
+          </a:xfrm>
+          <a:prstGeom prst="roundRect">
+            <a:avLst>
+              <a:gd name="adj" fmla="val 25000"/>
+            </a:avLst>
+          </a:prstGeom>
+          <a:solidFill>
+            <a:srgbClr val="3D5A80"/>
+          </a:solidFill>
+          <a:ln w="12700">
+            <a:solidFill>
+              <a:srgbClr val="3D5A80"/>
+            </a:solidFill>
+            <a:prstDash val="solid"/>
+          </a:ln>
+        </p:spPr>
+      </p:sp>
+      <p:sp>
+        <p:nvSpPr>
+          <p:cNvPr id="18" name="Text 16"/>
+          <p:cNvSpPr txBox="1"/>
+          <p:nvPr/>
+        </p:nvSpPr>
+        <p:spPr>
+          <a:xfrm>
+            <a:off x="10058400" y="4160520"/>
+            <a:ext cx="1554480" cy="292608"/>
+          </a:xfrm>
+          <a:prstGeom prst="rect">
+            <a:avLst/>
+          </a:prstGeom>
+          <a:noFill/>
+          <a:ln/>
+        </p:spPr>
+        <p:txBody>
+          <a:bodyPr wrap="square" lIns="0" tIns="0" rIns="0" bIns="0" rtlCol="0" anchor="ctr"/>
+          <a:lstStyle/>
+          <a:p>
+            <a:pPr algn="ctr" indent="0" marL="0">
+              <a:buNone/>
+            </a:pPr>
+            <a:r>
+              <a:rPr lang="en-US" sz="1100" b="1" dirty="0">
+                <a:solidFill>
+                  <a:srgbClr val="FFFFFF"/>
                 </a:solidFill>
                 <a:latin typeface="Calibri" pitchFamily="34" charset="0"/>
                 <a:ea typeface="Calibri" pitchFamily="34" charset="-122"/>
                 <a:cs typeface="Calibri" pitchFamily="34" charset="-120"/>
               </a:rPr>
-              <a:t>All error comes from the DP noise and the ridge it forces. The revised protocol's sanitization has not been implemented in OpenFHE yet (see the placeholder slide).</a:t>
+              <a:t>To be run</a:t>
             </a:r>
-            <a:endParaRPr lang="en-US" sz="1450" dirty="0"/>
+            <a:endParaRPr lang="en-US" sz="1100" dirty="0"/>
           </a:p>
         </p:txBody>
       </p:sp>
+      <p:graphicFrame>
+        <p:nvGraphicFramePr>
+          <p:cNvPr id="22" name="Table 0"/>
+          <p:cNvGraphicFramePr>
+            <a:graphicFrameLocks noGrp="1"/>
+          </p:cNvGraphicFramePr>
+          <p:nvPr>
+            <p:extLst>
+              <p:ext uri="{D42A27DB-BD31-4B8C-83A1-F6EECF244321}">
+                <p14:modId xmlns:p14="http://schemas.microsoft.com/office/powerpoint/2010/main" val="1579011935"/>
+              </p:ext>
+            </p:extLst>
+          </p:nvPr>
+        </p:nvGraphicFramePr>
+        <p:xfrm>
+          <a:off x="548640" y="4617720"/>
+          <a:ext cx="9144000" cy="914400"/>
+        </p:xfrm>
+        <a:graphic>
+          <a:graphicData uri="http://schemas.openxmlformats.org/drawingml/2006/table">
+            <a:tbl>
+              <a:tblPr/>
+              <a:tblGrid>
+                <a:gridCol w="2103120"/>
+                <a:gridCol w="731520"/>
+                <a:gridCol w="1737360"/>
+                <a:gridCol w="2194560"/>
+                <a:gridCol w="1828800"/>
+                <a:gridCol w="2468880"/>
+              </a:tblGrid>
+              <a:tr h="310896">
+                <a:tc>
+                  <a:txBody>
+                    <a:bodyPr/>
+                    <a:lstStyle/>
+                    <a:p>
+                      <a:pPr indent="0" marL="0">
+                        <a:buNone/>
+                      </a:pPr>
+                      <a:r>
+                        <a:rPr lang="en-US" sz="1250" b="1" dirty="0">
+                          <a:solidFill>
+                            <a:srgbClr val="FFFFFF"/>
+                          </a:solidFill>
+                          <a:latin typeface="Calibri" pitchFamily="34" charset="0"/>
+                          <a:ea typeface="Calibri" pitchFamily="34" charset="-122"/>
+                          <a:cs typeface="Calibri" pitchFamily="34" charset="-120"/>
+                        </a:rPr>
+                        <a:t>Register size n_O</a:t>
+                      </a:r>
+                      <a:endParaRPr lang="en-US" sz="1250" dirty="0">
+                        <a:latin typeface="Calibri" charset="0"/>
+                        <a:ea typeface="Calibri" charset="0"/>
+                        <a:cs typeface="Calibri" charset="0"/>
+                      </a:endParaRPr>
+                    </a:p>
+                  </a:txBody>
+                  <a:tcPr marL="76200" marR="76200" marT="38100" marB="38100" anchor="ctr">
+                    <a:lnL w="9525" cap="flat" cmpd="sng" algn="ctr">
+                      <a:solidFill>
+                        <a:srgbClr val="C9D3E0"/>
+                      </a:solidFill>
+                      <a:prstDash val="solid"/>
+                      <a:round/>
+                      <a:headEnd type="none" w="med" len="med"/>
+                      <a:tailEnd type="none" w="med" len="med"/>
+                    </a:lnL>
+                    <a:lnR w="9525" cap="flat" cmpd="sng" algn="ctr">
+                      <a:solidFill>
+                        <a:srgbClr val="C9D3E0"/>
+                      </a:solidFill>
+                      <a:prstDash val="solid"/>
+                      <a:round/>
+                      <a:headEnd type="none" w="med" len="med"/>
+                      <a:tailEnd type="none" w="med" len="med"/>
+                    </a:lnR>
+                    <a:lnT w="9525" cap="flat" cmpd="sng" algn="ctr">
+                      <a:solidFill>
+                        <a:srgbClr val="C9D3E0"/>
+                      </a:solidFill>
+                      <a:prstDash val="solid"/>
+                      <a:round/>
+                      <a:headEnd type="none" w="med" len="med"/>
+                      <a:tailEnd type="none" w="med" len="med"/>
+                    </a:lnT>
+                    <a:lnB w="9525" cap="flat" cmpd="sng" algn="ctr">
+                      <a:solidFill>
+                        <a:srgbClr val="C9D3E0"/>
+                      </a:solidFill>
+                      <a:prstDash val="solid"/>
+                      <a:round/>
+                      <a:headEnd type="none" w="med" len="med"/>
+                      <a:tailEnd type="none" w="med" len="med"/>
+                    </a:lnB>
+                    <a:solidFill>
+                      <a:srgbClr val="14213D"/>
+                    </a:solidFill>
+                  </a:tcPr>
+                </a:tc>
+                <a:tc>
+                  <a:txBody>
+                    <a:bodyPr/>
+                    <a:lstStyle/>
+                    <a:p>
+                      <a:pPr indent="0" marL="0">
+                        <a:buNone/>
+                      </a:pPr>
+                      <a:r>
+                        <a:rPr lang="en-US" sz="1250" b="1" dirty="0">
+                          <a:solidFill>
+                            <a:srgbClr val="FFFFFF"/>
+                          </a:solidFill>
+                          <a:latin typeface="Calibri" pitchFamily="34" charset="0"/>
+                          <a:ea typeface="Calibri" pitchFamily="34" charset="-122"/>
+                          <a:cs typeface="Calibri" pitchFamily="34" charset="-120"/>
+                        </a:rPr>
+                        <a:t>d</a:t>
+                      </a:r>
+                      <a:endParaRPr lang="en-US" sz="1250" dirty="0">
+                        <a:latin typeface="Calibri" charset="0"/>
+                        <a:ea typeface="Calibri" charset="0"/>
+                        <a:cs typeface="Calibri" charset="0"/>
+                      </a:endParaRPr>
+                    </a:p>
+                  </a:txBody>
+                  <a:tcPr marL="76200" marR="76200" marT="38100" marB="38100" anchor="ctr">
+                    <a:lnL w="9525" cap="flat" cmpd="sng" algn="ctr">
+                      <a:solidFill>
+                        <a:srgbClr val="C9D3E0"/>
+                      </a:solidFill>
+                      <a:prstDash val="solid"/>
+                      <a:round/>
+                      <a:headEnd type="none" w="med" len="med"/>
+                      <a:tailEnd type="none" w="med" len="med"/>
+                    </a:lnL>
+                    <a:lnR w="9525" cap="flat" cmpd="sng" algn="ctr">
+                      <a:solidFill>
+                        <a:srgbClr val="C9D3E0"/>
+                      </a:solidFill>
+                      <a:prstDash val="solid"/>
+                      <a:round/>
+                      <a:headEnd type="none" w="med" len="med"/>
+                      <a:tailEnd type="none" w="med" len="med"/>
+                    </a:lnR>
+                    <a:lnT w="9525" cap="flat" cmpd="sng" algn="ctr">
+                      <a:solidFill>
+                        <a:srgbClr val="C9D3E0"/>
+                      </a:solidFill>
+                      <a:prstDash val="solid"/>
+                      <a:round/>
+                      <a:headEnd type="none" w="med" len="med"/>
+                      <a:tailEnd type="none" w="med" len="med"/>
+                    </a:lnT>
+                    <a:lnB w="9525" cap="flat" cmpd="sng" algn="ctr">
+                      <a:solidFill>
+                        <a:srgbClr val="C9D3E0"/>
+                      </a:solidFill>
+                      <a:prstDash val="solid"/>
+                      <a:round/>
+                      <a:headEnd type="none" w="med" len="med"/>
+                      <a:tailEnd type="none" w="med" len="med"/>
+                    </a:lnB>
+                    <a:solidFill>
+                      <a:srgbClr val="14213D"/>
+                    </a:solidFill>
+                  </a:tcPr>
+                </a:tc>
+                <a:tc>
+                  <a:txBody>
+                    <a:bodyPr/>
+                    <a:lstStyle/>
+                    <a:p>
+                      <a:pPr indent="0" marL="0">
+                        <a:buNone/>
+                      </a:pPr>
+                      <a:r>
+                        <a:rPr lang="en-US" sz="1250" b="1" dirty="0">
+                          <a:solidFill>
+                            <a:srgbClr val="FFFFFF"/>
+                          </a:solidFill>
+                          <a:latin typeface="Calibri" pitchFamily="34" charset="0"/>
+                          <a:ea typeface="Calibri" pitchFamily="34" charset="-122"/>
+                          <a:cs typeface="Calibri" pitchFamily="34" charset="-120"/>
+                        </a:rPr>
+                        <a:t>PSI time (s)</a:t>
+                      </a:r>
+                      <a:endParaRPr lang="en-US" sz="1250" dirty="0">
+                        <a:latin typeface="Calibri" charset="0"/>
+                        <a:ea typeface="Calibri" charset="0"/>
+                        <a:cs typeface="Calibri" charset="0"/>
+                      </a:endParaRPr>
+                    </a:p>
+                  </a:txBody>
+                  <a:tcPr marL="76200" marR="76200" marT="38100" marB="38100" anchor="ctr">
+                    <a:lnL w="9525" cap="flat" cmpd="sng" algn="ctr">
+                      <a:solidFill>
+                        <a:srgbClr val="C9D3E0"/>
+                      </a:solidFill>
+                      <a:prstDash val="solid"/>
+                      <a:round/>
+                      <a:headEnd type="none" w="med" len="med"/>
+                      <a:tailEnd type="none" w="med" len="med"/>
+                    </a:lnL>
+                    <a:lnR w="9525" cap="flat" cmpd="sng" algn="ctr">
+                      <a:solidFill>
+                        <a:srgbClr val="C9D3E0"/>
+                      </a:solidFill>
+                      <a:prstDash val="solid"/>
+                      <a:round/>
+                      <a:headEnd type="none" w="med" len="med"/>
+                      <a:tailEnd type="none" w="med" len="med"/>
+                    </a:lnR>
+                    <a:lnT w="9525" cap="flat" cmpd="sng" algn="ctr">
+                      <a:solidFill>
+                        <a:srgbClr val="C9D3E0"/>
+                      </a:solidFill>
+                      <a:prstDash val="solid"/>
+                      <a:round/>
+                      <a:headEnd type="none" w="med" len="med"/>
+                      <a:tailEnd type="none" w="med" len="med"/>
+                    </a:lnT>
+                    <a:lnB w="9525" cap="flat" cmpd="sng" algn="ctr">
+                      <a:solidFill>
+                        <a:srgbClr val="C9D3E0"/>
+                      </a:solidFill>
+                      <a:prstDash val="solid"/>
+                      <a:round/>
+                      <a:headEnd type="none" w="med" len="med"/>
+                      <a:tailEnd type="none" w="med" len="med"/>
+                    </a:lnB>
+                    <a:solidFill>
+                      <a:srgbClr val="14213D"/>
+                    </a:solidFill>
+                  </a:tcPr>
+                </a:tc>
+                <a:tc>
+                  <a:txBody>
+                    <a:bodyPr/>
+                    <a:lstStyle/>
+                    <a:p>
+                      <a:pPr indent="0" marL="0">
+                        <a:buNone/>
+                      </a:pPr>
+                      <a:r>
+                        <a:rPr lang="en-US" sz="1250" b="1" dirty="0">
+                          <a:solidFill>
+                            <a:srgbClr val="FFFFFF"/>
+                          </a:solidFill>
+                          <a:latin typeface="Calibri" pitchFamily="34" charset="0"/>
+                          <a:ea typeface="Calibri" pitchFamily="34" charset="-122"/>
+                          <a:cs typeface="Calibri" pitchFamily="34" charset="-120"/>
+                        </a:rPr>
+                        <a:t>Aggregation time (s)</a:t>
+                      </a:r>
+                      <a:endParaRPr lang="en-US" sz="1250" dirty="0">
+                        <a:latin typeface="Calibri" charset="0"/>
+                        <a:ea typeface="Calibri" charset="0"/>
+                        <a:cs typeface="Calibri" charset="0"/>
+                      </a:endParaRPr>
+                    </a:p>
+                  </a:txBody>
+                  <a:tcPr marL="76200" marR="76200" marT="38100" marB="38100" anchor="ctr">
+                    <a:lnL w="9525" cap="flat" cmpd="sng" algn="ctr">
+                      <a:solidFill>
+                        <a:srgbClr val="C9D3E0"/>
+                      </a:solidFill>
+                      <a:prstDash val="solid"/>
+                      <a:round/>
+                      <a:headEnd type="none" w="med" len="med"/>
+                      <a:tailEnd type="none" w="med" len="med"/>
+                    </a:lnL>
+                    <a:lnR w="9525" cap="flat" cmpd="sng" algn="ctr">
+                      <a:solidFill>
+                        <a:srgbClr val="C9D3E0"/>
+                      </a:solidFill>
+                      <a:prstDash val="solid"/>
+                      <a:round/>
+                      <a:headEnd type="none" w="med" len="med"/>
+                      <a:tailEnd type="none" w="med" len="med"/>
+                    </a:lnR>
+                    <a:lnT w="9525" cap="flat" cmpd="sng" algn="ctr">
+                      <a:solidFill>
+                        <a:srgbClr val="C9D3E0"/>
+                      </a:solidFill>
+                      <a:prstDash val="solid"/>
+                      <a:round/>
+                      <a:headEnd type="none" w="med" len="med"/>
+                      <a:tailEnd type="none" w="med" len="med"/>
+                    </a:lnT>
+                    <a:lnB w="9525" cap="flat" cmpd="sng" algn="ctr">
+                      <a:solidFill>
+                        <a:srgbClr val="C9D3E0"/>
+                      </a:solidFill>
+                      <a:prstDash val="solid"/>
+                      <a:round/>
+                      <a:headEnd type="none" w="med" len="med"/>
+                      <a:tailEnd type="none" w="med" len="med"/>
+                    </a:lnB>
+                    <a:solidFill>
+                      <a:srgbClr val="14213D"/>
+                    </a:solidFill>
+                  </a:tcPr>
+                </a:tc>
+                <a:tc>
+                  <a:txBody>
+                    <a:bodyPr/>
+                    <a:lstStyle/>
+                    <a:p>
+                      <a:pPr indent="0" marL="0">
+                        <a:buNone/>
+                      </a:pPr>
+                      <a:r>
+                        <a:rPr lang="en-US" sz="1250" b="1" dirty="0">
+                          <a:solidFill>
+                            <a:srgbClr val="FFFFFF"/>
+                          </a:solidFill>
+                          <a:latin typeface="Calibri" pitchFamily="34" charset="0"/>
+                          <a:ea typeface="Calibri" pitchFamily="34" charset="-122"/>
+                          <a:cs typeface="Calibri" pitchFamily="34" charset="-120"/>
+                        </a:rPr>
+                        <a:t>Traffic (MB)</a:t>
+                      </a:r>
+                      <a:endParaRPr lang="en-US" sz="1250" dirty="0">
+                        <a:latin typeface="Calibri" charset="0"/>
+                        <a:ea typeface="Calibri" charset="0"/>
+                        <a:cs typeface="Calibri" charset="0"/>
+                      </a:endParaRPr>
+                    </a:p>
+                  </a:txBody>
+                  <a:tcPr marL="76200" marR="76200" marT="38100" marB="38100" anchor="ctr">
+                    <a:lnL w="9525" cap="flat" cmpd="sng" algn="ctr">
+                      <a:solidFill>
+                        <a:srgbClr val="C9D3E0"/>
+                      </a:solidFill>
+                      <a:prstDash val="solid"/>
+                      <a:round/>
+                      <a:headEnd type="none" w="med" len="med"/>
+                      <a:tailEnd type="none" w="med" len="med"/>
+                    </a:lnL>
+                    <a:lnR w="9525" cap="flat" cmpd="sng" algn="ctr">
+                      <a:solidFill>
+                        <a:srgbClr val="C9D3E0"/>
+                      </a:solidFill>
+                      <a:prstDash val="solid"/>
+                      <a:round/>
+                      <a:headEnd type="none" w="med" len="med"/>
+                      <a:tailEnd type="none" w="med" len="med"/>
+                    </a:lnR>
+                    <a:lnT w="9525" cap="flat" cmpd="sng" algn="ctr">
+                      <a:solidFill>
+                        <a:srgbClr val="C9D3E0"/>
+                      </a:solidFill>
+                      <a:prstDash val="solid"/>
+                      <a:round/>
+                      <a:headEnd type="none" w="med" len="med"/>
+                      <a:tailEnd type="none" w="med" len="med"/>
+                    </a:lnT>
+                    <a:lnB w="9525" cap="flat" cmpd="sng" algn="ctr">
+                      <a:solidFill>
+                        <a:srgbClr val="C9D3E0"/>
+                      </a:solidFill>
+                      <a:prstDash val="solid"/>
+                      <a:round/>
+                      <a:headEnd type="none" w="med" len="med"/>
+                      <a:tailEnd type="none" w="med" len="med"/>
+                    </a:lnB>
+                    <a:solidFill>
+                      <a:srgbClr val="14213D"/>
+                    </a:solidFill>
+                  </a:tcPr>
+                </a:tc>
+                <a:tc>
+                  <a:txBody>
+                    <a:bodyPr/>
+                    <a:lstStyle/>
+                    <a:p>
+                      <a:pPr indent="0" marL="0">
+                        <a:buNone/>
+                      </a:pPr>
+                      <a:r>
+                        <a:rPr lang="en-US" sz="1250" b="1" dirty="0">
+                          <a:solidFill>
+                            <a:srgbClr val="FFFFFF"/>
+                          </a:solidFill>
+                          <a:latin typeface="Calibri" pitchFamily="34" charset="0"/>
+                          <a:ea typeface="Calibri" pitchFamily="34" charset="-122"/>
+                          <a:cs typeface="Calibri" pitchFamily="34" charset="-120"/>
+                        </a:rPr>
+                        <a:t>Sanitization overhead</a:t>
+                      </a:r>
+                      <a:endParaRPr lang="en-US" sz="1250" dirty="0">
+                        <a:latin typeface="Calibri" charset="0"/>
+                        <a:ea typeface="Calibri" charset="0"/>
+                        <a:cs typeface="Calibri" charset="0"/>
+                      </a:endParaRPr>
+                    </a:p>
+                  </a:txBody>
+                  <a:tcPr marL="76200" marR="76200" marT="38100" marB="38100" anchor="ctr">
+                    <a:lnL w="9525" cap="flat" cmpd="sng" algn="ctr">
+                      <a:solidFill>
+                        <a:srgbClr val="C9D3E0"/>
+                      </a:solidFill>
+                      <a:prstDash val="solid"/>
+                      <a:round/>
+                      <a:headEnd type="none" w="med" len="med"/>
+                      <a:tailEnd type="none" w="med" len="med"/>
+                    </a:lnL>
+                    <a:lnR w="9525" cap="flat" cmpd="sng" algn="ctr">
+                      <a:solidFill>
+                        <a:srgbClr val="C9D3E0"/>
+                      </a:solidFill>
+                      <a:prstDash val="solid"/>
+                      <a:round/>
+                      <a:headEnd type="none" w="med" len="med"/>
+                      <a:tailEnd type="none" w="med" len="med"/>
+                    </a:lnR>
+                    <a:lnT w="9525" cap="flat" cmpd="sng" algn="ctr">
+                      <a:solidFill>
+                        <a:srgbClr val="C9D3E0"/>
+                      </a:solidFill>
+                      <a:prstDash val="solid"/>
+                      <a:round/>
+                      <a:headEnd type="none" w="med" len="med"/>
+                      <a:tailEnd type="none" w="med" len="med"/>
+                    </a:lnT>
+                    <a:lnB w="9525" cap="flat" cmpd="sng" algn="ctr">
+                      <a:solidFill>
+                        <a:srgbClr val="C9D3E0"/>
+                      </a:solidFill>
+                      <a:prstDash val="solid"/>
+                      <a:round/>
+                      <a:headEnd type="none" w="med" len="med"/>
+                      <a:tailEnd type="none" w="med" len="med"/>
+                    </a:lnB>
+                    <a:solidFill>
+                      <a:srgbClr val="14213D"/>
+                    </a:solidFill>
+                  </a:tcPr>
+                </a:tc>
+              </a:tr>
+              <a:tr h="310896">
+                <a:tc>
+                  <a:txBody>
+                    <a:bodyPr/>
+                    <a:lstStyle/>
+                    <a:p>
+                      <a:pPr indent="0" marL="0">
+                        <a:buNone/>
+                      </a:pPr>
+                      <a:r>
+                        <a:rPr lang="en-US" sz="1250" dirty="0">
+                          <a:solidFill>
+                            <a:srgbClr val="1F2937"/>
+                          </a:solidFill>
+                          <a:latin typeface="Calibri" pitchFamily="34" charset="0"/>
+                          <a:ea typeface="Calibri" pitchFamily="34" charset="-122"/>
+                          <a:cs typeface="Calibri" pitchFamily="34" charset="-120"/>
+                        </a:rPr>
+                        <a:t>4,000</a:t>
+                      </a:r>
+                      <a:endParaRPr lang="en-US" sz="1250" dirty="0">
+                        <a:latin typeface="Calibri" charset="0"/>
+                        <a:ea typeface="Calibri" charset="0"/>
+                        <a:cs typeface="Calibri" charset="0"/>
+                      </a:endParaRPr>
+                    </a:p>
+                  </a:txBody>
+                  <a:tcPr marL="76200" marR="76200" marT="38100" marB="38100" anchor="ctr">
+                    <a:lnL w="9525" cap="flat" cmpd="sng" algn="ctr">
+                      <a:solidFill>
+                        <a:srgbClr val="C9D3E0"/>
+                      </a:solidFill>
+                      <a:prstDash val="solid"/>
+                      <a:round/>
+                      <a:headEnd type="none" w="med" len="med"/>
+                      <a:tailEnd type="none" w="med" len="med"/>
+                    </a:lnL>
+                    <a:lnR w="9525" cap="flat" cmpd="sng" algn="ctr">
+                      <a:solidFill>
+                        <a:srgbClr val="C9D3E0"/>
+                      </a:solidFill>
+                      <a:prstDash val="solid"/>
+                      <a:round/>
+                      <a:headEnd type="none" w="med" len="med"/>
+                      <a:tailEnd type="none" w="med" len="med"/>
+                    </a:lnR>
+                    <a:lnT w="9525" cap="flat" cmpd="sng" algn="ctr">
+                      <a:solidFill>
+                        <a:srgbClr val="C9D3E0"/>
+                      </a:solidFill>
+                      <a:prstDash val="solid"/>
+                      <a:round/>
+                      <a:headEnd type="none" w="med" len="med"/>
+                      <a:tailEnd type="none" w="med" len="med"/>
+                    </a:lnT>
+                    <a:lnB w="9525" cap="flat" cmpd="sng" algn="ctr">
+                      <a:solidFill>
+                        <a:srgbClr val="C9D3E0"/>
+                      </a:solidFill>
+                      <a:prstDash val="solid"/>
+                      <a:round/>
+                      <a:headEnd type="none" w="med" len="med"/>
+                      <a:tailEnd type="none" w="med" len="med"/>
+                    </a:lnB>
+                  </a:tcPr>
+                </a:tc>
+                <a:tc>
+                  <a:txBody>
+                    <a:bodyPr/>
+                    <a:lstStyle/>
+                    <a:p>
+                      <a:pPr indent="0" marL="0">
+                        <a:buNone/>
+                      </a:pPr>
+                      <a:r>
+                        <a:rPr lang="en-US" sz="1250" dirty="0">
+                          <a:solidFill>
+                            <a:srgbClr val="1F2937"/>
+                          </a:solidFill>
+                          <a:latin typeface="Calibri" pitchFamily="34" charset="0"/>
+                          <a:ea typeface="Calibri" pitchFamily="34" charset="-122"/>
+                          <a:cs typeface="Calibri" pitchFamily="34" charset="-120"/>
+                        </a:rPr>
+                        <a:t>10</a:t>
+                      </a:r>
+                      <a:endParaRPr lang="en-US" sz="1250" dirty="0">
+                        <a:latin typeface="Calibri" charset="0"/>
+                        <a:ea typeface="Calibri" charset="0"/>
+                        <a:cs typeface="Calibri" charset="0"/>
+                      </a:endParaRPr>
+                    </a:p>
+                  </a:txBody>
+                  <a:tcPr marL="76200" marR="76200" marT="38100" marB="38100" anchor="ctr">
+                    <a:lnL w="9525" cap="flat" cmpd="sng" algn="ctr">
+                      <a:solidFill>
+                        <a:srgbClr val="C9D3E0"/>
+                      </a:solidFill>
+                      <a:prstDash val="solid"/>
+                      <a:round/>
+                      <a:headEnd type="none" w="med" len="med"/>
+                      <a:tailEnd type="none" w="med" len="med"/>
+                    </a:lnL>
+                    <a:lnR w="9525" cap="flat" cmpd="sng" algn="ctr">
+                      <a:solidFill>
+                        <a:srgbClr val="C9D3E0"/>
+                      </a:solidFill>
+                      <a:prstDash val="solid"/>
+                      <a:round/>
+                      <a:headEnd type="none" w="med" len="med"/>
+                      <a:tailEnd type="none" w="med" len="med"/>
+                    </a:lnR>
+                    <a:lnT w="9525" cap="flat" cmpd="sng" algn="ctr">
+                      <a:solidFill>
+                        <a:srgbClr val="C9D3E0"/>
+                      </a:solidFill>
+                      <a:prstDash val="solid"/>
+                      <a:round/>
+                      <a:headEnd type="none" w="med" len="med"/>
+                      <a:tailEnd type="none" w="med" len="med"/>
+                    </a:lnT>
+                    <a:lnB w="9525" cap="flat" cmpd="sng" algn="ctr">
+                      <a:solidFill>
+                        <a:srgbClr val="C9D3E0"/>
+                      </a:solidFill>
+                      <a:prstDash val="solid"/>
+                      <a:round/>
+                      <a:headEnd type="none" w="med" len="med"/>
+                      <a:tailEnd type="none" w="med" len="med"/>
+                    </a:lnB>
+                  </a:tcPr>
+                </a:tc>
+                <a:tc>
+                  <a:txBody>
+                    <a:bodyPr/>
+                    <a:lstStyle/>
+                    <a:p>
+                      <a:pPr indent="0" marL="0">
+                        <a:buNone/>
+                      </a:pPr>
+                      <a:r>
+                        <a:rPr lang="en-US" sz="1250" i="1" dirty="0">
+                          <a:solidFill>
+                            <a:srgbClr val="9AA5B4"/>
+                          </a:solidFill>
+                          <a:latin typeface="Calibri" pitchFamily="34" charset="0"/>
+                          <a:ea typeface="Calibri" pitchFamily="34" charset="-122"/>
+                          <a:cs typeface="Calibri" pitchFamily="34" charset="-120"/>
+                        </a:rPr>
+                        <a:t>tbd</a:t>
+                      </a:r>
+                      <a:endParaRPr lang="en-US" sz="1250" dirty="0">
+                        <a:latin typeface="Calibri" charset="0"/>
+                        <a:ea typeface="Calibri" charset="0"/>
+                        <a:cs typeface="Calibri" charset="0"/>
+                      </a:endParaRPr>
+                    </a:p>
+                  </a:txBody>
+                  <a:tcPr marL="76200" marR="76200" marT="38100" marB="38100" anchor="ctr">
+                    <a:lnL w="9525" cap="flat" cmpd="sng" algn="ctr">
+                      <a:solidFill>
+                        <a:srgbClr val="C9D3E0"/>
+                      </a:solidFill>
+                      <a:prstDash val="solid"/>
+                      <a:round/>
+                      <a:headEnd type="none" w="med" len="med"/>
+                      <a:tailEnd type="none" w="med" len="med"/>
+                    </a:lnL>
+                    <a:lnR w="9525" cap="flat" cmpd="sng" algn="ctr">
+                      <a:solidFill>
+                        <a:srgbClr val="C9D3E0"/>
+                      </a:solidFill>
+                      <a:prstDash val="solid"/>
+                      <a:round/>
+                      <a:headEnd type="none" w="med" len="med"/>
+                      <a:tailEnd type="none" w="med" len="med"/>
+                    </a:lnR>
+                    <a:lnT w="9525" cap="flat" cmpd="sng" algn="ctr">
+                      <a:solidFill>
+                        <a:srgbClr val="C9D3E0"/>
+                      </a:solidFill>
+                      <a:prstDash val="solid"/>
+                      <a:round/>
+                      <a:headEnd type="none" w="med" len="med"/>
+                      <a:tailEnd type="none" w="med" len="med"/>
+                    </a:lnT>
+                    <a:lnB w="9525" cap="flat" cmpd="sng" algn="ctr">
+                      <a:solidFill>
+                        <a:srgbClr val="C9D3E0"/>
+                      </a:solidFill>
+                      <a:prstDash val="solid"/>
+                      <a:round/>
+                      <a:headEnd type="none" w="med" len="med"/>
+                      <a:tailEnd type="none" w="med" len="med"/>
+                    </a:lnB>
+                  </a:tcPr>
+                </a:tc>
+                <a:tc>
+                  <a:txBody>
+                    <a:bodyPr/>
+                    <a:lstStyle/>
+                    <a:p>
+                      <a:pPr indent="0" marL="0">
+                        <a:buNone/>
+                      </a:pPr>
+                      <a:r>
+                        <a:rPr lang="en-US" sz="1250" i="1" dirty="0">
+                          <a:solidFill>
+                            <a:srgbClr val="9AA5B4"/>
+                          </a:solidFill>
+                          <a:latin typeface="Calibri" pitchFamily="34" charset="0"/>
+                          <a:ea typeface="Calibri" pitchFamily="34" charset="-122"/>
+                          <a:cs typeface="Calibri" pitchFamily="34" charset="-120"/>
+                        </a:rPr>
+                        <a:t>tbd</a:t>
+                      </a:r>
+                      <a:endParaRPr lang="en-US" sz="1250" dirty="0">
+                        <a:latin typeface="Calibri" charset="0"/>
+                        <a:ea typeface="Calibri" charset="0"/>
+                        <a:cs typeface="Calibri" charset="0"/>
+                      </a:endParaRPr>
+                    </a:p>
+                  </a:txBody>
+                  <a:tcPr marL="76200" marR="76200" marT="38100" marB="38100" anchor="ctr">
+                    <a:lnL w="9525" cap="flat" cmpd="sng" algn="ctr">
+                      <a:solidFill>
+                        <a:srgbClr val="C9D3E0"/>
+                      </a:solidFill>
+                      <a:prstDash val="solid"/>
+                      <a:round/>
+                      <a:headEnd type="none" w="med" len="med"/>
+                      <a:tailEnd type="none" w="med" len="med"/>
+                    </a:lnL>
+                    <a:lnR w="9525" cap="flat" cmpd="sng" algn="ctr">
+                      <a:solidFill>
+                        <a:srgbClr val="C9D3E0"/>
+                      </a:solidFill>
+                      <a:prstDash val="solid"/>
+                      <a:round/>
+                      <a:headEnd type="none" w="med" len="med"/>
+                      <a:tailEnd type="none" w="med" len="med"/>
+                    </a:lnR>
+                    <a:lnT w="9525" cap="flat" cmpd="sng" algn="ctr">
+                      <a:solidFill>
+                        <a:srgbClr val="C9D3E0"/>
+                      </a:solidFill>
+                      <a:prstDash val="solid"/>
+                      <a:round/>
+                      <a:headEnd type="none" w="med" len="med"/>
+                      <a:tailEnd type="none" w="med" len="med"/>
+                    </a:lnT>
+                    <a:lnB w="9525" cap="flat" cmpd="sng" algn="ctr">
+                      <a:solidFill>
+                        <a:srgbClr val="C9D3E0"/>
+                      </a:solidFill>
+                      <a:prstDash val="solid"/>
+                      <a:round/>
+                      <a:headEnd type="none" w="med" len="med"/>
+                      <a:tailEnd type="none" w="med" len="med"/>
+                    </a:lnB>
+                  </a:tcPr>
+                </a:tc>
+                <a:tc>
+                  <a:txBody>
+                    <a:bodyPr/>
+                    <a:lstStyle/>
+                    <a:p>
+                      <a:pPr indent="0" marL="0">
+                        <a:buNone/>
+                      </a:pPr>
+                      <a:r>
+                        <a:rPr lang="en-US" sz="1250" i="1" dirty="0">
+                          <a:solidFill>
+                            <a:srgbClr val="9AA5B4"/>
+                          </a:solidFill>
+                          <a:latin typeface="Calibri" pitchFamily="34" charset="0"/>
+                          <a:ea typeface="Calibri" pitchFamily="34" charset="-122"/>
+                          <a:cs typeface="Calibri" pitchFamily="34" charset="-120"/>
+                        </a:rPr>
+                        <a:t>tbd</a:t>
+                      </a:r>
+                      <a:endParaRPr lang="en-US" sz="1250" dirty="0">
+                        <a:latin typeface="Calibri" charset="0"/>
+                        <a:ea typeface="Calibri" charset="0"/>
+                        <a:cs typeface="Calibri" charset="0"/>
+                      </a:endParaRPr>
+                    </a:p>
+                  </a:txBody>
+                  <a:tcPr marL="76200" marR="76200" marT="38100" marB="38100" anchor="ctr">
+                    <a:lnL w="9525" cap="flat" cmpd="sng" algn="ctr">
+                      <a:solidFill>
+                        <a:srgbClr val="C9D3E0"/>
+                      </a:solidFill>
+                      <a:prstDash val="solid"/>
+                      <a:round/>
+                      <a:headEnd type="none" w="med" len="med"/>
+                      <a:tailEnd type="none" w="med" len="med"/>
+                    </a:lnL>
+                    <a:lnR w="9525" cap="flat" cmpd="sng" algn="ctr">
+                      <a:solidFill>
+                        <a:srgbClr val="C9D3E0"/>
+                      </a:solidFill>
+                      <a:prstDash val="solid"/>
+                      <a:round/>
+                      <a:headEnd type="none" w="med" len="med"/>
+                      <a:tailEnd type="none" w="med" len="med"/>
+                    </a:lnR>
+                    <a:lnT w="9525" cap="flat" cmpd="sng" algn="ctr">
+                      <a:solidFill>
+                        <a:srgbClr val="C9D3E0"/>
+                      </a:solidFill>
+                      <a:prstDash val="solid"/>
+                      <a:round/>
+                      <a:headEnd type="none" w="med" len="med"/>
+                      <a:tailEnd type="none" w="med" len="med"/>
+                    </a:lnT>
+                    <a:lnB w="9525" cap="flat" cmpd="sng" algn="ctr">
+                      <a:solidFill>
+                        <a:srgbClr val="C9D3E0"/>
+                      </a:solidFill>
+                      <a:prstDash val="solid"/>
+                      <a:round/>
+                      <a:headEnd type="none" w="med" len="med"/>
+                      <a:tailEnd type="none" w="med" len="med"/>
+                    </a:lnB>
+                  </a:tcPr>
+                </a:tc>
+                <a:tc>
+                  <a:txBody>
+                    <a:bodyPr/>
+                    <a:lstStyle/>
+                    <a:p>
+                      <a:pPr indent="0" marL="0">
+                        <a:buNone/>
+                      </a:pPr>
+                      <a:r>
+                        <a:rPr lang="en-US" sz="1250" i="1" dirty="0">
+                          <a:solidFill>
+                            <a:srgbClr val="9AA5B4"/>
+                          </a:solidFill>
+                          <a:latin typeface="Calibri" pitchFamily="34" charset="0"/>
+                          <a:ea typeface="Calibri" pitchFamily="34" charset="-122"/>
+                          <a:cs typeface="Calibri" pitchFamily="34" charset="-120"/>
+                        </a:rPr>
+                        <a:t>tbd</a:t>
+                      </a:r>
+                      <a:endParaRPr lang="en-US" sz="1250" dirty="0">
+                        <a:latin typeface="Calibri" charset="0"/>
+                        <a:ea typeface="Calibri" charset="0"/>
+                        <a:cs typeface="Calibri" charset="0"/>
+                      </a:endParaRPr>
+                    </a:p>
+                  </a:txBody>
+                  <a:tcPr marL="76200" marR="76200" marT="38100" marB="38100" anchor="ctr">
+                    <a:lnL w="9525" cap="flat" cmpd="sng" algn="ctr">
+                      <a:solidFill>
+                        <a:srgbClr val="C9D3E0"/>
+                      </a:solidFill>
+                      <a:prstDash val="solid"/>
+                      <a:round/>
+                      <a:headEnd type="none" w="med" len="med"/>
+                      <a:tailEnd type="none" w="med" len="med"/>
+                    </a:lnL>
+                    <a:lnR w="9525" cap="flat" cmpd="sng" algn="ctr">
+                      <a:solidFill>
+                        <a:srgbClr val="C9D3E0"/>
+                      </a:solidFill>
+                      <a:prstDash val="solid"/>
+                      <a:round/>
+                      <a:headEnd type="none" w="med" len="med"/>
+                      <a:tailEnd type="none" w="med" len="med"/>
+                    </a:lnR>
+                    <a:lnT w="9525" cap="flat" cmpd="sng" algn="ctr">
+                      <a:solidFill>
+                        <a:srgbClr val="C9D3E0"/>
+                      </a:solidFill>
+                      <a:prstDash val="solid"/>
+                      <a:round/>
+                      <a:headEnd type="none" w="med" len="med"/>
+                      <a:tailEnd type="none" w="med" len="med"/>
+                    </a:lnT>
+                    <a:lnB w="9525" cap="flat" cmpd="sng" algn="ctr">
+                      <a:solidFill>
+                        <a:srgbClr val="C9D3E0"/>
+                      </a:solidFill>
+                      <a:prstDash val="solid"/>
+                      <a:round/>
+                      <a:headEnd type="none" w="med" len="med"/>
+                      <a:tailEnd type="none" w="med" len="med"/>
+                    </a:lnB>
+                  </a:tcPr>
+                </a:tc>
+              </a:tr>
+              <a:tr h="310896">
+                <a:tc>
+                  <a:txBody>
+                    <a:bodyPr/>
+                    <a:lstStyle/>
+                    <a:p>
+                      <a:pPr indent="0" marL="0">
+                        <a:buNone/>
+                      </a:pPr>
+                      <a:r>
+                        <a:rPr lang="en-US" sz="1250" dirty="0">
+                          <a:solidFill>
+                            <a:srgbClr val="1F2937"/>
+                          </a:solidFill>
+                          <a:latin typeface="Calibri" pitchFamily="34" charset="0"/>
+                          <a:ea typeface="Calibri" pitchFamily="34" charset="-122"/>
+                          <a:cs typeface="Calibri" pitchFamily="34" charset="-120"/>
+                        </a:rPr>
+                        <a:t>32,000</a:t>
+                      </a:r>
+                      <a:endParaRPr lang="en-US" sz="1250" dirty="0">
+                        <a:latin typeface="Calibri" charset="0"/>
+                        <a:ea typeface="Calibri" charset="0"/>
+                        <a:cs typeface="Calibri" charset="0"/>
+                      </a:endParaRPr>
+                    </a:p>
+                  </a:txBody>
+                  <a:tcPr marL="76200" marR="76200" marT="38100" marB="38100" anchor="ctr">
+                    <a:lnL w="9525" cap="flat" cmpd="sng" algn="ctr">
+                      <a:solidFill>
+                        <a:srgbClr val="C9D3E0"/>
+                      </a:solidFill>
+                      <a:prstDash val="solid"/>
+                      <a:round/>
+                      <a:headEnd type="none" w="med" len="med"/>
+                      <a:tailEnd type="none" w="med" len="med"/>
+                    </a:lnL>
+                    <a:lnR w="9525" cap="flat" cmpd="sng" algn="ctr">
+                      <a:solidFill>
+                        <a:srgbClr val="C9D3E0"/>
+                      </a:solidFill>
+                      <a:prstDash val="solid"/>
+                      <a:round/>
+                      <a:headEnd type="none" w="med" len="med"/>
+                      <a:tailEnd type="none" w="med" len="med"/>
+                    </a:lnR>
+                    <a:lnT w="9525" cap="flat" cmpd="sng" algn="ctr">
+                      <a:solidFill>
+                        <a:srgbClr val="C9D3E0"/>
+                      </a:solidFill>
+                      <a:prstDash val="solid"/>
+                      <a:round/>
+                      <a:headEnd type="none" w="med" len="med"/>
+                      <a:tailEnd type="none" w="med" len="med"/>
+                    </a:lnT>
+                    <a:lnB w="9525" cap="flat" cmpd="sng" algn="ctr">
+                      <a:solidFill>
+                        <a:srgbClr val="C9D3E0"/>
+                      </a:solidFill>
+                      <a:prstDash val="solid"/>
+                      <a:round/>
+                      <a:headEnd type="none" w="med" len="med"/>
+                      <a:tailEnd type="none" w="med" len="med"/>
+                    </a:lnB>
+                  </a:tcPr>
+                </a:tc>
+                <a:tc>
+                  <a:txBody>
+                    <a:bodyPr/>
+                    <a:lstStyle/>
+                    <a:p>
+                      <a:pPr indent="0" marL="0">
+                        <a:buNone/>
+                      </a:pPr>
+                      <a:r>
+                        <a:rPr lang="en-US" sz="1250" dirty="0">
+                          <a:solidFill>
+                            <a:srgbClr val="1F2937"/>
+                          </a:solidFill>
+                          <a:latin typeface="Calibri" pitchFamily="34" charset="0"/>
+                          <a:ea typeface="Calibri" pitchFamily="34" charset="-122"/>
+                          <a:cs typeface="Calibri" pitchFamily="34" charset="-120"/>
+                        </a:rPr>
+                        <a:t>10</a:t>
+                      </a:r>
+                      <a:endParaRPr lang="en-US" sz="1250" dirty="0">
+                        <a:latin typeface="Calibri" charset="0"/>
+                        <a:ea typeface="Calibri" charset="0"/>
+                        <a:cs typeface="Calibri" charset="0"/>
+                      </a:endParaRPr>
+                    </a:p>
+                  </a:txBody>
+                  <a:tcPr marL="76200" marR="76200" marT="38100" marB="38100" anchor="ctr">
+                    <a:lnL w="9525" cap="flat" cmpd="sng" algn="ctr">
+                      <a:solidFill>
+                        <a:srgbClr val="C9D3E0"/>
+                      </a:solidFill>
+                      <a:prstDash val="solid"/>
+                      <a:round/>
+                      <a:headEnd type="none" w="med" len="med"/>
+                      <a:tailEnd type="none" w="med" len="med"/>
+                    </a:lnL>
+                    <a:lnR w="9525" cap="flat" cmpd="sng" algn="ctr">
+                      <a:solidFill>
+                        <a:srgbClr val="C9D3E0"/>
+                      </a:solidFill>
+                      <a:prstDash val="solid"/>
+                      <a:round/>
+                      <a:headEnd type="none" w="med" len="med"/>
+                      <a:tailEnd type="none" w="med" len="med"/>
+                    </a:lnR>
+                    <a:lnT w="9525" cap="flat" cmpd="sng" algn="ctr">
+                      <a:solidFill>
+                        <a:srgbClr val="C9D3E0"/>
+                      </a:solidFill>
+                      <a:prstDash val="solid"/>
+                      <a:round/>
+                      <a:headEnd type="none" w="med" len="med"/>
+                      <a:tailEnd type="none" w="med" len="med"/>
+                    </a:lnT>
+                    <a:lnB w="9525" cap="flat" cmpd="sng" algn="ctr">
+                      <a:solidFill>
+                        <a:srgbClr val="C9D3E0"/>
+                      </a:solidFill>
+                      <a:prstDash val="solid"/>
+                      <a:round/>
+                      <a:headEnd type="none" w="med" len="med"/>
+                      <a:tailEnd type="none" w="med" len="med"/>
+                    </a:lnB>
+                  </a:tcPr>
+                </a:tc>
+                <a:tc>
+                  <a:txBody>
+                    <a:bodyPr/>
+                    <a:lstStyle/>
+                    <a:p>
+                      <a:pPr indent="0" marL="0">
+                        <a:buNone/>
+                      </a:pPr>
+                      <a:r>
+                        <a:rPr lang="en-US" sz="1250" i="1" dirty="0">
+                          <a:solidFill>
+                            <a:srgbClr val="9AA5B4"/>
+                          </a:solidFill>
+                          <a:latin typeface="Calibri" pitchFamily="34" charset="0"/>
+                          <a:ea typeface="Calibri" pitchFamily="34" charset="-122"/>
+                          <a:cs typeface="Calibri" pitchFamily="34" charset="-120"/>
+                        </a:rPr>
+                        <a:t>tbd</a:t>
+                      </a:r>
+                      <a:endParaRPr lang="en-US" sz="1250" dirty="0">
+                        <a:latin typeface="Calibri" charset="0"/>
+                        <a:ea typeface="Calibri" charset="0"/>
+                        <a:cs typeface="Calibri" charset="0"/>
+                      </a:endParaRPr>
+                    </a:p>
+                  </a:txBody>
+                  <a:tcPr marL="76200" marR="76200" marT="38100" marB="38100" anchor="ctr">
+                    <a:lnL w="9525" cap="flat" cmpd="sng" algn="ctr">
+                      <a:solidFill>
+                        <a:srgbClr val="C9D3E0"/>
+                      </a:solidFill>
+                      <a:prstDash val="solid"/>
+                      <a:round/>
+                      <a:headEnd type="none" w="med" len="med"/>
+                      <a:tailEnd type="none" w="med" len="med"/>
+                    </a:lnL>
+                    <a:lnR w="9525" cap="flat" cmpd="sng" algn="ctr">
+                      <a:solidFill>
+                        <a:srgbClr val="C9D3E0"/>
+                      </a:solidFill>
+                      <a:prstDash val="solid"/>
+                      <a:round/>
+                      <a:headEnd type="none" w="med" len="med"/>
+                      <a:tailEnd type="none" w="med" len="med"/>
+                    </a:lnR>
+                    <a:lnT w="9525" cap="flat" cmpd="sng" algn="ctr">
+                      <a:solidFill>
+                        <a:srgbClr val="C9D3E0"/>
+                      </a:solidFill>
+                      <a:prstDash val="solid"/>
+                      <a:round/>
+                      <a:headEnd type="none" w="med" len="med"/>
+                      <a:tailEnd type="none" w="med" len="med"/>
+                    </a:lnT>
+                    <a:lnB w="9525" cap="flat" cmpd="sng" algn="ctr">
+                      <a:solidFill>
+                        <a:srgbClr val="C9D3E0"/>
+                      </a:solidFill>
+                      <a:prstDash val="solid"/>
+                      <a:round/>
+                      <a:headEnd type="none" w="med" len="med"/>
+                      <a:tailEnd type="none" w="med" len="med"/>
+                    </a:lnB>
+                  </a:tcPr>
+                </a:tc>
+                <a:tc>
+                  <a:txBody>
+                    <a:bodyPr/>
+                    <a:lstStyle/>
+                    <a:p>
+                      <a:pPr indent="0" marL="0">
+                        <a:buNone/>
+                      </a:pPr>
+                      <a:r>
+                        <a:rPr lang="en-US" sz="1250" i="1" dirty="0">
+                          <a:solidFill>
+                            <a:srgbClr val="9AA5B4"/>
+                          </a:solidFill>
+                          <a:latin typeface="Calibri" pitchFamily="34" charset="0"/>
+                          <a:ea typeface="Calibri" pitchFamily="34" charset="-122"/>
+                          <a:cs typeface="Calibri" pitchFamily="34" charset="-120"/>
+                        </a:rPr>
+                        <a:t>tbd</a:t>
+                      </a:r>
+                      <a:endParaRPr lang="en-US" sz="1250" dirty="0">
+                        <a:latin typeface="Calibri" charset="0"/>
+                        <a:ea typeface="Calibri" charset="0"/>
+                        <a:cs typeface="Calibri" charset="0"/>
+                      </a:endParaRPr>
+                    </a:p>
+                  </a:txBody>
+                  <a:tcPr marL="76200" marR="76200" marT="38100" marB="38100" anchor="ctr">
+                    <a:lnL w="9525" cap="flat" cmpd="sng" algn="ctr">
+                      <a:solidFill>
+                        <a:srgbClr val="C9D3E0"/>
+                      </a:solidFill>
+                      <a:prstDash val="solid"/>
+                      <a:round/>
+                      <a:headEnd type="none" w="med" len="med"/>
+                      <a:tailEnd type="none" w="med" len="med"/>
+                    </a:lnL>
+                    <a:lnR w="9525" cap="flat" cmpd="sng" algn="ctr">
+                      <a:solidFill>
+                        <a:srgbClr val="C9D3E0"/>
+                      </a:solidFill>
+                      <a:prstDash val="solid"/>
+                      <a:round/>
+                      <a:headEnd type="none" w="med" len="med"/>
+                      <a:tailEnd type="none" w="med" len="med"/>
+                    </a:lnR>
+                    <a:lnT w="9525" cap="flat" cmpd="sng" algn="ctr">
+                      <a:solidFill>
+                        <a:srgbClr val="C9D3E0"/>
+                      </a:solidFill>
+                      <a:prstDash val="solid"/>
+                      <a:round/>
+                      <a:headEnd type="none" w="med" len="med"/>
+                      <a:tailEnd type="none" w="med" len="med"/>
+                    </a:lnT>
+                    <a:lnB w="9525" cap="flat" cmpd="sng" algn="ctr">
+                      <a:solidFill>
+                        <a:srgbClr val="C9D3E0"/>
+                      </a:solidFill>
+                      <a:prstDash val="solid"/>
+                      <a:round/>
+                      <a:headEnd type="none" w="med" len="med"/>
+                      <a:tailEnd type="none" w="med" len="med"/>
+                    </a:lnB>
+                  </a:tcPr>
+                </a:tc>
+                <a:tc>
+                  <a:txBody>
+                    <a:bodyPr/>
+                    <a:lstStyle/>
+                    <a:p>
+                      <a:pPr indent="0" marL="0">
+                        <a:buNone/>
+                      </a:pPr>
+                      <a:r>
+                        <a:rPr lang="en-US" sz="1250" i="1" dirty="0">
+                          <a:solidFill>
+                            <a:srgbClr val="9AA5B4"/>
+                          </a:solidFill>
+                          <a:latin typeface="Calibri" pitchFamily="34" charset="0"/>
+                          <a:ea typeface="Calibri" pitchFamily="34" charset="-122"/>
+                          <a:cs typeface="Calibri" pitchFamily="34" charset="-120"/>
+                        </a:rPr>
+                        <a:t>tbd</a:t>
+                      </a:r>
+                      <a:endParaRPr lang="en-US" sz="1250" dirty="0">
+                        <a:latin typeface="Calibri" charset="0"/>
+                        <a:ea typeface="Calibri" charset="0"/>
+                        <a:cs typeface="Calibri" charset="0"/>
+                      </a:endParaRPr>
+                    </a:p>
+                  </a:txBody>
+                  <a:tcPr marL="76200" marR="76200" marT="38100" marB="38100" anchor="ctr">
+                    <a:lnL w="9525" cap="flat" cmpd="sng" algn="ctr">
+                      <a:solidFill>
+                        <a:srgbClr val="C9D3E0"/>
+                      </a:solidFill>
+                      <a:prstDash val="solid"/>
+                      <a:round/>
+                      <a:headEnd type="none" w="med" len="med"/>
+                      <a:tailEnd type="none" w="med" len="med"/>
+                    </a:lnL>
+                    <a:lnR w="9525" cap="flat" cmpd="sng" algn="ctr">
+                      <a:solidFill>
+                        <a:srgbClr val="C9D3E0"/>
+                      </a:solidFill>
+                      <a:prstDash val="solid"/>
+                      <a:round/>
+                      <a:headEnd type="none" w="med" len="med"/>
+                      <a:tailEnd type="none" w="med" len="med"/>
+                    </a:lnR>
+                    <a:lnT w="9525" cap="flat" cmpd="sng" algn="ctr">
+                      <a:solidFill>
+                        <a:srgbClr val="C9D3E0"/>
+                      </a:solidFill>
+                      <a:prstDash val="solid"/>
+                      <a:round/>
+                      <a:headEnd type="none" w="med" len="med"/>
+                      <a:tailEnd type="none" w="med" len="med"/>
+                    </a:lnT>
+                    <a:lnB w="9525" cap="flat" cmpd="sng" algn="ctr">
+                      <a:solidFill>
+                        <a:srgbClr val="C9D3E0"/>
+                      </a:solidFill>
+                      <a:prstDash val="solid"/>
+                      <a:round/>
+                      <a:headEnd type="none" w="med" len="med"/>
+                      <a:tailEnd type="none" w="med" len="med"/>
+                    </a:lnB>
+                  </a:tcPr>
+                </a:tc>
+                <a:tc>
+                  <a:txBody>
+                    <a:bodyPr/>
+                    <a:lstStyle/>
+                    <a:p>
+                      <a:pPr indent="0" marL="0">
+                        <a:buNone/>
+                      </a:pPr>
+                      <a:r>
+                        <a:rPr lang="en-US" sz="1250" i="1" dirty="0">
+                          <a:solidFill>
+                            <a:srgbClr val="9AA5B4"/>
+                          </a:solidFill>
+                          <a:latin typeface="Calibri" pitchFamily="34" charset="0"/>
+                          <a:ea typeface="Calibri" pitchFamily="34" charset="-122"/>
+                          <a:cs typeface="Calibri" pitchFamily="34" charset="-120"/>
+                        </a:rPr>
+                        <a:t>tbd</a:t>
+                      </a:r>
+                      <a:endParaRPr lang="en-US" sz="1250" dirty="0">
+                        <a:latin typeface="Calibri" charset="0"/>
+                        <a:ea typeface="Calibri" charset="0"/>
+                        <a:cs typeface="Calibri" charset="0"/>
+                      </a:endParaRPr>
+                    </a:p>
+                  </a:txBody>
+                  <a:tcPr marL="76200" marR="76200" marT="38100" marB="38100" anchor="ctr">
+                    <a:lnL w="9525" cap="flat" cmpd="sng" algn="ctr">
+                      <a:solidFill>
+                        <a:srgbClr val="C9D3E0"/>
+                      </a:solidFill>
+                      <a:prstDash val="solid"/>
+                      <a:round/>
+                      <a:headEnd type="none" w="med" len="med"/>
+                      <a:tailEnd type="none" w="med" len="med"/>
+                    </a:lnL>
+                    <a:lnR w="9525" cap="flat" cmpd="sng" algn="ctr">
+                      <a:solidFill>
+                        <a:srgbClr val="C9D3E0"/>
+                      </a:solidFill>
+                      <a:prstDash val="solid"/>
+                      <a:round/>
+                      <a:headEnd type="none" w="med" len="med"/>
+                      <a:tailEnd type="none" w="med" len="med"/>
+                    </a:lnR>
+                    <a:lnT w="9525" cap="flat" cmpd="sng" algn="ctr">
+                      <a:solidFill>
+                        <a:srgbClr val="C9D3E0"/>
+                      </a:solidFill>
+                      <a:prstDash val="solid"/>
+                      <a:round/>
+                      <a:headEnd type="none" w="med" len="med"/>
+                      <a:tailEnd type="none" w="med" len="med"/>
+                    </a:lnT>
+                    <a:lnB w="9525" cap="flat" cmpd="sng" algn="ctr">
+                      <a:solidFill>
+                        <a:srgbClr val="C9D3E0"/>
+                      </a:solidFill>
+                      <a:prstDash val="solid"/>
+                      <a:round/>
+                      <a:headEnd type="none" w="med" len="med"/>
+                      <a:tailEnd type="none" w="med" len="med"/>
+                    </a:lnB>
+                  </a:tcPr>
+                </a:tc>
+              </a:tr>
+              <a:tr h="310896">
+                <a:tc>
+                  <a:txBody>
+                    <a:bodyPr/>
+                    <a:lstStyle/>
+                    <a:p>
+                      <a:pPr indent="0" marL="0">
+                        <a:buNone/>
+                      </a:pPr>
+                      <a:r>
+                        <a:rPr lang="en-US" sz="1250" dirty="0">
+                          <a:solidFill>
+                            <a:srgbClr val="1F2937"/>
+                          </a:solidFill>
+                          <a:latin typeface="Calibri" pitchFamily="34" charset="0"/>
+                          <a:ea typeface="Calibri" pitchFamily="34" charset="-122"/>
+                          <a:cs typeface="Calibri" pitchFamily="34" charset="-120"/>
+                        </a:rPr>
+                        <a:t>65,536</a:t>
+                      </a:r>
+                      <a:endParaRPr lang="en-US" sz="1250" dirty="0">
+                        <a:latin typeface="Calibri" charset="0"/>
+                        <a:ea typeface="Calibri" charset="0"/>
+                        <a:cs typeface="Calibri" charset="0"/>
+                      </a:endParaRPr>
+                    </a:p>
+                  </a:txBody>
+                  <a:tcPr marL="76200" marR="76200" marT="38100" marB="38100" anchor="ctr">
+                    <a:lnL w="9525" cap="flat" cmpd="sng" algn="ctr">
+                      <a:solidFill>
+                        <a:srgbClr val="C9D3E0"/>
+                      </a:solidFill>
+                      <a:prstDash val="solid"/>
+                      <a:round/>
+                      <a:headEnd type="none" w="med" len="med"/>
+                      <a:tailEnd type="none" w="med" len="med"/>
+                    </a:lnL>
+                    <a:lnR w="9525" cap="flat" cmpd="sng" algn="ctr">
+                      <a:solidFill>
+                        <a:srgbClr val="C9D3E0"/>
+                      </a:solidFill>
+                      <a:prstDash val="solid"/>
+                      <a:round/>
+                      <a:headEnd type="none" w="med" len="med"/>
+                      <a:tailEnd type="none" w="med" len="med"/>
+                    </a:lnR>
+                    <a:lnT w="9525" cap="flat" cmpd="sng" algn="ctr">
+                      <a:solidFill>
+                        <a:srgbClr val="C9D3E0"/>
+                      </a:solidFill>
+                      <a:prstDash val="solid"/>
+                      <a:round/>
+                      <a:headEnd type="none" w="med" len="med"/>
+                      <a:tailEnd type="none" w="med" len="med"/>
+                    </a:lnT>
+                    <a:lnB w="9525" cap="flat" cmpd="sng" algn="ctr">
+                      <a:solidFill>
+                        <a:srgbClr val="C9D3E0"/>
+                      </a:solidFill>
+                      <a:prstDash val="solid"/>
+                      <a:round/>
+                      <a:headEnd type="none" w="med" len="med"/>
+                      <a:tailEnd type="none" w="med" len="med"/>
+                    </a:lnB>
+                  </a:tcPr>
+                </a:tc>
+                <a:tc>
+                  <a:txBody>
+                    <a:bodyPr/>
+                    <a:lstStyle/>
+                    <a:p>
+                      <a:pPr indent="0" marL="0">
+                        <a:buNone/>
+                      </a:pPr>
+                      <a:r>
+                        <a:rPr lang="en-US" sz="1250" dirty="0">
+                          <a:solidFill>
+                            <a:srgbClr val="1F2937"/>
+                          </a:solidFill>
+                          <a:latin typeface="Calibri" pitchFamily="34" charset="0"/>
+                          <a:ea typeface="Calibri" pitchFamily="34" charset="-122"/>
+                          <a:cs typeface="Calibri" pitchFamily="34" charset="-120"/>
+                        </a:rPr>
+                        <a:t>20</a:t>
+                      </a:r>
+                      <a:endParaRPr lang="en-US" sz="1250" dirty="0">
+                        <a:latin typeface="Calibri" charset="0"/>
+                        <a:ea typeface="Calibri" charset="0"/>
+                        <a:cs typeface="Calibri" charset="0"/>
+                      </a:endParaRPr>
+                    </a:p>
+                  </a:txBody>
+                  <a:tcPr marL="76200" marR="76200" marT="38100" marB="38100" anchor="ctr">
+                    <a:lnL w="9525" cap="flat" cmpd="sng" algn="ctr">
+                      <a:solidFill>
+                        <a:srgbClr val="C9D3E0"/>
+                      </a:solidFill>
+                      <a:prstDash val="solid"/>
+                      <a:round/>
+                      <a:headEnd type="none" w="med" len="med"/>
+                      <a:tailEnd type="none" w="med" len="med"/>
+                    </a:lnL>
+                    <a:lnR w="9525" cap="flat" cmpd="sng" algn="ctr">
+                      <a:solidFill>
+                        <a:srgbClr val="C9D3E0"/>
+                      </a:solidFill>
+                      <a:prstDash val="solid"/>
+                      <a:round/>
+                      <a:headEnd type="none" w="med" len="med"/>
+                      <a:tailEnd type="none" w="med" len="med"/>
+                    </a:lnR>
+                    <a:lnT w="9525" cap="flat" cmpd="sng" algn="ctr">
+                      <a:solidFill>
+                        <a:srgbClr val="C9D3E0"/>
+                      </a:solidFill>
+                      <a:prstDash val="solid"/>
+                      <a:round/>
+                      <a:headEnd type="none" w="med" len="med"/>
+                      <a:tailEnd type="none" w="med" len="med"/>
+                    </a:lnT>
+                    <a:lnB w="9525" cap="flat" cmpd="sng" algn="ctr">
+                      <a:solidFill>
+                        <a:srgbClr val="C9D3E0"/>
+                      </a:solidFill>
+                      <a:prstDash val="solid"/>
+                      <a:round/>
+                      <a:headEnd type="none" w="med" len="med"/>
+                      <a:tailEnd type="none" w="med" len="med"/>
+                    </a:lnB>
+                  </a:tcPr>
+                </a:tc>
+                <a:tc>
+                  <a:txBody>
+                    <a:bodyPr/>
+                    <a:lstStyle/>
+                    <a:p>
+                      <a:pPr indent="0" marL="0">
+                        <a:buNone/>
+                      </a:pPr>
+                      <a:r>
+                        <a:rPr lang="en-US" sz="1250" i="1" dirty="0">
+                          <a:solidFill>
+                            <a:srgbClr val="9AA5B4"/>
+                          </a:solidFill>
+                          <a:latin typeface="Calibri" pitchFamily="34" charset="0"/>
+                          <a:ea typeface="Calibri" pitchFamily="34" charset="-122"/>
+                          <a:cs typeface="Calibri" pitchFamily="34" charset="-120"/>
+                        </a:rPr>
+                        <a:t>tbd</a:t>
+                      </a:r>
+                      <a:endParaRPr lang="en-US" sz="1250" dirty="0">
+                        <a:latin typeface="Calibri" charset="0"/>
+                        <a:ea typeface="Calibri" charset="0"/>
+                        <a:cs typeface="Calibri" charset="0"/>
+                      </a:endParaRPr>
+                    </a:p>
+                  </a:txBody>
+                  <a:tcPr marL="76200" marR="76200" marT="38100" marB="38100" anchor="ctr">
+                    <a:lnL w="9525" cap="flat" cmpd="sng" algn="ctr">
+                      <a:solidFill>
+                        <a:srgbClr val="C9D3E0"/>
+                      </a:solidFill>
+                      <a:prstDash val="solid"/>
+                      <a:round/>
+                      <a:headEnd type="none" w="med" len="med"/>
+                      <a:tailEnd type="none" w="med" len="med"/>
+                    </a:lnL>
+                    <a:lnR w="9525" cap="flat" cmpd="sng" algn="ctr">
+                      <a:solidFill>
+                        <a:srgbClr val="C9D3E0"/>
+                      </a:solidFill>
+                      <a:prstDash val="solid"/>
+                      <a:round/>
+                      <a:headEnd type="none" w="med" len="med"/>
+                      <a:tailEnd type="none" w="med" len="med"/>
+                    </a:lnR>
+                    <a:lnT w="9525" cap="flat" cmpd="sng" algn="ctr">
+                      <a:solidFill>
+                        <a:srgbClr val="C9D3E0"/>
+                      </a:solidFill>
+                      <a:prstDash val="solid"/>
+                      <a:round/>
+                      <a:headEnd type="none" w="med" len="med"/>
+                      <a:tailEnd type="none" w="med" len="med"/>
+                    </a:lnT>
+                    <a:lnB w="9525" cap="flat" cmpd="sng" algn="ctr">
+                      <a:solidFill>
+                        <a:srgbClr val="C9D3E0"/>
+                      </a:solidFill>
+                      <a:prstDash val="solid"/>
+                      <a:round/>
+                      <a:headEnd type="none" w="med" len="med"/>
+                      <a:tailEnd type="none" w="med" len="med"/>
+                    </a:lnB>
+                  </a:tcPr>
+                </a:tc>
+                <a:tc>
+                  <a:txBody>
+                    <a:bodyPr/>
+                    <a:lstStyle/>
+                    <a:p>
+                      <a:pPr indent="0" marL="0">
+                        <a:buNone/>
+                      </a:pPr>
+                      <a:r>
+                        <a:rPr lang="en-US" sz="1250" i="1" dirty="0">
+                          <a:solidFill>
+                            <a:srgbClr val="9AA5B4"/>
+                          </a:solidFill>
+                          <a:latin typeface="Calibri" pitchFamily="34" charset="0"/>
+                          <a:ea typeface="Calibri" pitchFamily="34" charset="-122"/>
+                          <a:cs typeface="Calibri" pitchFamily="34" charset="-120"/>
+                        </a:rPr>
+                        <a:t>tbd</a:t>
+                      </a:r>
+                      <a:endParaRPr lang="en-US" sz="1250" dirty="0">
+                        <a:latin typeface="Calibri" charset="0"/>
+                        <a:ea typeface="Calibri" charset="0"/>
+                        <a:cs typeface="Calibri" charset="0"/>
+                      </a:endParaRPr>
+                    </a:p>
+                  </a:txBody>
+                  <a:tcPr marL="76200" marR="76200" marT="38100" marB="38100" anchor="ctr">
+                    <a:lnL w="9525" cap="flat" cmpd="sng" algn="ctr">
+                      <a:solidFill>
+                        <a:srgbClr val="C9D3E0"/>
+                      </a:solidFill>
+                      <a:prstDash val="solid"/>
+                      <a:round/>
+                      <a:headEnd type="none" w="med" len="med"/>
+                      <a:tailEnd type="none" w="med" len="med"/>
+                    </a:lnL>
+                    <a:lnR w="9525" cap="flat" cmpd="sng" algn="ctr">
+                      <a:solidFill>
+                        <a:srgbClr val="C9D3E0"/>
+                      </a:solidFill>
+                      <a:prstDash val="solid"/>
+                      <a:round/>
+                      <a:headEnd type="none" w="med" len="med"/>
+                      <a:tailEnd type="none" w="med" len="med"/>
+                    </a:lnR>
+                    <a:lnT w="9525" cap="flat" cmpd="sng" algn="ctr">
+                      <a:solidFill>
+                        <a:srgbClr val="C9D3E0"/>
+                      </a:solidFill>
+                      <a:prstDash val="solid"/>
+                      <a:round/>
+                      <a:headEnd type="none" w="med" len="med"/>
+                      <a:tailEnd type="none" w="med" len="med"/>
+                    </a:lnT>
+                    <a:lnB w="9525" cap="flat" cmpd="sng" algn="ctr">
+                      <a:solidFill>
+                        <a:srgbClr val="C9D3E0"/>
+                      </a:solidFill>
+                      <a:prstDash val="solid"/>
+                      <a:round/>
+                      <a:headEnd type="none" w="med" len="med"/>
+                      <a:tailEnd type="none" w="med" len="med"/>
+                    </a:lnB>
+                  </a:tcPr>
+                </a:tc>
+                <a:tc>
+                  <a:txBody>
+                    <a:bodyPr/>
+                    <a:lstStyle/>
+                    <a:p>
+                      <a:pPr indent="0" marL="0">
+                        <a:buNone/>
+                      </a:pPr>
+                      <a:r>
+                        <a:rPr lang="en-US" sz="1250" i="1" dirty="0">
+                          <a:solidFill>
+                            <a:srgbClr val="9AA5B4"/>
+                          </a:solidFill>
+                          <a:latin typeface="Calibri" pitchFamily="34" charset="0"/>
+                          <a:ea typeface="Calibri" pitchFamily="34" charset="-122"/>
+                          <a:cs typeface="Calibri" pitchFamily="34" charset="-120"/>
+                        </a:rPr>
+                        <a:t>tbd</a:t>
+                      </a:r>
+                      <a:endParaRPr lang="en-US" sz="1250" dirty="0">
+                        <a:latin typeface="Calibri" charset="0"/>
+                        <a:ea typeface="Calibri" charset="0"/>
+                        <a:cs typeface="Calibri" charset="0"/>
+                      </a:endParaRPr>
+                    </a:p>
+                  </a:txBody>
+                  <a:tcPr marL="76200" marR="76200" marT="38100" marB="38100" anchor="ctr">
+                    <a:lnL w="9525" cap="flat" cmpd="sng" algn="ctr">
+                      <a:solidFill>
+                        <a:srgbClr val="C9D3E0"/>
+                      </a:solidFill>
+                      <a:prstDash val="solid"/>
+                      <a:round/>
+                      <a:headEnd type="none" w="med" len="med"/>
+                      <a:tailEnd type="none" w="med" len="med"/>
+                    </a:lnL>
+                    <a:lnR w="9525" cap="flat" cmpd="sng" algn="ctr">
+                      <a:solidFill>
+                        <a:srgbClr val="C9D3E0"/>
+                      </a:solidFill>
+                      <a:prstDash val="solid"/>
+                      <a:round/>
+                      <a:headEnd type="none" w="med" len="med"/>
+                      <a:tailEnd type="none" w="med" len="med"/>
+                    </a:lnR>
+                    <a:lnT w="9525" cap="flat" cmpd="sng" algn="ctr">
+                      <a:solidFill>
+                        <a:srgbClr val="C9D3E0"/>
+                      </a:solidFill>
+                      <a:prstDash val="solid"/>
+                      <a:round/>
+                      <a:headEnd type="none" w="med" len="med"/>
+                      <a:tailEnd type="none" w="med" len="med"/>
+                    </a:lnT>
+                    <a:lnB w="9525" cap="flat" cmpd="sng" algn="ctr">
+                      <a:solidFill>
+                        <a:srgbClr val="C9D3E0"/>
+                      </a:solidFill>
+                      <a:prstDash val="solid"/>
+                      <a:round/>
+                      <a:headEnd type="none" w="med" len="med"/>
+                      <a:tailEnd type="none" w="med" len="med"/>
+                    </a:lnB>
+                  </a:tcPr>
+                </a:tc>
+                <a:tc>
+                  <a:txBody>
+                    <a:bodyPr/>
+                    <a:lstStyle/>
+                    <a:p>
+                      <a:pPr indent="0" marL="0">
+                        <a:buNone/>
+                      </a:pPr>
+                      <a:r>
+                        <a:rPr lang="en-US" sz="1250" i="1" dirty="0">
+                          <a:solidFill>
+                            <a:srgbClr val="9AA5B4"/>
+                          </a:solidFill>
+                          <a:latin typeface="Calibri" pitchFamily="34" charset="0"/>
+                          <a:ea typeface="Calibri" pitchFamily="34" charset="-122"/>
+                          <a:cs typeface="Calibri" pitchFamily="34" charset="-120"/>
+                        </a:rPr>
+                        <a:t>tbd</a:t>
+                      </a:r>
+                      <a:endParaRPr lang="en-US" sz="1250" dirty="0">
+                        <a:latin typeface="Calibri" charset="0"/>
+                        <a:ea typeface="Calibri" charset="0"/>
+                        <a:cs typeface="Calibri" charset="0"/>
+                      </a:endParaRPr>
+                    </a:p>
+                  </a:txBody>
+                  <a:tcPr marL="76200" marR="76200" marT="38100" marB="38100" anchor="ctr">
+                    <a:lnL w="9525" cap="flat" cmpd="sng" algn="ctr">
+                      <a:solidFill>
+                        <a:srgbClr val="C9D3E0"/>
+                      </a:solidFill>
+                      <a:prstDash val="solid"/>
+                      <a:round/>
+                      <a:headEnd type="none" w="med" len="med"/>
+                      <a:tailEnd type="none" w="med" len="med"/>
+                    </a:lnL>
+                    <a:lnR w="9525" cap="flat" cmpd="sng" algn="ctr">
+                      <a:solidFill>
+                        <a:srgbClr val="C9D3E0"/>
+                      </a:solidFill>
+                      <a:prstDash val="solid"/>
+                      <a:round/>
+                      <a:headEnd type="none" w="med" len="med"/>
+                      <a:tailEnd type="none" w="med" len="med"/>
+                    </a:lnR>
+                    <a:lnT w="9525" cap="flat" cmpd="sng" algn="ctr">
+                      <a:solidFill>
+                        <a:srgbClr val="C9D3E0"/>
+                      </a:solidFill>
+                      <a:prstDash val="solid"/>
+                      <a:round/>
+                      <a:headEnd type="none" w="med" len="med"/>
+                      <a:tailEnd type="none" w="med" len="med"/>
+                    </a:lnT>
+                    <a:lnB w="9525" cap="flat" cmpd="sng" algn="ctr">
+                      <a:solidFill>
+                        <a:srgbClr val="C9D3E0"/>
+                      </a:solidFill>
+                      <a:prstDash val="solid"/>
+                      <a:round/>
+                      <a:headEnd type="none" w="med" len="med"/>
+                      <a:tailEnd type="none" w="med" len="med"/>
+                    </a:lnB>
+                  </a:tcPr>
+                </a:tc>
+              </a:tr>
+              <a:tr h="310896">
+                <a:tc>
+                  <a:txBody>
+                    <a:bodyPr/>
+                    <a:lstStyle/>
+                    <a:p>
+                      <a:pPr indent="0" marL="0">
+                        <a:buNone/>
+                      </a:pPr>
+                      <a:r>
+                        <a:rPr lang="en-US" sz="1250" dirty="0">
+                          <a:solidFill>
+                            <a:srgbClr val="1F2937"/>
+                          </a:solidFill>
+                          <a:latin typeface="Calibri" pitchFamily="34" charset="0"/>
+                          <a:ea typeface="Calibri" pitchFamily="34" charset="-122"/>
+                          <a:cs typeface="Calibri" pitchFamily="34" charset="-120"/>
+                        </a:rPr>
+                        <a:t>10⁶ (chunked)</a:t>
+                      </a:r>
+                      <a:endParaRPr lang="en-US" sz="1250" dirty="0">
+                        <a:latin typeface="Calibri" charset="0"/>
+                        <a:ea typeface="Calibri" charset="0"/>
+                        <a:cs typeface="Calibri" charset="0"/>
+                      </a:endParaRPr>
+                    </a:p>
+                  </a:txBody>
+                  <a:tcPr marL="76200" marR="76200" marT="38100" marB="38100" anchor="ctr">
+                    <a:lnL w="9525" cap="flat" cmpd="sng" algn="ctr">
+                      <a:solidFill>
+                        <a:srgbClr val="C9D3E0"/>
+                      </a:solidFill>
+                      <a:prstDash val="solid"/>
+                      <a:round/>
+                      <a:headEnd type="none" w="med" len="med"/>
+                      <a:tailEnd type="none" w="med" len="med"/>
+                    </a:lnL>
+                    <a:lnR w="9525" cap="flat" cmpd="sng" algn="ctr">
+                      <a:solidFill>
+                        <a:srgbClr val="C9D3E0"/>
+                      </a:solidFill>
+                      <a:prstDash val="solid"/>
+                      <a:round/>
+                      <a:headEnd type="none" w="med" len="med"/>
+                      <a:tailEnd type="none" w="med" len="med"/>
+                    </a:lnR>
+                    <a:lnT w="9525" cap="flat" cmpd="sng" algn="ctr">
+                      <a:solidFill>
+                        <a:srgbClr val="C9D3E0"/>
+                      </a:solidFill>
+                      <a:prstDash val="solid"/>
+                      <a:round/>
+                      <a:headEnd type="none" w="med" len="med"/>
+                      <a:tailEnd type="none" w="med" len="med"/>
+                    </a:lnT>
+                    <a:lnB w="9525" cap="flat" cmpd="sng" algn="ctr">
+                      <a:solidFill>
+                        <a:srgbClr val="C9D3E0"/>
+                      </a:solidFill>
+                      <a:prstDash val="solid"/>
+                      <a:round/>
+                      <a:headEnd type="none" w="med" len="med"/>
+                      <a:tailEnd type="none" w="med" len="med"/>
+                    </a:lnB>
+                  </a:tcPr>
+                </a:tc>
+                <a:tc>
+                  <a:txBody>
+                    <a:bodyPr/>
+                    <a:lstStyle/>
+                    <a:p>
+                      <a:pPr indent="0" marL="0">
+                        <a:buNone/>
+                      </a:pPr>
+                      <a:r>
+                        <a:rPr lang="en-US" sz="1250" dirty="0">
+                          <a:solidFill>
+                            <a:srgbClr val="1F2937"/>
+                          </a:solidFill>
+                          <a:latin typeface="Calibri" pitchFamily="34" charset="0"/>
+                          <a:ea typeface="Calibri" pitchFamily="34" charset="-122"/>
+                          <a:cs typeface="Calibri" pitchFamily="34" charset="-120"/>
+                        </a:rPr>
+                        <a:t>20</a:t>
+                      </a:r>
+                      <a:endParaRPr lang="en-US" sz="1250" dirty="0">
+                        <a:latin typeface="Calibri" charset="0"/>
+                        <a:ea typeface="Calibri" charset="0"/>
+                        <a:cs typeface="Calibri" charset="0"/>
+                      </a:endParaRPr>
+                    </a:p>
+                  </a:txBody>
+                  <a:tcPr marL="76200" marR="76200" marT="38100" marB="38100" anchor="ctr">
+                    <a:lnL w="9525" cap="flat" cmpd="sng" algn="ctr">
+                      <a:solidFill>
+                        <a:srgbClr val="C9D3E0"/>
+                      </a:solidFill>
+                      <a:prstDash val="solid"/>
+                      <a:round/>
+                      <a:headEnd type="none" w="med" len="med"/>
+                      <a:tailEnd type="none" w="med" len="med"/>
+                    </a:lnL>
+                    <a:lnR w="9525" cap="flat" cmpd="sng" algn="ctr">
+                      <a:solidFill>
+                        <a:srgbClr val="C9D3E0"/>
+                      </a:solidFill>
+                      <a:prstDash val="solid"/>
+                      <a:round/>
+                      <a:headEnd type="none" w="med" len="med"/>
+                      <a:tailEnd type="none" w="med" len="med"/>
+                    </a:lnR>
+                    <a:lnT w="9525" cap="flat" cmpd="sng" algn="ctr">
+                      <a:solidFill>
+                        <a:srgbClr val="C9D3E0"/>
+                      </a:solidFill>
+                      <a:prstDash val="solid"/>
+                      <a:round/>
+                      <a:headEnd type="none" w="med" len="med"/>
+                      <a:tailEnd type="none" w="med" len="med"/>
+                    </a:lnT>
+                    <a:lnB w="9525" cap="flat" cmpd="sng" algn="ctr">
+                      <a:solidFill>
+                        <a:srgbClr val="C9D3E0"/>
+                      </a:solidFill>
+                      <a:prstDash val="solid"/>
+                      <a:round/>
+                      <a:headEnd type="none" w="med" len="med"/>
+                      <a:tailEnd type="none" w="med" len="med"/>
+                    </a:lnB>
+                  </a:tcPr>
+                </a:tc>
+                <a:tc>
+                  <a:txBody>
+                    <a:bodyPr/>
+                    <a:lstStyle/>
+                    <a:p>
+                      <a:pPr indent="0" marL="0">
+                        <a:buNone/>
+                      </a:pPr>
+                      <a:r>
+                        <a:rPr lang="en-US" sz="1250" i="1" dirty="0">
+                          <a:solidFill>
+                            <a:srgbClr val="9AA5B4"/>
+                          </a:solidFill>
+                          <a:latin typeface="Calibri" pitchFamily="34" charset="0"/>
+                          <a:ea typeface="Calibri" pitchFamily="34" charset="-122"/>
+                          <a:cs typeface="Calibri" pitchFamily="34" charset="-120"/>
+                        </a:rPr>
+                        <a:t>tbd</a:t>
+                      </a:r>
+                      <a:endParaRPr lang="en-US" sz="1250" dirty="0">
+                        <a:latin typeface="Calibri" charset="0"/>
+                        <a:ea typeface="Calibri" charset="0"/>
+                        <a:cs typeface="Calibri" charset="0"/>
+                      </a:endParaRPr>
+                    </a:p>
+                  </a:txBody>
+                  <a:tcPr marL="76200" marR="76200" marT="38100" marB="38100" anchor="ctr">
+                    <a:lnL w="9525" cap="flat" cmpd="sng" algn="ctr">
+                      <a:solidFill>
+                        <a:srgbClr val="C9D3E0"/>
+                      </a:solidFill>
+                      <a:prstDash val="solid"/>
+                      <a:round/>
+                      <a:headEnd type="none" w="med" len="med"/>
+                      <a:tailEnd type="none" w="med" len="med"/>
+                    </a:lnL>
+                    <a:lnR w="9525" cap="flat" cmpd="sng" algn="ctr">
+                      <a:solidFill>
+                        <a:srgbClr val="C9D3E0"/>
+                      </a:solidFill>
+                      <a:prstDash val="solid"/>
+                      <a:round/>
+                      <a:headEnd type="none" w="med" len="med"/>
+                      <a:tailEnd type="none" w="med" len="med"/>
+                    </a:lnR>
+                    <a:lnT w="9525" cap="flat" cmpd="sng" algn="ctr">
+                      <a:solidFill>
+                        <a:srgbClr val="C9D3E0"/>
+                      </a:solidFill>
+                      <a:prstDash val="solid"/>
+                      <a:round/>
+                      <a:headEnd type="none" w="med" len="med"/>
+                      <a:tailEnd type="none" w="med" len="med"/>
+                    </a:lnT>
+                    <a:lnB w="9525" cap="flat" cmpd="sng" algn="ctr">
+                      <a:solidFill>
+                        <a:srgbClr val="C9D3E0"/>
+                      </a:solidFill>
+                      <a:prstDash val="solid"/>
+                      <a:round/>
+                      <a:headEnd type="none" w="med" len="med"/>
+                      <a:tailEnd type="none" w="med" len="med"/>
+                    </a:lnB>
+                  </a:tcPr>
+                </a:tc>
+                <a:tc>
+                  <a:txBody>
+                    <a:bodyPr/>
+                    <a:lstStyle/>
+                    <a:p>
+                      <a:pPr indent="0" marL="0">
+                        <a:buNone/>
+                      </a:pPr>
+                      <a:r>
+                        <a:rPr lang="en-US" sz="1250" i="1" dirty="0">
+                          <a:solidFill>
+                            <a:srgbClr val="9AA5B4"/>
+                          </a:solidFill>
+                          <a:latin typeface="Calibri" pitchFamily="34" charset="0"/>
+                          <a:ea typeface="Calibri" pitchFamily="34" charset="-122"/>
+                          <a:cs typeface="Calibri" pitchFamily="34" charset="-120"/>
+                        </a:rPr>
+                        <a:t>tbd</a:t>
+                      </a:r>
+                      <a:endParaRPr lang="en-US" sz="1250" dirty="0">
+                        <a:latin typeface="Calibri" charset="0"/>
+                        <a:ea typeface="Calibri" charset="0"/>
+                        <a:cs typeface="Calibri" charset="0"/>
+                      </a:endParaRPr>
+                    </a:p>
+                  </a:txBody>
+                  <a:tcPr marL="76200" marR="76200" marT="38100" marB="38100" anchor="ctr">
+                    <a:lnL w="9525" cap="flat" cmpd="sng" algn="ctr">
+                      <a:solidFill>
+                        <a:srgbClr val="C9D3E0"/>
+                      </a:solidFill>
+                      <a:prstDash val="solid"/>
+                      <a:round/>
+                      <a:headEnd type="none" w="med" len="med"/>
+                      <a:tailEnd type="none" w="med" len="med"/>
+                    </a:lnL>
+                    <a:lnR w="9525" cap="flat" cmpd="sng" algn="ctr">
+                      <a:solidFill>
+                        <a:srgbClr val="C9D3E0"/>
+                      </a:solidFill>
+                      <a:prstDash val="solid"/>
+                      <a:round/>
+                      <a:headEnd type="none" w="med" len="med"/>
+                      <a:tailEnd type="none" w="med" len="med"/>
+                    </a:lnR>
+                    <a:lnT w="9525" cap="flat" cmpd="sng" algn="ctr">
+                      <a:solidFill>
+                        <a:srgbClr val="C9D3E0"/>
+                      </a:solidFill>
+                      <a:prstDash val="solid"/>
+                      <a:round/>
+                      <a:headEnd type="none" w="med" len="med"/>
+                      <a:tailEnd type="none" w="med" len="med"/>
+                    </a:lnT>
+                    <a:lnB w="9525" cap="flat" cmpd="sng" algn="ctr">
+                      <a:solidFill>
+                        <a:srgbClr val="C9D3E0"/>
+                      </a:solidFill>
+                      <a:prstDash val="solid"/>
+                      <a:round/>
+                      <a:headEnd type="none" w="med" len="med"/>
+                      <a:tailEnd type="none" w="med" len="med"/>
+                    </a:lnB>
+                  </a:tcPr>
+                </a:tc>
+                <a:tc>
+                  <a:txBody>
+                    <a:bodyPr/>
+                    <a:lstStyle/>
+                    <a:p>
+                      <a:pPr indent="0" marL="0">
+                        <a:buNone/>
+                      </a:pPr>
+                      <a:r>
+                        <a:rPr lang="en-US" sz="1250" i="1" dirty="0">
+                          <a:solidFill>
+                            <a:srgbClr val="9AA5B4"/>
+                          </a:solidFill>
+                          <a:latin typeface="Calibri" pitchFamily="34" charset="0"/>
+                          <a:ea typeface="Calibri" pitchFamily="34" charset="-122"/>
+                          <a:cs typeface="Calibri" pitchFamily="34" charset="-120"/>
+                        </a:rPr>
+                        <a:t>tbd</a:t>
+                      </a:r>
+                      <a:endParaRPr lang="en-US" sz="1250" dirty="0">
+                        <a:latin typeface="Calibri" charset="0"/>
+                        <a:ea typeface="Calibri" charset="0"/>
+                        <a:cs typeface="Calibri" charset="0"/>
+                      </a:endParaRPr>
+                    </a:p>
+                  </a:txBody>
+                  <a:tcPr marL="76200" marR="76200" marT="38100" marB="38100" anchor="ctr">
+                    <a:lnL w="9525" cap="flat" cmpd="sng" algn="ctr">
+                      <a:solidFill>
+                        <a:srgbClr val="C9D3E0"/>
+                      </a:solidFill>
+                      <a:prstDash val="solid"/>
+                      <a:round/>
+                      <a:headEnd type="none" w="med" len="med"/>
+                      <a:tailEnd type="none" w="med" len="med"/>
+                    </a:lnL>
+                    <a:lnR w="9525" cap="flat" cmpd="sng" algn="ctr">
+                      <a:solidFill>
+                        <a:srgbClr val="C9D3E0"/>
+                      </a:solidFill>
+                      <a:prstDash val="solid"/>
+                      <a:round/>
+                      <a:headEnd type="none" w="med" len="med"/>
+                      <a:tailEnd type="none" w="med" len="med"/>
+                    </a:lnR>
+                    <a:lnT w="9525" cap="flat" cmpd="sng" algn="ctr">
+                      <a:solidFill>
+                        <a:srgbClr val="C9D3E0"/>
+                      </a:solidFill>
+                      <a:prstDash val="solid"/>
+                      <a:round/>
+                      <a:headEnd type="none" w="med" len="med"/>
+                      <a:tailEnd type="none" w="med" len="med"/>
+                    </a:lnT>
+                    <a:lnB w="9525" cap="flat" cmpd="sng" algn="ctr">
+                      <a:solidFill>
+                        <a:srgbClr val="C9D3E0"/>
+                      </a:solidFill>
+                      <a:prstDash val="solid"/>
+                      <a:round/>
+                      <a:headEnd type="none" w="med" len="med"/>
+                      <a:tailEnd type="none" w="med" len="med"/>
+                    </a:lnB>
+                  </a:tcPr>
+                </a:tc>
+                <a:tc>
+                  <a:txBody>
+                    <a:bodyPr/>
+                    <a:lstStyle/>
+                    <a:p>
+                      <a:pPr indent="0" marL="0">
+                        <a:buNone/>
+                      </a:pPr>
+                      <a:r>
+                        <a:rPr lang="en-US" sz="1250" i="1" dirty="0">
+                          <a:solidFill>
+                            <a:srgbClr val="9AA5B4"/>
+                          </a:solidFill>
+                          <a:latin typeface="Calibri" pitchFamily="34" charset="0"/>
+                          <a:ea typeface="Calibri" pitchFamily="34" charset="-122"/>
+                          <a:cs typeface="Calibri" pitchFamily="34" charset="-120"/>
+                        </a:rPr>
+                        <a:t>tbd</a:t>
+                      </a:r>
+                      <a:endParaRPr lang="en-US" sz="1250" dirty="0">
+                        <a:latin typeface="Calibri" charset="0"/>
+                        <a:ea typeface="Calibri" charset="0"/>
+                        <a:cs typeface="Calibri" charset="0"/>
+                      </a:endParaRPr>
+                    </a:p>
+                  </a:txBody>
+                  <a:tcPr marL="76200" marR="76200" marT="38100" marB="38100" anchor="ctr">
+                    <a:lnL w="9525" cap="flat" cmpd="sng" algn="ctr">
+                      <a:solidFill>
+                        <a:srgbClr val="C9D3E0"/>
+                      </a:solidFill>
+                      <a:prstDash val="solid"/>
+                      <a:round/>
+                      <a:headEnd type="none" w="med" len="med"/>
+                      <a:tailEnd type="none" w="med" len="med"/>
+                    </a:lnL>
+                    <a:lnR w="9525" cap="flat" cmpd="sng" algn="ctr">
+                      <a:solidFill>
+                        <a:srgbClr val="C9D3E0"/>
+                      </a:solidFill>
+                      <a:prstDash val="solid"/>
+                      <a:round/>
+                      <a:headEnd type="none" w="med" len="med"/>
+                      <a:tailEnd type="none" w="med" len="med"/>
+                    </a:lnR>
+                    <a:lnT w="9525" cap="flat" cmpd="sng" algn="ctr">
+                      <a:solidFill>
+                        <a:srgbClr val="C9D3E0"/>
+                      </a:solidFill>
+                      <a:prstDash val="solid"/>
+                      <a:round/>
+                      <a:headEnd type="none" w="med" len="med"/>
+                      <a:tailEnd type="none" w="med" len="med"/>
+                    </a:lnT>
+                    <a:lnB w="9525" cap="flat" cmpd="sng" algn="ctr">
+                      <a:solidFill>
+                        <a:srgbClr val="C9D3E0"/>
+                      </a:solidFill>
+                      <a:prstDash val="solid"/>
+                      <a:round/>
+                      <a:headEnd type="none" w="med" len="med"/>
+                      <a:tailEnd type="none" w="med" len="med"/>
+                    </a:lnB>
+                  </a:tcPr>
+                </a:tc>
+              </a:tr>
+            </a:tbl>
+          </a:graphicData>
+        </a:graphic>
+      </p:graphicFrame>
     </p:spTree>
   </p:cSld>
   <p:clrMapOvr>
@@ -28856,7 +30934,7 @@
                 <a:ea typeface="Cambria" pitchFamily="34" charset="-122"/>
                 <a:cs typeface="Cambria" pitchFamily="34" charset="-120"/>
               </a:rPr>
-              <a:t>Still to run</a:t>
+              <a:t>Intersection size on real data</a:t>
             </a:r>
             <a:endParaRPr lang="en-US" sz="3200" dirty="0"/>
           </a:p>
@@ -28864,59 +30942,46 @@
       </p:sp>
       <p:sp>
         <p:nvSpPr>
-          <p:cNvPr id="3" name="Shape 1"/>
-          <p:cNvSpPr/>
-          <p:nvPr/>
-        </p:nvSpPr>
-        <p:spPr>
-          <a:xfrm>
-            <a:off x="548640" y="1417320"/>
-            <a:ext cx="5440680" cy="4709160"/>
-          </a:xfrm>
-          <a:prstGeom prst="roundRect">
-            <a:avLst>
-              <a:gd name="adj" fmla="val 1553"/>
-            </a:avLst>
-          </a:prstGeom>
-          <a:solidFill>
-            <a:srgbClr val="FAFBFD"/>
-          </a:solidFill>
-          <a:ln w="15875">
-            <a:solidFill>
-              <a:srgbClr val="3D5A80"/>
-            </a:solidFill>
-            <a:prstDash val="dash"/>
-          </a:ln>
-        </p:spPr>
-      </p:sp>
-      <p:sp>
-        <p:nvSpPr>
-          <p:cNvPr id="4" name="Shape 2"/>
-          <p:cNvSpPr/>
-          <p:nvPr/>
-        </p:nvSpPr>
-        <p:spPr>
-          <a:xfrm>
-            <a:off x="2948940" y="2903220"/>
-            <a:ext cx="640080" cy="640080"/>
-          </a:xfrm>
-          <a:prstGeom prst="ellipse">
+          <p:cNvPr id="3" name="Text 1"/>
+          <p:cNvSpPr txBox="1"/>
+          <p:nvPr/>
+        </p:nvSpPr>
+        <p:spPr>
+          <a:xfrm>
+            <a:off x="548640" y="1024128"/>
+            <a:ext cx="11064240" cy="411480"/>
+          </a:xfrm>
+          <a:prstGeom prst="rect">
             <a:avLst/>
           </a:prstGeom>
-          <a:solidFill>
-            <a:srgbClr val="3D5A80"/>
-          </a:solidFill>
-          <a:ln w="12700">
-            <a:solidFill>
-              <a:srgbClr val="3D5A80"/>
-            </a:solidFill>
-            <a:prstDash val="solid"/>
-          </a:ln>
-        </p:spPr>
+          <a:noFill/>
+          <a:ln/>
+        </p:spPr>
+        <p:txBody>
+          <a:bodyPr wrap="square" lIns="0" tIns="0" rIns="0" bIns="0" rtlCol="0" anchor="ctr"/>
+          <a:lstStyle/>
+          <a:p>
+            <a:pPr indent="0" marL="0">
+              <a:buNone/>
+            </a:pPr>
+            <a:r>
+              <a:rPr lang="en-US" sz="1600" i="1" dirty="0">
+                <a:solidFill>
+                  <a:srgbClr val="5B6576"/>
+                </a:solidFill>
+                <a:latin typeface="Calibri" pitchFamily="34" charset="0"/>
+                <a:ea typeface="Calibri" pitchFamily="34" charset="-122"/>
+                <a:cs typeface="Calibri" pitchFamily="34" charset="-120"/>
+              </a:rPr>
+              <a:t>Test MSE ÷ non-private at the same n; nested subsets of the training folds; bars: 95% CI over folds</a:t>
+            </a:r>
+            <a:endParaRPr lang="en-US" sz="1600" dirty="0"/>
+          </a:p>
+        </p:txBody>
       </p:sp>
       <p:pic>
         <p:nvPicPr>
-          <p:cNvPr id="5" name="Image 0" descr="preencoded.png">    </p:cNvPr>
+          <p:cNvPr id="4" name="Image 0" descr="/home/user/VerticalFederatedRegression/reports/adassp/sweep/fig_sweep_n_deck.png">    </p:cNvPr>
           <p:cNvPicPr>
             <a:picLocks noChangeAspect="1"/>
           </p:cNvPicPr>
@@ -28930,8 +30995,8 @@
         </p:blipFill>
         <p:spPr>
           <a:xfrm>
-            <a:off x="3102559" y="3056839"/>
-            <a:ext cx="332842" cy="332842"/>
+            <a:off x="594360" y="1463040"/>
+            <a:ext cx="6309360" cy="5257800"/>
           </a:xfrm>
           <a:prstGeom prst="rect">
             <a:avLst/>
@@ -28940,92 +31005,14 @@
       </p:pic>
       <p:sp>
         <p:nvSpPr>
-          <p:cNvPr id="6" name="Text 3"/>
+          <p:cNvPr id="5" name="Text 2"/>
           <p:cNvSpPr txBox="1"/>
           <p:nvPr/>
         </p:nvSpPr>
         <p:spPr>
           <a:xfrm>
-            <a:off x="822960" y="3634740"/>
-            <a:ext cx="4892040" cy="411480"/>
-          </a:xfrm>
-          <a:prstGeom prst="rect">
-            <a:avLst/>
-          </a:prstGeom>
-          <a:noFill/>
-          <a:ln/>
-        </p:spPr>
-        <p:txBody>
-          <a:bodyPr wrap="square" lIns="0" tIns="0" rIns="0" bIns="0" rtlCol="0" anchor="ctr"/>
-          <a:lstStyle/>
-          <a:p>
-            <a:pPr algn="ctr" indent="0" marL="0">
-              <a:buNone/>
-            </a:pPr>
-            <a:r>
-              <a:rPr lang="en-US" sz="1600" b="1" dirty="0">
-                <a:solidFill>
-                  <a:srgbClr val="14213D"/>
-                </a:solidFill>
-                <a:latin typeface="Calibri" pitchFamily="34" charset="0"/>
-                <a:ea typeface="Calibri" pitchFamily="34" charset="-122"/>
-                <a:cs typeface="Calibri" pitchFamily="34" charset="-120"/>
-              </a:rPr>
-              <a:t>Intersection-size sweep on real data</a:t>
-            </a:r>
-            <a:endParaRPr lang="en-US" sz="1600" dirty="0"/>
-          </a:p>
-        </p:txBody>
-      </p:sp>
-      <p:sp>
-        <p:nvSpPr>
-          <p:cNvPr id="7" name="Text 4"/>
-          <p:cNvSpPr txBox="1"/>
-          <p:nvPr/>
-        </p:nvSpPr>
-        <p:spPr>
-          <a:xfrm>
-            <a:off x="914400" y="4046220"/>
-            <a:ext cx="4709160" cy="1943100"/>
-          </a:xfrm>
-          <a:prstGeom prst="rect">
-            <a:avLst/>
-          </a:prstGeom>
-          <a:noFill/>
-          <a:ln/>
-        </p:spPr>
-        <p:txBody>
-          <a:bodyPr wrap="square" lIns="0" tIns="0" rIns="0" bIns="0" rtlCol="0" anchor="t"/>
-          <a:lstStyle/>
-          <a:p>
-            <a:pPr algn="ctr" indent="0" marL="0">
-              <a:buNone/>
-            </a:pPr>
-            <a:r>
-              <a:rPr lang="en-US" sz="1250" dirty="0">
-                <a:solidFill>
-                  <a:srgbClr val="5B6576"/>
-                </a:solidFill>
-                <a:latin typeface="Calibri" pitchFamily="34" charset="0"/>
-                <a:ea typeface="Calibri" pitchFamily="34" charset="-122"/>
-                <a:cs typeface="Calibri" pitchFamily="34" charset="-120"/>
-              </a:rPr>
-              <a:t>Graphic to be done: test MSE vs matched cohort size n (log) for bike, elevators, pol, kin40k and protein, one panel per dataset, lines for ε ∈ {0.5, 1, 2, 4}; AdaSSP and non-private for reference.</a:t>
-            </a:r>
-            <a:endParaRPr lang="en-US" sz="1250" dirty="0"/>
-          </a:p>
-        </p:txBody>
-      </p:sp>
-      <p:sp>
-        <p:nvSpPr>
-          <p:cNvPr id="8" name="Text 5"/>
-          <p:cNvSpPr txBox="1"/>
-          <p:nvPr/>
-        </p:nvSpPr>
-        <p:spPr>
-          <a:xfrm>
-            <a:off x="6263640" y="1463040"/>
-            <a:ext cx="5303520" cy="411480"/>
+            <a:off x="7360920" y="1508760"/>
+            <a:ext cx="4297680" cy="640080"/>
           </a:xfrm>
           <a:prstGeom prst="rect">
             <a:avLst/>
@@ -29041,7 +31028,7 @@
               <a:buNone/>
             </a:pPr>
             <a:r>
-              <a:rPr lang="en-US" sz="1800" b="1" dirty="0">
+              <a:rPr lang="en-US" sz="1600" b="1" dirty="0">
                 <a:solidFill>
                   <a:srgbClr val="14213D"/>
                 </a:solidFill>
@@ -29049,9 +31036,48 @@
                 <a:ea typeface="Cambria" pitchFamily="34" charset="-122"/>
                 <a:cs typeface="Cambria" pitchFamily="34" charset="-120"/>
               </a:rPr>
-              <a:t>Cost of the revised protocol in OpenFHE</a:t>
+              <a:t>Matched records to come within 10% of non-private</a:t>
             </a:r>
-            <a:endParaRPr lang="en-US" sz="1800" dirty="0"/>
+            <a:endParaRPr lang="en-US" sz="1600" dirty="0"/>
+          </a:p>
+        </p:txBody>
+      </p:sp>
+      <p:sp>
+        <p:nvSpPr>
+          <p:cNvPr id="6" name="Text 3"/>
+          <p:cNvSpPr txBox="1"/>
+          <p:nvPr/>
+        </p:nvSpPr>
+        <p:spPr>
+          <a:xfrm>
+            <a:off x="7360920" y="2148840"/>
+            <a:ext cx="4297680" cy="274320"/>
+          </a:xfrm>
+          <a:prstGeom prst="rect">
+            <a:avLst/>
+          </a:prstGeom>
+          <a:noFill/>
+          <a:ln/>
+        </p:spPr>
+        <p:txBody>
+          <a:bodyPr wrap="square" lIns="0" tIns="0" rIns="0" bIns="0" rtlCol="0" anchor="t"/>
+          <a:lstStyle/>
+          <a:p>
+            <a:pPr indent="0" marL="0">
+              <a:buNone/>
+            </a:pPr>
+            <a:r>
+              <a:rPr lang="en-US" sz="1200" i="1" dirty="0">
+                <a:solidFill>
+                  <a:srgbClr val="5B6576"/>
+                </a:solidFill>
+                <a:latin typeface="Calibri" pitchFamily="34" charset="0"/>
+                <a:ea typeface="Calibri" pitchFamily="34" charset="-122"/>
+                <a:cs typeface="Calibri" pitchFamily="34" charset="-120"/>
+              </a:rPr>
+              <a:t>Ours (AdaSSP published)</a:t>
+            </a:r>
+            <a:endParaRPr lang="en-US" sz="1200" dirty="0"/>
           </a:p>
         </p:txBody>
       </p:sp>
@@ -29070,7 +31096,7 @@
           </p:nvPr>
         </p:nvGraphicFramePr>
         <p:xfrm>
-          <a:off x="6263640" y="1965960"/>
+          <a:off x="7360920" y="2468880"/>
           <a:ext cx="9144000" cy="914400"/>
         </p:xfrm>
         <a:graphic>
@@ -29078,41 +31104,29 @@
             <a:tbl>
               <a:tblPr/>
               <a:tblGrid>
-                <a:gridCol w="1234440"/>
-                <a:gridCol w="457200"/>
-                <a:gridCol w="777240"/>
+                <a:gridCol w="1005840"/>
                 <a:gridCol w="822960"/>
-                <a:gridCol w="1005840"/>
-                <a:gridCol w="1051560"/>
+                <a:gridCol w="822960"/>
+                <a:gridCol w="822960"/>
+                <a:gridCol w="822960"/>
               </a:tblGrid>
-              <a:tr h="438912">
+              <a:tr h="329184">
                 <a:tc>
                   <a:txBody>
                     <a:bodyPr/>
                     <a:lstStyle/>
                     <a:p>
-                      <a:pPr indent="0" marL="0">
+                      <a:pPr algn="ctr" indent="0" marL="0">
                         <a:buNone/>
                       </a:pPr>
-                      <a:r>
-                        <a:rPr lang="en-US" sz="1150" b="1" dirty="0">
-                          <a:solidFill>
-                            <a:srgbClr val="FFFFFF"/>
-                          </a:solidFill>
-                          <a:latin typeface="Calibri" pitchFamily="34" charset="0"/>
-                          <a:ea typeface="Calibri" pitchFamily="34" charset="-122"/>
-                          <a:cs typeface="Calibri" pitchFamily="34" charset="-120"/>
-                        </a:rPr>
-                        <a:t>n_O</a:t>
-                      </a:r>
-                      <a:endParaRPr lang="en-US" sz="1150" dirty="0">
+                      <a:endParaRPr lang="en-US" sz="1250" dirty="0">
                         <a:latin typeface="Calibri" charset="0"/>
                         <a:ea typeface="Calibri" charset="0"/>
                         <a:cs typeface="Calibri" charset="0"/>
                       </a:endParaRPr>
                     </a:p>
                   </a:txBody>
-                  <a:tcPr marL="50800" marR="50800" marT="38100" marB="38100" anchor="ctr">
+                  <a:tcPr marL="38100" marR="38100" marT="25400" marB="25400" anchor="ctr">
                     <a:lnL w="9525" cap="flat" cmpd="sng" algn="ctr">
                       <a:solidFill>
                         <a:srgbClr val="C9D3E0"/>
@@ -29159,11 +31173,11 @@
                     <a:bodyPr/>
                     <a:lstStyle/>
                     <a:p>
-                      <a:pPr indent="0" marL="0">
+                      <a:pPr algn="ctr" indent="0" marL="0">
                         <a:buNone/>
                       </a:pPr>
                       <a:r>
-                        <a:rPr lang="en-US" sz="1150" b="1" dirty="0">
+                        <a:rPr lang="en-US" sz="1250" b="1" dirty="0">
                           <a:solidFill>
                             <a:srgbClr val="FFFFFF"/>
                           </a:solidFill>
@@ -29171,16 +31185,16 @@
                           <a:ea typeface="Calibri" pitchFamily="34" charset="-122"/>
                           <a:cs typeface="Calibri" pitchFamily="34" charset="-120"/>
                         </a:rPr>
-                        <a:t>d</a:t>
+                        <a:t>ε = 0.5</a:t>
                       </a:r>
-                      <a:endParaRPr lang="en-US" sz="1150" dirty="0">
+                      <a:endParaRPr lang="en-US" sz="1250" dirty="0">
                         <a:latin typeface="Calibri" charset="0"/>
                         <a:ea typeface="Calibri" charset="0"/>
                         <a:cs typeface="Calibri" charset="0"/>
                       </a:endParaRPr>
                     </a:p>
                   </a:txBody>
-                  <a:tcPr marL="50800" marR="50800" marT="38100" marB="38100" anchor="ctr">
+                  <a:tcPr marL="38100" marR="38100" marT="25400" marB="25400" anchor="ctr">
                     <a:lnL w="9525" cap="flat" cmpd="sng" algn="ctr">
                       <a:solidFill>
                         <a:srgbClr val="C9D3E0"/>
@@ -29227,11 +31241,11 @@
                     <a:bodyPr/>
                     <a:lstStyle/>
                     <a:p>
-                      <a:pPr indent="0" marL="0">
+                      <a:pPr algn="ctr" indent="0" marL="0">
                         <a:buNone/>
                       </a:pPr>
                       <a:r>
-                        <a:rPr lang="en-US" sz="1150" b="1" dirty="0">
+                        <a:rPr lang="en-US" sz="1250" b="1" dirty="0">
                           <a:solidFill>
                             <a:srgbClr val="FFFFFF"/>
                           </a:solidFill>
@@ -29239,16 +31253,16 @@
                           <a:ea typeface="Calibri" pitchFamily="34" charset="-122"/>
                           <a:cs typeface="Calibri" pitchFamily="34" charset="-120"/>
                         </a:rPr>
-                        <a:t>PSI (s)</a:t>
+                        <a:t>ε = 1</a:t>
                       </a:r>
-                      <a:endParaRPr lang="en-US" sz="1150" dirty="0">
+                      <a:endParaRPr lang="en-US" sz="1250" dirty="0">
                         <a:latin typeface="Calibri" charset="0"/>
                         <a:ea typeface="Calibri" charset="0"/>
                         <a:cs typeface="Calibri" charset="0"/>
                       </a:endParaRPr>
                     </a:p>
                   </a:txBody>
-                  <a:tcPr marL="50800" marR="50800" marT="38100" marB="38100" anchor="ctr">
+                  <a:tcPr marL="38100" marR="38100" marT="25400" marB="25400" anchor="ctr">
                     <a:lnL w="9525" cap="flat" cmpd="sng" algn="ctr">
                       <a:solidFill>
                         <a:srgbClr val="C9D3E0"/>
@@ -29295,11 +31309,11 @@
                     <a:bodyPr/>
                     <a:lstStyle/>
                     <a:p>
-                      <a:pPr indent="0" marL="0">
+                      <a:pPr algn="ctr" indent="0" marL="0">
                         <a:buNone/>
                       </a:pPr>
                       <a:r>
-                        <a:rPr lang="en-US" sz="1150" b="1" dirty="0">
+                        <a:rPr lang="en-US" sz="1250" b="1" dirty="0">
                           <a:solidFill>
                             <a:srgbClr val="FFFFFF"/>
                           </a:solidFill>
@@ -29307,16 +31321,16 @@
                           <a:ea typeface="Calibri" pitchFamily="34" charset="-122"/>
                           <a:cs typeface="Calibri" pitchFamily="34" charset="-120"/>
                         </a:rPr>
-                        <a:t>Agg. (s)</a:t>
+                        <a:t>ε = 2</a:t>
                       </a:r>
-                      <a:endParaRPr lang="en-US" sz="1150" dirty="0">
+                      <a:endParaRPr lang="en-US" sz="1250" dirty="0">
                         <a:latin typeface="Calibri" charset="0"/>
                         <a:ea typeface="Calibri" charset="0"/>
                         <a:cs typeface="Calibri" charset="0"/>
                       </a:endParaRPr>
                     </a:p>
                   </a:txBody>
-                  <a:tcPr marL="50800" marR="50800" marT="38100" marB="38100" anchor="ctr">
+                  <a:tcPr marL="38100" marR="38100" marT="25400" marB="25400" anchor="ctr">
                     <a:lnL w="9525" cap="flat" cmpd="sng" algn="ctr">
                       <a:solidFill>
                         <a:srgbClr val="C9D3E0"/>
@@ -29363,11 +31377,11 @@
                     <a:bodyPr/>
                     <a:lstStyle/>
                     <a:p>
-                      <a:pPr indent="0" marL="0">
+                      <a:pPr algn="ctr" indent="0" marL="0">
                         <a:buNone/>
                       </a:pPr>
                       <a:r>
-                        <a:rPr lang="en-US" sz="1150" b="1" dirty="0">
+                        <a:rPr lang="en-US" sz="1250" b="1" dirty="0">
                           <a:solidFill>
                             <a:srgbClr val="FFFFFF"/>
                           </a:solidFill>
@@ -29375,84 +31389,16 @@
                           <a:ea typeface="Calibri" pitchFamily="34" charset="-122"/>
                           <a:cs typeface="Calibri" pitchFamily="34" charset="-120"/>
                         </a:rPr>
-                        <a:t>Traffic (MB)</a:t>
+                        <a:t>ε = 4</a:t>
                       </a:r>
-                      <a:endParaRPr lang="en-US" sz="1150" dirty="0">
+                      <a:endParaRPr lang="en-US" sz="1250" dirty="0">
                         <a:latin typeface="Calibri" charset="0"/>
                         <a:ea typeface="Calibri" charset="0"/>
                         <a:cs typeface="Calibri" charset="0"/>
                       </a:endParaRPr>
                     </a:p>
                   </a:txBody>
-                  <a:tcPr marL="50800" marR="50800" marT="38100" marB="38100" anchor="ctr">
-                    <a:lnL w="9525" cap="flat" cmpd="sng" algn="ctr">
-                      <a:solidFill>
-                        <a:srgbClr val="C9D3E0"/>
-                      </a:solidFill>
-                      <a:prstDash val="solid"/>
-                      <a:round/>
-                      <a:headEnd type="none" w="med" len="med"/>
-                      <a:tailEnd type="none" w="med" len="med"/>
-                    </a:lnL>
-                    <a:lnR w="9525" cap="flat" cmpd="sng" algn="ctr">
-                      <a:solidFill>
-                        <a:srgbClr val="C9D3E0"/>
-                      </a:solidFill>
-                      <a:prstDash val="solid"/>
-                      <a:round/>
-                      <a:headEnd type="none" w="med" len="med"/>
-                      <a:tailEnd type="none" w="med" len="med"/>
-                    </a:lnR>
-                    <a:lnT w="9525" cap="flat" cmpd="sng" algn="ctr">
-                      <a:solidFill>
-                        <a:srgbClr val="C9D3E0"/>
-                      </a:solidFill>
-                      <a:prstDash val="solid"/>
-                      <a:round/>
-                      <a:headEnd type="none" w="med" len="med"/>
-                      <a:tailEnd type="none" w="med" len="med"/>
-                    </a:lnT>
-                    <a:lnB w="9525" cap="flat" cmpd="sng" algn="ctr">
-                      <a:solidFill>
-                        <a:srgbClr val="C9D3E0"/>
-                      </a:solidFill>
-                      <a:prstDash val="solid"/>
-                      <a:round/>
-                      <a:headEnd type="none" w="med" len="med"/>
-                      <a:tailEnd type="none" w="med" len="med"/>
-                    </a:lnB>
-                    <a:solidFill>
-                      <a:srgbClr val="14213D"/>
-                    </a:solidFill>
-                  </a:tcPr>
-                </a:tc>
-                <a:tc>
-                  <a:txBody>
-                    <a:bodyPr/>
-                    <a:lstStyle/>
-                    <a:p>
-                      <a:pPr indent="0" marL="0">
-                        <a:buNone/>
-                      </a:pPr>
-                      <a:r>
-                        <a:rPr lang="en-US" sz="1150" b="1" dirty="0">
-                          <a:solidFill>
-                            <a:srgbClr val="FFFFFF"/>
-                          </a:solidFill>
-                          <a:latin typeface="Calibri" pitchFamily="34" charset="0"/>
-                          <a:ea typeface="Calibri" pitchFamily="34" charset="-122"/>
-                          <a:cs typeface="Calibri" pitchFamily="34" charset="-120"/>
-                        </a:rPr>
-                        <a:t>Flood cost</a:t>
-                      </a:r>
-                      <a:endParaRPr lang="en-US" sz="1150" dirty="0">
-                        <a:latin typeface="Calibri" charset="0"/>
-                        <a:ea typeface="Calibri" charset="0"/>
-                        <a:cs typeface="Calibri" charset="0"/>
-                      </a:endParaRPr>
-                    </a:p>
-                  </a:txBody>
-                  <a:tcPr marL="50800" marR="50800" marT="38100" marB="38100" anchor="ctr">
+                  <a:tcPr marL="38100" marR="38100" marT="25400" marB="25400" anchor="ctr">
                     <a:lnL w="9525" cap="flat" cmpd="sng" algn="ctr">
                       <a:solidFill>
                         <a:srgbClr val="C9D3E0"/>
@@ -29495,17 +31441,17 @@
                   </a:tcPr>
                 </a:tc>
               </a:tr>
-              <a:tr h="438912">
+              <a:tr h="512064">
                 <a:tc>
                   <a:txBody>
                     <a:bodyPr/>
                     <a:lstStyle/>
                     <a:p>
-                      <a:pPr indent="0" marL="0">
+                      <a:pPr algn="ctr" indent="0" marL="0">
                         <a:buNone/>
                       </a:pPr>
                       <a:r>
-                        <a:rPr lang="en-US" sz="1150" dirty="0">
+                        <a:rPr lang="en-US" sz="1250" dirty="0">
                           <a:solidFill>
                             <a:srgbClr val="1F2937"/>
                           </a:solidFill>
@@ -29513,16 +31459,16 @@
                           <a:ea typeface="Calibri" pitchFamily="34" charset="-122"/>
                           <a:cs typeface="Calibri" pitchFamily="34" charset="-120"/>
                         </a:rPr>
-                        <a:t>4,000</a:t>
+                        <a:t>bike</a:t>
                       </a:r>
-                      <a:endParaRPr lang="en-US" sz="1150" dirty="0">
+                      <a:endParaRPr lang="en-US" sz="1250" dirty="0">
                         <a:latin typeface="Calibri" charset="0"/>
                         <a:ea typeface="Calibri" charset="0"/>
                         <a:cs typeface="Calibri" charset="0"/>
                       </a:endParaRPr>
                     </a:p>
                   </a:txBody>
-                  <a:tcPr marL="50800" marR="50800" marT="38100" marB="38100" anchor="ctr">
+                  <a:tcPr marL="38100" marR="38100" marT="25400" marB="25400" anchor="ctr">
                     <a:lnL w="9525" cap="flat" cmpd="sng" algn="ctr">
                       <a:solidFill>
                         <a:srgbClr val="C9D3E0"/>
@@ -29566,11 +31512,11 @@
                     <a:bodyPr/>
                     <a:lstStyle/>
                     <a:p>
-                      <a:pPr indent="0" marL="0">
+                      <a:pPr algn="ctr" indent="0" marL="0">
                         <a:buNone/>
                       </a:pPr>
                       <a:r>
-                        <a:rPr lang="en-US" sz="1150" dirty="0">
+                        <a:rPr lang="en-US" sz="1250" b="1" dirty="0">
                           <a:solidFill>
                             <a:srgbClr val="1F2937"/>
                           </a:solidFill>
@@ -29578,16 +31524,37 @@
                           <a:ea typeface="Calibri" pitchFamily="34" charset="-122"/>
                           <a:cs typeface="Calibri" pitchFamily="34" charset="-120"/>
                         </a:rPr>
-                        <a:t>10</a:t>
+                        <a:t>&gt;15k</a:t>
                       </a:r>
-                      <a:endParaRPr lang="en-US" sz="1150" dirty="0">
+                      <a:endParaRPr lang="en-US" sz="1250" dirty="0">
+                        <a:latin typeface="Calibri" charset="0"/>
+                        <a:ea typeface="Calibri" charset="0"/>
+                        <a:cs typeface="Calibri" charset="0"/>
+                      </a:endParaRPr>
+                    </a:p>
+                    <a:p>
+                      <a:pPr algn="ctr" indent="0" marL="0">
+                        <a:buNone/>
+                      </a:pPr>
+                      <a:r>
+                        <a:rPr lang="en-US" sz="1100" dirty="0">
+                          <a:solidFill>
+                            <a:srgbClr val="5B6576"/>
+                          </a:solidFill>
+                          <a:latin typeface="Calibri" pitchFamily="34" charset="0"/>
+                          <a:ea typeface="Calibri" pitchFamily="34" charset="-122"/>
+                          <a:cs typeface="Calibri" pitchFamily="34" charset="-120"/>
+                        </a:rPr>
+                        <a:t>(15k)</a:t>
+                      </a:r>
+                      <a:endParaRPr lang="en-US" sz="1250" dirty="0">
                         <a:latin typeface="Calibri" charset="0"/>
                         <a:ea typeface="Calibri" charset="0"/>
                         <a:cs typeface="Calibri" charset="0"/>
                       </a:endParaRPr>
                     </a:p>
                   </a:txBody>
-                  <a:tcPr marL="50800" marR="50800" marT="38100" marB="38100" anchor="ctr">
+                  <a:tcPr marL="38100" marR="38100" marT="25400" marB="25400" anchor="ctr">
                     <a:lnL w="9525" cap="flat" cmpd="sng" algn="ctr">
                       <a:solidFill>
                         <a:srgbClr val="C9D3E0"/>
@@ -29631,28 +31598,49 @@
                     <a:bodyPr/>
                     <a:lstStyle/>
                     <a:p>
-                      <a:pPr indent="0" marL="0">
+                      <a:pPr algn="ctr" indent="0" marL="0">
                         <a:buNone/>
                       </a:pPr>
                       <a:r>
-                        <a:rPr lang="en-US" sz="1150" i="1" dirty="0">
+                        <a:rPr lang="en-US" sz="1250" b="1" dirty="0">
                           <a:solidFill>
-                            <a:srgbClr val="9AA5B4"/>
+                            <a:srgbClr val="1F2937"/>
                           </a:solidFill>
                           <a:latin typeface="Calibri" pitchFamily="34" charset="0"/>
                           <a:ea typeface="Calibri" pitchFamily="34" charset="-122"/>
                           <a:cs typeface="Calibri" pitchFamily="34" charset="-120"/>
                         </a:rPr>
-                        <a:t>tbd</a:t>
+                        <a:t>11k</a:t>
                       </a:r>
-                      <a:endParaRPr lang="en-US" sz="1150" dirty="0">
+                      <a:endParaRPr lang="en-US" sz="1250" dirty="0">
+                        <a:latin typeface="Calibri" charset="0"/>
+                        <a:ea typeface="Calibri" charset="0"/>
+                        <a:cs typeface="Calibri" charset="0"/>
+                      </a:endParaRPr>
+                    </a:p>
+                    <a:p>
+                      <a:pPr algn="ctr" indent="0" marL="0">
+                        <a:buNone/>
+                      </a:pPr>
+                      <a:r>
+                        <a:rPr lang="en-US" sz="1100" dirty="0">
+                          <a:solidFill>
+                            <a:srgbClr val="5B6576"/>
+                          </a:solidFill>
+                          <a:latin typeface="Calibri" pitchFamily="34" charset="0"/>
+                          <a:ea typeface="Calibri" pitchFamily="34" charset="-122"/>
+                          <a:cs typeface="Calibri" pitchFamily="34" charset="-120"/>
+                        </a:rPr>
+                        <a:t>(7.5k)</a:t>
+                      </a:r>
+                      <a:endParaRPr lang="en-US" sz="1250" dirty="0">
                         <a:latin typeface="Calibri" charset="0"/>
                         <a:ea typeface="Calibri" charset="0"/>
                         <a:cs typeface="Calibri" charset="0"/>
                       </a:endParaRPr>
                     </a:p>
                   </a:txBody>
-                  <a:tcPr marL="50800" marR="50800" marT="38100" marB="38100" anchor="ctr">
+                  <a:tcPr marL="38100" marR="38100" marT="25400" marB="25400" anchor="ctr">
                     <a:lnL w="9525" cap="flat" cmpd="sng" algn="ctr">
                       <a:solidFill>
                         <a:srgbClr val="C9D3E0"/>
@@ -29696,28 +31684,49 @@
                     <a:bodyPr/>
                     <a:lstStyle/>
                     <a:p>
-                      <a:pPr indent="0" marL="0">
+                      <a:pPr algn="ctr" indent="0" marL="0">
                         <a:buNone/>
                       </a:pPr>
                       <a:r>
-                        <a:rPr lang="en-US" sz="1150" i="1" dirty="0">
+                        <a:rPr lang="en-US" sz="1250" b="1" dirty="0">
                           <a:solidFill>
-                            <a:srgbClr val="9AA5B4"/>
+                            <a:srgbClr val="1F2937"/>
                           </a:solidFill>
                           <a:latin typeface="Calibri" pitchFamily="34" charset="0"/>
                           <a:ea typeface="Calibri" pitchFamily="34" charset="-122"/>
                           <a:cs typeface="Calibri" pitchFamily="34" charset="-120"/>
                         </a:rPr>
-                        <a:t>tbd</a:t>
+                        <a:t>5.9k</a:t>
                       </a:r>
-                      <a:endParaRPr lang="en-US" sz="1150" dirty="0">
+                      <a:endParaRPr lang="en-US" sz="1250" dirty="0">
+                        <a:latin typeface="Calibri" charset="0"/>
+                        <a:ea typeface="Calibri" charset="0"/>
+                        <a:cs typeface="Calibri" charset="0"/>
+                      </a:endParaRPr>
+                    </a:p>
+                    <a:p>
+                      <a:pPr algn="ctr" indent="0" marL="0">
+                        <a:buNone/>
+                      </a:pPr>
+                      <a:r>
+                        <a:rPr lang="en-US" sz="1100" dirty="0">
+                          <a:solidFill>
+                            <a:srgbClr val="5B6576"/>
+                          </a:solidFill>
+                          <a:latin typeface="Calibri" pitchFamily="34" charset="0"/>
+                          <a:ea typeface="Calibri" pitchFamily="34" charset="-122"/>
+                          <a:cs typeface="Calibri" pitchFamily="34" charset="-120"/>
+                        </a:rPr>
+                        <a:t>(3.8k)</a:t>
+                      </a:r>
+                      <a:endParaRPr lang="en-US" sz="1250" dirty="0">
                         <a:latin typeface="Calibri" charset="0"/>
                         <a:ea typeface="Calibri" charset="0"/>
                         <a:cs typeface="Calibri" charset="0"/>
                       </a:endParaRPr>
                     </a:p>
                   </a:txBody>
-                  <a:tcPr marL="50800" marR="50800" marT="38100" marB="38100" anchor="ctr">
+                  <a:tcPr marL="38100" marR="38100" marT="25400" marB="25400" anchor="ctr">
                     <a:lnL w="9525" cap="flat" cmpd="sng" algn="ctr">
                       <a:solidFill>
                         <a:srgbClr val="C9D3E0"/>
@@ -29761,28 +31770,116 @@
                     <a:bodyPr/>
                     <a:lstStyle/>
                     <a:p>
-                      <a:pPr indent="0" marL="0">
+                      <a:pPr algn="ctr" indent="0" marL="0">
                         <a:buNone/>
                       </a:pPr>
                       <a:r>
-                        <a:rPr lang="en-US" sz="1150" i="1" dirty="0">
+                        <a:rPr lang="en-US" sz="1250" b="1" dirty="0">
                           <a:solidFill>
-                            <a:srgbClr val="9AA5B4"/>
+                            <a:srgbClr val="1F2937"/>
                           </a:solidFill>
                           <a:latin typeface="Calibri" pitchFamily="34" charset="0"/>
                           <a:ea typeface="Calibri" pitchFamily="34" charset="-122"/>
                           <a:cs typeface="Calibri" pitchFamily="34" charset="-120"/>
                         </a:rPr>
-                        <a:t>tbd</a:t>
+                        <a:t>3.1k</a:t>
                       </a:r>
-                      <a:endParaRPr lang="en-US" sz="1150" dirty="0">
+                      <a:endParaRPr lang="en-US" sz="1250" dirty="0">
+                        <a:latin typeface="Calibri" charset="0"/>
+                        <a:ea typeface="Calibri" charset="0"/>
+                        <a:cs typeface="Calibri" charset="0"/>
+                      </a:endParaRPr>
+                    </a:p>
+                    <a:p>
+                      <a:pPr algn="ctr" indent="0" marL="0">
+                        <a:buNone/>
+                      </a:pPr>
+                      <a:r>
+                        <a:rPr lang="en-US" sz="1100" dirty="0">
+                          <a:solidFill>
+                            <a:srgbClr val="5B6576"/>
+                          </a:solidFill>
+                          <a:latin typeface="Calibri" pitchFamily="34" charset="0"/>
+                          <a:ea typeface="Calibri" pitchFamily="34" charset="-122"/>
+                          <a:cs typeface="Calibri" pitchFamily="34" charset="-120"/>
+                        </a:rPr>
+                        <a:t>(1.8k)</a:t>
+                      </a:r>
+                      <a:endParaRPr lang="en-US" sz="1250" dirty="0">
                         <a:latin typeface="Calibri" charset="0"/>
                         <a:ea typeface="Calibri" charset="0"/>
                         <a:cs typeface="Calibri" charset="0"/>
                       </a:endParaRPr>
                     </a:p>
                   </a:txBody>
-                  <a:tcPr marL="50800" marR="50800" marT="38100" marB="38100" anchor="ctr">
+                  <a:tcPr marL="38100" marR="38100" marT="25400" marB="25400" anchor="ctr">
+                    <a:lnL w="9525" cap="flat" cmpd="sng" algn="ctr">
+                      <a:solidFill>
+                        <a:srgbClr val="C9D3E0"/>
+                      </a:solidFill>
+                      <a:prstDash val="solid"/>
+                      <a:round/>
+                      <a:headEnd type="none" w="med" len="med"/>
+                      <a:tailEnd type="none" w="med" len="med"/>
+                    </a:lnL>
+                    <a:lnR w="9525" cap="flat" cmpd="sng" algn="ctr">
+                      <a:solidFill>
+                        <a:srgbClr val="C9D3E0"/>
+                      </a:solidFill>
+                      <a:prstDash val="solid"/>
+                      <a:round/>
+                      <a:headEnd type="none" w="med" len="med"/>
+                      <a:tailEnd type="none" w="med" len="med"/>
+                    </a:lnR>
+                    <a:lnT w="9525" cap="flat" cmpd="sng" algn="ctr">
+                      <a:solidFill>
+                        <a:srgbClr val="C9D3E0"/>
+                      </a:solidFill>
+                      <a:prstDash val="solid"/>
+                      <a:round/>
+                      <a:headEnd type="none" w="med" len="med"/>
+                      <a:tailEnd type="none" w="med" len="med"/>
+                    </a:lnT>
+                    <a:lnB w="9525" cap="flat" cmpd="sng" algn="ctr">
+                      <a:solidFill>
+                        <a:srgbClr val="C9D3E0"/>
+                      </a:solidFill>
+                      <a:prstDash val="solid"/>
+                      <a:round/>
+                      <a:headEnd type="none" w="med" len="med"/>
+                      <a:tailEnd type="none" w="med" len="med"/>
+                    </a:lnB>
+                  </a:tcPr>
+                </a:tc>
+              </a:tr>
+              <a:tr h="512064">
+                <a:tc>
+                  <a:txBody>
+                    <a:bodyPr/>
+                    <a:lstStyle/>
+                    <a:p>
+                      <a:pPr algn="ctr" indent="0" marL="0">
+                        <a:buNone/>
+                      </a:pPr>
+                      <a:r>
+                        <a:rPr lang="en-US" sz="1250" dirty="0">
+                          <a:solidFill>
+                            <a:srgbClr val="1F2937"/>
+                          </a:solidFill>
+                          <a:latin typeface="Calibri" pitchFamily="34" charset="0"/>
+                          <a:ea typeface="Calibri" pitchFamily="34" charset="-122"/>
+                          <a:cs typeface="Calibri" pitchFamily="34" charset="-120"/>
+                        </a:rPr>
+                        <a:t>elevators</a:t>
+                      </a:r>
+                      <a:endParaRPr lang="en-US" sz="1250" dirty="0">
+                        <a:latin typeface="Calibri" charset="0"/>
+                        <a:ea typeface="Calibri" charset="0"/>
+                        <a:cs typeface="Calibri" charset="0"/>
+                      </a:endParaRPr>
+                    </a:p>
+                  </a:txBody>
+                  <a:tcPr marL="38100" marR="38100" marT="25400" marB="25400" anchor="ctr">
                     <a:lnL w="9525" cap="flat" cmpd="sng" algn="ctr">
                       <a:solidFill>
                         <a:srgbClr val="C9D3E0"/>
@@ -29826,78 +31923,11 @@
                     <a:bodyPr/>
                     <a:lstStyle/>
                     <a:p>
-                      <a:pPr indent="0" marL="0">
+                      <a:pPr algn="ctr" indent="0" marL="0">
                         <a:buNone/>
                       </a:pPr>
                       <a:r>
-                        <a:rPr lang="en-US" sz="1150" i="1" dirty="0">
-                          <a:solidFill>
-                            <a:srgbClr val="9AA5B4"/>
-                          </a:solidFill>
-                          <a:latin typeface="Calibri" pitchFamily="34" charset="0"/>
-                          <a:ea typeface="Calibri" pitchFamily="34" charset="-122"/>
-                          <a:cs typeface="Calibri" pitchFamily="34" charset="-120"/>
-                        </a:rPr>
-                        <a:t>tbd</a:t>
-                      </a:r>
-                      <a:endParaRPr lang="en-US" sz="1150" dirty="0">
-                        <a:latin typeface="Calibri" charset="0"/>
-                        <a:ea typeface="Calibri" charset="0"/>
-                        <a:cs typeface="Calibri" charset="0"/>
-                      </a:endParaRPr>
-                    </a:p>
-                  </a:txBody>
-                  <a:tcPr marL="50800" marR="50800" marT="38100" marB="38100" anchor="ctr">
-                    <a:lnL w="9525" cap="flat" cmpd="sng" algn="ctr">
-                      <a:solidFill>
-                        <a:srgbClr val="C9D3E0"/>
-                      </a:solidFill>
-                      <a:prstDash val="solid"/>
-                      <a:round/>
-                      <a:headEnd type="none" w="med" len="med"/>
-                      <a:tailEnd type="none" w="med" len="med"/>
-                    </a:lnL>
-                    <a:lnR w="9525" cap="flat" cmpd="sng" algn="ctr">
-                      <a:solidFill>
-                        <a:srgbClr val="C9D3E0"/>
-                      </a:solidFill>
-                      <a:prstDash val="solid"/>
-                      <a:round/>
-                      <a:headEnd type="none" w="med" len="med"/>
-                      <a:tailEnd type="none" w="med" len="med"/>
-                    </a:lnR>
-                    <a:lnT w="9525" cap="flat" cmpd="sng" algn="ctr">
-                      <a:solidFill>
-                        <a:srgbClr val="C9D3E0"/>
-                      </a:solidFill>
-                      <a:prstDash val="solid"/>
-                      <a:round/>
-                      <a:headEnd type="none" w="med" len="med"/>
-                      <a:tailEnd type="none" w="med" len="med"/>
-                    </a:lnT>
-                    <a:lnB w="9525" cap="flat" cmpd="sng" algn="ctr">
-                      <a:solidFill>
-                        <a:srgbClr val="C9D3E0"/>
-                      </a:solidFill>
-                      <a:prstDash val="solid"/>
-                      <a:round/>
-                      <a:headEnd type="none" w="med" len="med"/>
-                      <a:tailEnd type="none" w="med" len="med"/>
-                    </a:lnB>
-                  </a:tcPr>
-                </a:tc>
-              </a:tr>
-              <a:tr h="438912">
-                <a:tc>
-                  <a:txBody>
-                    <a:bodyPr/>
-                    <a:lstStyle/>
-                    <a:p>
-                      <a:pPr indent="0" marL="0">
-                        <a:buNone/>
-                      </a:pPr>
-                      <a:r>
-                        <a:rPr lang="en-US" sz="1150" dirty="0">
+                        <a:rPr lang="en-US" sz="1250" b="1" dirty="0">
                           <a:solidFill>
                             <a:srgbClr val="1F2937"/>
                           </a:solidFill>
@@ -29905,16 +31935,37 @@
                           <a:ea typeface="Calibri" pitchFamily="34" charset="-122"/>
                           <a:cs typeface="Calibri" pitchFamily="34" charset="-120"/>
                         </a:rPr>
-                        <a:t>32,000</a:t>
+                        <a:t>&gt;14k</a:t>
                       </a:r>
-                      <a:endParaRPr lang="en-US" sz="1150" dirty="0">
+                      <a:endParaRPr lang="en-US" sz="1250" dirty="0">
+                        <a:latin typeface="Calibri" charset="0"/>
+                        <a:ea typeface="Calibri" charset="0"/>
+                        <a:cs typeface="Calibri" charset="0"/>
+                      </a:endParaRPr>
+                    </a:p>
+                    <a:p>
+                      <a:pPr algn="ctr" indent="0" marL="0">
+                        <a:buNone/>
+                      </a:pPr>
+                      <a:r>
+                        <a:rPr lang="en-US" sz="1100" dirty="0">
+                          <a:solidFill>
+                            <a:srgbClr val="5B6576"/>
+                          </a:solidFill>
+                          <a:latin typeface="Calibri" pitchFamily="34" charset="0"/>
+                          <a:ea typeface="Calibri" pitchFamily="34" charset="-122"/>
+                          <a:cs typeface="Calibri" pitchFamily="34" charset="-120"/>
+                        </a:rPr>
+                        <a:t>(&gt;14k)</a:t>
+                      </a:r>
+                      <a:endParaRPr lang="en-US" sz="1250" dirty="0">
                         <a:latin typeface="Calibri" charset="0"/>
                         <a:ea typeface="Calibri" charset="0"/>
                         <a:cs typeface="Calibri" charset="0"/>
                       </a:endParaRPr>
                     </a:p>
                   </a:txBody>
-                  <a:tcPr marL="50800" marR="50800" marT="38100" marB="38100" anchor="ctr">
+                  <a:tcPr marL="38100" marR="38100" marT="25400" marB="25400" anchor="ctr">
                     <a:lnL w="9525" cap="flat" cmpd="sng" algn="ctr">
                       <a:solidFill>
                         <a:srgbClr val="C9D3E0"/>
@@ -29958,11 +32009,11 @@
                     <a:bodyPr/>
                     <a:lstStyle/>
                     <a:p>
-                      <a:pPr indent="0" marL="0">
+                      <a:pPr algn="ctr" indent="0" marL="0">
                         <a:buNone/>
                       </a:pPr>
                       <a:r>
-                        <a:rPr lang="en-US" sz="1150" dirty="0">
+                        <a:rPr lang="en-US" sz="1250" b="1" dirty="0">
                           <a:solidFill>
                             <a:srgbClr val="1F2937"/>
                           </a:solidFill>
@@ -29970,16 +32021,37 @@
                           <a:ea typeface="Calibri" pitchFamily="34" charset="-122"/>
                           <a:cs typeface="Calibri" pitchFamily="34" charset="-120"/>
                         </a:rPr>
-                        <a:t>10</a:t>
+                        <a:t>&gt;14k</a:t>
                       </a:r>
-                      <a:endParaRPr lang="en-US" sz="1150" dirty="0">
+                      <a:endParaRPr lang="en-US" sz="1250" dirty="0">
+                        <a:latin typeface="Calibri" charset="0"/>
+                        <a:ea typeface="Calibri" charset="0"/>
+                        <a:cs typeface="Calibri" charset="0"/>
+                      </a:endParaRPr>
+                    </a:p>
+                    <a:p>
+                      <a:pPr algn="ctr" indent="0" marL="0">
+                        <a:buNone/>
+                      </a:pPr>
+                      <a:r>
+                        <a:rPr lang="en-US" sz="1100" dirty="0">
+                          <a:solidFill>
+                            <a:srgbClr val="5B6576"/>
+                          </a:solidFill>
+                          <a:latin typeface="Calibri" pitchFamily="34" charset="0"/>
+                          <a:ea typeface="Calibri" pitchFamily="34" charset="-122"/>
+                          <a:cs typeface="Calibri" pitchFamily="34" charset="-120"/>
+                        </a:rPr>
+                        <a:t>(&gt;14k)</a:t>
+                      </a:r>
+                      <a:endParaRPr lang="en-US" sz="1250" dirty="0">
                         <a:latin typeface="Calibri" charset="0"/>
                         <a:ea typeface="Calibri" charset="0"/>
                         <a:cs typeface="Calibri" charset="0"/>
                       </a:endParaRPr>
                     </a:p>
                   </a:txBody>
-                  <a:tcPr marL="50800" marR="50800" marT="38100" marB="38100" anchor="ctr">
+                  <a:tcPr marL="38100" marR="38100" marT="25400" marB="25400" anchor="ctr">
                     <a:lnL w="9525" cap="flat" cmpd="sng" algn="ctr">
                       <a:solidFill>
                         <a:srgbClr val="C9D3E0"/>
@@ -30023,28 +32095,49 @@
                     <a:bodyPr/>
                     <a:lstStyle/>
                     <a:p>
-                      <a:pPr indent="0" marL="0">
+                      <a:pPr algn="ctr" indent="0" marL="0">
                         <a:buNone/>
                       </a:pPr>
                       <a:r>
-                        <a:rPr lang="en-US" sz="1150" i="1" dirty="0">
+                        <a:rPr lang="en-US" sz="1250" b="1" dirty="0">
                           <a:solidFill>
-                            <a:srgbClr val="9AA5B4"/>
+                            <a:srgbClr val="1F2937"/>
                           </a:solidFill>
                           <a:latin typeface="Calibri" pitchFamily="34" charset="0"/>
                           <a:ea typeface="Calibri" pitchFamily="34" charset="-122"/>
                           <a:cs typeface="Calibri" pitchFamily="34" charset="-120"/>
                         </a:rPr>
-                        <a:t>tbd</a:t>
+                        <a:t>&gt;14k</a:t>
                       </a:r>
-                      <a:endParaRPr lang="en-US" sz="1150" dirty="0">
+                      <a:endParaRPr lang="en-US" sz="1250" dirty="0">
+                        <a:latin typeface="Calibri" charset="0"/>
+                        <a:ea typeface="Calibri" charset="0"/>
+                        <a:cs typeface="Calibri" charset="0"/>
+                      </a:endParaRPr>
+                    </a:p>
+                    <a:p>
+                      <a:pPr algn="ctr" indent="0" marL="0">
+                        <a:buNone/>
+                      </a:pPr>
+                      <a:r>
+                        <a:rPr lang="en-US" sz="1100" dirty="0">
+                          <a:solidFill>
+                            <a:srgbClr val="5B6576"/>
+                          </a:solidFill>
+                          <a:latin typeface="Calibri" pitchFamily="34" charset="0"/>
+                          <a:ea typeface="Calibri" pitchFamily="34" charset="-122"/>
+                          <a:cs typeface="Calibri" pitchFamily="34" charset="-120"/>
+                        </a:rPr>
+                        <a:t>(&gt;14k)</a:t>
+                      </a:r>
+                      <a:endParaRPr lang="en-US" sz="1250" dirty="0">
                         <a:latin typeface="Calibri" charset="0"/>
                         <a:ea typeface="Calibri" charset="0"/>
                         <a:cs typeface="Calibri" charset="0"/>
                       </a:endParaRPr>
                     </a:p>
                   </a:txBody>
-                  <a:tcPr marL="50800" marR="50800" marT="38100" marB="38100" anchor="ctr">
+                  <a:tcPr marL="38100" marR="38100" marT="25400" marB="25400" anchor="ctr">
                     <a:lnL w="9525" cap="flat" cmpd="sng" algn="ctr">
                       <a:solidFill>
                         <a:srgbClr val="C9D3E0"/>
@@ -30088,28 +32181,116 @@
                     <a:bodyPr/>
                     <a:lstStyle/>
                     <a:p>
-                      <a:pPr indent="0" marL="0">
+                      <a:pPr algn="ctr" indent="0" marL="0">
                         <a:buNone/>
                       </a:pPr>
                       <a:r>
-                        <a:rPr lang="en-US" sz="1150" i="1" dirty="0">
+                        <a:rPr lang="en-US" sz="1250" b="1" dirty="0">
                           <a:solidFill>
-                            <a:srgbClr val="9AA5B4"/>
+                            <a:srgbClr val="1F2937"/>
                           </a:solidFill>
                           <a:latin typeface="Calibri" pitchFamily="34" charset="0"/>
                           <a:ea typeface="Calibri" pitchFamily="34" charset="-122"/>
                           <a:cs typeface="Calibri" pitchFamily="34" charset="-120"/>
                         </a:rPr>
-                        <a:t>tbd</a:t>
+                        <a:t>&gt;14k</a:t>
                       </a:r>
-                      <a:endParaRPr lang="en-US" sz="1150" dirty="0">
+                      <a:endParaRPr lang="en-US" sz="1250" dirty="0">
+                        <a:latin typeface="Calibri" charset="0"/>
+                        <a:ea typeface="Calibri" charset="0"/>
+                        <a:cs typeface="Calibri" charset="0"/>
+                      </a:endParaRPr>
+                    </a:p>
+                    <a:p>
+                      <a:pPr algn="ctr" indent="0" marL="0">
+                        <a:buNone/>
+                      </a:pPr>
+                      <a:r>
+                        <a:rPr lang="en-US" sz="1100" dirty="0">
+                          <a:solidFill>
+                            <a:srgbClr val="5B6576"/>
+                          </a:solidFill>
+                          <a:latin typeface="Calibri" pitchFamily="34" charset="0"/>
+                          <a:ea typeface="Calibri" pitchFamily="34" charset="-122"/>
+                          <a:cs typeface="Calibri" pitchFamily="34" charset="-120"/>
+                        </a:rPr>
+                        <a:t>(14k)</a:t>
+                      </a:r>
+                      <a:endParaRPr lang="en-US" sz="1250" dirty="0">
                         <a:latin typeface="Calibri" charset="0"/>
                         <a:ea typeface="Calibri" charset="0"/>
                         <a:cs typeface="Calibri" charset="0"/>
                       </a:endParaRPr>
                     </a:p>
                   </a:txBody>
-                  <a:tcPr marL="50800" marR="50800" marT="38100" marB="38100" anchor="ctr">
+                  <a:tcPr marL="38100" marR="38100" marT="25400" marB="25400" anchor="ctr">
+                    <a:lnL w="9525" cap="flat" cmpd="sng" algn="ctr">
+                      <a:solidFill>
+                        <a:srgbClr val="C9D3E0"/>
+                      </a:solidFill>
+                      <a:prstDash val="solid"/>
+                      <a:round/>
+                      <a:headEnd type="none" w="med" len="med"/>
+                      <a:tailEnd type="none" w="med" len="med"/>
+                    </a:lnL>
+                    <a:lnR w="9525" cap="flat" cmpd="sng" algn="ctr">
+                      <a:solidFill>
+                        <a:srgbClr val="C9D3E0"/>
+                      </a:solidFill>
+                      <a:prstDash val="solid"/>
+                      <a:round/>
+                      <a:headEnd type="none" w="med" len="med"/>
+                      <a:tailEnd type="none" w="med" len="med"/>
+                    </a:lnR>
+                    <a:lnT w="9525" cap="flat" cmpd="sng" algn="ctr">
+                      <a:solidFill>
+                        <a:srgbClr val="C9D3E0"/>
+                      </a:solidFill>
+                      <a:prstDash val="solid"/>
+                      <a:round/>
+                      <a:headEnd type="none" w="med" len="med"/>
+                      <a:tailEnd type="none" w="med" len="med"/>
+                    </a:lnT>
+                    <a:lnB w="9525" cap="flat" cmpd="sng" algn="ctr">
+                      <a:solidFill>
+                        <a:srgbClr val="C9D3E0"/>
+                      </a:solidFill>
+                      <a:prstDash val="solid"/>
+                      <a:round/>
+                      <a:headEnd type="none" w="med" len="med"/>
+                      <a:tailEnd type="none" w="med" len="med"/>
+                    </a:lnB>
+                  </a:tcPr>
+                </a:tc>
+              </a:tr>
+              <a:tr h="512064">
+                <a:tc>
+                  <a:txBody>
+                    <a:bodyPr/>
+                    <a:lstStyle/>
+                    <a:p>
+                      <a:pPr algn="ctr" indent="0" marL="0">
+                        <a:buNone/>
+                      </a:pPr>
+                      <a:r>
+                        <a:rPr lang="en-US" sz="1250" dirty="0">
+                          <a:solidFill>
+                            <a:srgbClr val="1F2937"/>
+                          </a:solidFill>
+                          <a:latin typeface="Calibri" pitchFamily="34" charset="0"/>
+                          <a:ea typeface="Calibri" pitchFamily="34" charset="-122"/>
+                          <a:cs typeface="Calibri" pitchFamily="34" charset="-120"/>
+                        </a:rPr>
+                        <a:t>pol</a:t>
+                      </a:r>
+                      <a:endParaRPr lang="en-US" sz="1250" dirty="0">
+                        <a:latin typeface="Calibri" charset="0"/>
+                        <a:ea typeface="Calibri" charset="0"/>
+                        <a:cs typeface="Calibri" charset="0"/>
+                      </a:endParaRPr>
+                    </a:p>
+                  </a:txBody>
+                  <a:tcPr marL="38100" marR="38100" marT="25400" marB="25400" anchor="ctr">
                     <a:lnL w="9525" cap="flat" cmpd="sng" algn="ctr">
                       <a:solidFill>
                         <a:srgbClr val="C9D3E0"/>
@@ -30153,28 +32334,49 @@
                     <a:bodyPr/>
                     <a:lstStyle/>
                     <a:p>
-                      <a:pPr indent="0" marL="0">
+                      <a:pPr algn="ctr" indent="0" marL="0">
                         <a:buNone/>
                       </a:pPr>
                       <a:r>
-                        <a:rPr lang="en-US" sz="1150" i="1" dirty="0">
+                        <a:rPr lang="en-US" sz="1250" b="1" dirty="0">
                           <a:solidFill>
-                            <a:srgbClr val="9AA5B4"/>
+                            <a:srgbClr val="1F2937"/>
                           </a:solidFill>
                           <a:latin typeface="Calibri" pitchFamily="34" charset="0"/>
                           <a:ea typeface="Calibri" pitchFamily="34" charset="-122"/>
                           <a:cs typeface="Calibri" pitchFamily="34" charset="-120"/>
                         </a:rPr>
-                        <a:t>tbd</a:t>
+                        <a:t>&gt;13k</a:t>
                       </a:r>
-                      <a:endParaRPr lang="en-US" sz="1150" dirty="0">
+                      <a:endParaRPr lang="en-US" sz="1250" dirty="0">
+                        <a:latin typeface="Calibri" charset="0"/>
+                        <a:ea typeface="Calibri" charset="0"/>
+                        <a:cs typeface="Calibri" charset="0"/>
+                      </a:endParaRPr>
+                    </a:p>
+                    <a:p>
+                      <a:pPr algn="ctr" indent="0" marL="0">
+                        <a:buNone/>
+                      </a:pPr>
+                      <a:r>
+                        <a:rPr lang="en-US" sz="1100" dirty="0">
+                          <a:solidFill>
+                            <a:srgbClr val="5B6576"/>
+                          </a:solidFill>
+                          <a:latin typeface="Calibri" pitchFamily="34" charset="0"/>
+                          <a:ea typeface="Calibri" pitchFamily="34" charset="-122"/>
+                          <a:cs typeface="Calibri" pitchFamily="34" charset="-120"/>
+                        </a:rPr>
+                        <a:t>(&gt;13k)</a:t>
+                      </a:r>
+                      <a:endParaRPr lang="en-US" sz="1250" dirty="0">
                         <a:latin typeface="Calibri" charset="0"/>
                         <a:ea typeface="Calibri" charset="0"/>
                         <a:cs typeface="Calibri" charset="0"/>
                       </a:endParaRPr>
                     </a:p>
                   </a:txBody>
-                  <a:tcPr marL="50800" marR="50800" marT="38100" marB="38100" anchor="ctr">
+                  <a:tcPr marL="38100" marR="38100" marT="25400" marB="25400" anchor="ctr">
                     <a:lnL w="9525" cap="flat" cmpd="sng" algn="ctr">
                       <a:solidFill>
                         <a:srgbClr val="C9D3E0"/>
@@ -30218,78 +32420,11 @@
                     <a:bodyPr/>
                     <a:lstStyle/>
                     <a:p>
-                      <a:pPr indent="0" marL="0">
+                      <a:pPr algn="ctr" indent="0" marL="0">
                         <a:buNone/>
                       </a:pPr>
                       <a:r>
-                        <a:rPr lang="en-US" sz="1150" i="1" dirty="0">
-                          <a:solidFill>
-                            <a:srgbClr val="9AA5B4"/>
-                          </a:solidFill>
-                          <a:latin typeface="Calibri" pitchFamily="34" charset="0"/>
-                          <a:ea typeface="Calibri" pitchFamily="34" charset="-122"/>
-                          <a:cs typeface="Calibri" pitchFamily="34" charset="-120"/>
-                        </a:rPr>
-                        <a:t>tbd</a:t>
-                      </a:r>
-                      <a:endParaRPr lang="en-US" sz="1150" dirty="0">
-                        <a:latin typeface="Calibri" charset="0"/>
-                        <a:ea typeface="Calibri" charset="0"/>
-                        <a:cs typeface="Calibri" charset="0"/>
-                      </a:endParaRPr>
-                    </a:p>
-                  </a:txBody>
-                  <a:tcPr marL="50800" marR="50800" marT="38100" marB="38100" anchor="ctr">
-                    <a:lnL w="9525" cap="flat" cmpd="sng" algn="ctr">
-                      <a:solidFill>
-                        <a:srgbClr val="C9D3E0"/>
-                      </a:solidFill>
-                      <a:prstDash val="solid"/>
-                      <a:round/>
-                      <a:headEnd type="none" w="med" len="med"/>
-                      <a:tailEnd type="none" w="med" len="med"/>
-                    </a:lnL>
-                    <a:lnR w="9525" cap="flat" cmpd="sng" algn="ctr">
-                      <a:solidFill>
-                        <a:srgbClr val="C9D3E0"/>
-                      </a:solidFill>
-                      <a:prstDash val="solid"/>
-                      <a:round/>
-                      <a:headEnd type="none" w="med" len="med"/>
-                      <a:tailEnd type="none" w="med" len="med"/>
-                    </a:lnR>
-                    <a:lnT w="9525" cap="flat" cmpd="sng" algn="ctr">
-                      <a:solidFill>
-                        <a:srgbClr val="C9D3E0"/>
-                      </a:solidFill>
-                      <a:prstDash val="solid"/>
-                      <a:round/>
-                      <a:headEnd type="none" w="med" len="med"/>
-                      <a:tailEnd type="none" w="med" len="med"/>
-                    </a:lnT>
-                    <a:lnB w="9525" cap="flat" cmpd="sng" algn="ctr">
-                      <a:solidFill>
-                        <a:srgbClr val="C9D3E0"/>
-                      </a:solidFill>
-                      <a:prstDash val="solid"/>
-                      <a:round/>
-                      <a:headEnd type="none" w="med" len="med"/>
-                      <a:tailEnd type="none" w="med" len="med"/>
-                    </a:lnB>
-                  </a:tcPr>
-                </a:tc>
-              </a:tr>
-              <a:tr h="438912">
-                <a:tc>
-                  <a:txBody>
-                    <a:bodyPr/>
-                    <a:lstStyle/>
-                    <a:p>
-                      <a:pPr indent="0" marL="0">
-                        <a:buNone/>
-                      </a:pPr>
-                      <a:r>
-                        <a:rPr lang="en-US" sz="1150" dirty="0">
+                        <a:rPr lang="en-US" sz="1250" b="1" dirty="0">
                           <a:solidFill>
                             <a:srgbClr val="1F2937"/>
                           </a:solidFill>
@@ -30297,16 +32432,37 @@
                           <a:ea typeface="Calibri" pitchFamily="34" charset="-122"/>
                           <a:cs typeface="Calibri" pitchFamily="34" charset="-120"/>
                         </a:rPr>
-                        <a:t>65,536</a:t>
+                        <a:t>10k</a:t>
                       </a:r>
-                      <a:endParaRPr lang="en-US" sz="1150" dirty="0">
+                      <a:endParaRPr lang="en-US" sz="1250" dirty="0">
+                        <a:latin typeface="Calibri" charset="0"/>
+                        <a:ea typeface="Calibri" charset="0"/>
+                        <a:cs typeface="Calibri" charset="0"/>
+                      </a:endParaRPr>
+                    </a:p>
+                    <a:p>
+                      <a:pPr algn="ctr" indent="0" marL="0">
+                        <a:buNone/>
+                      </a:pPr>
+                      <a:r>
+                        <a:rPr lang="en-US" sz="1100" dirty="0">
+                          <a:solidFill>
+                            <a:srgbClr val="5B6576"/>
+                          </a:solidFill>
+                          <a:latin typeface="Calibri" pitchFamily="34" charset="0"/>
+                          <a:ea typeface="Calibri" pitchFamily="34" charset="-122"/>
+                          <a:cs typeface="Calibri" pitchFamily="34" charset="-120"/>
+                        </a:rPr>
+                        <a:t>(7.0k)</a:t>
+                      </a:r>
+                      <a:endParaRPr lang="en-US" sz="1250" dirty="0">
                         <a:latin typeface="Calibri" charset="0"/>
                         <a:ea typeface="Calibri" charset="0"/>
                         <a:cs typeface="Calibri" charset="0"/>
                       </a:endParaRPr>
                     </a:p>
                   </a:txBody>
-                  <a:tcPr marL="50800" marR="50800" marT="38100" marB="38100" anchor="ctr">
+                  <a:tcPr marL="38100" marR="38100" marT="25400" marB="25400" anchor="ctr">
                     <a:lnL w="9525" cap="flat" cmpd="sng" algn="ctr">
                       <a:solidFill>
                         <a:srgbClr val="C9D3E0"/>
@@ -30350,11 +32506,11 @@
                     <a:bodyPr/>
                     <a:lstStyle/>
                     <a:p>
-                      <a:pPr indent="0" marL="0">
+                      <a:pPr algn="ctr" indent="0" marL="0">
                         <a:buNone/>
                       </a:pPr>
                       <a:r>
-                        <a:rPr lang="en-US" sz="1150" dirty="0">
+                        <a:rPr lang="en-US" sz="1250" b="1" dirty="0">
                           <a:solidFill>
                             <a:srgbClr val="1F2937"/>
                           </a:solidFill>
@@ -30362,16 +32518,37 @@
                           <a:ea typeface="Calibri" pitchFamily="34" charset="-122"/>
                           <a:cs typeface="Calibri" pitchFamily="34" charset="-120"/>
                         </a:rPr>
-                        <a:t>20</a:t>
+                        <a:t>5.3k</a:t>
                       </a:r>
-                      <a:endParaRPr lang="en-US" sz="1150" dirty="0">
+                      <a:endParaRPr lang="en-US" sz="1250" dirty="0">
+                        <a:latin typeface="Calibri" charset="0"/>
+                        <a:ea typeface="Calibri" charset="0"/>
+                        <a:cs typeface="Calibri" charset="0"/>
+                      </a:endParaRPr>
+                    </a:p>
+                    <a:p>
+                      <a:pPr algn="ctr" indent="0" marL="0">
+                        <a:buNone/>
+                      </a:pPr>
+                      <a:r>
+                        <a:rPr lang="en-US" sz="1100" dirty="0">
+                          <a:solidFill>
+                            <a:srgbClr val="5B6576"/>
+                          </a:solidFill>
+                          <a:latin typeface="Calibri" pitchFamily="34" charset="0"/>
+                          <a:ea typeface="Calibri" pitchFamily="34" charset="-122"/>
+                          <a:cs typeface="Calibri" pitchFamily="34" charset="-120"/>
+                        </a:rPr>
+                        <a:t>(3.5k)</a:t>
+                      </a:r>
+                      <a:endParaRPr lang="en-US" sz="1250" dirty="0">
                         <a:latin typeface="Calibri" charset="0"/>
                         <a:ea typeface="Calibri" charset="0"/>
                         <a:cs typeface="Calibri" charset="0"/>
                       </a:endParaRPr>
                     </a:p>
                   </a:txBody>
-                  <a:tcPr marL="50800" marR="50800" marT="38100" marB="38100" anchor="ctr">
+                  <a:tcPr marL="38100" marR="38100" marT="25400" marB="25400" anchor="ctr">
                     <a:lnL w="9525" cap="flat" cmpd="sng" algn="ctr">
                       <a:solidFill>
                         <a:srgbClr val="C9D3E0"/>
@@ -30415,28 +32592,116 @@
                     <a:bodyPr/>
                     <a:lstStyle/>
                     <a:p>
-                      <a:pPr indent="0" marL="0">
+                      <a:pPr algn="ctr" indent="0" marL="0">
                         <a:buNone/>
                       </a:pPr>
                       <a:r>
-                        <a:rPr lang="en-US" sz="1150" i="1" dirty="0">
+                        <a:rPr lang="en-US" sz="1250" b="1" dirty="0">
                           <a:solidFill>
-                            <a:srgbClr val="9AA5B4"/>
+                            <a:srgbClr val="1F2937"/>
                           </a:solidFill>
                           <a:latin typeface="Calibri" pitchFamily="34" charset="0"/>
                           <a:ea typeface="Calibri" pitchFamily="34" charset="-122"/>
                           <a:cs typeface="Calibri" pitchFamily="34" charset="-120"/>
                         </a:rPr>
-                        <a:t>tbd</a:t>
+                        <a:t>2.8k</a:t>
                       </a:r>
-                      <a:endParaRPr lang="en-US" sz="1150" dirty="0">
+                      <a:endParaRPr lang="en-US" sz="1250" dirty="0">
+                        <a:latin typeface="Calibri" charset="0"/>
+                        <a:ea typeface="Calibri" charset="0"/>
+                        <a:cs typeface="Calibri" charset="0"/>
+                      </a:endParaRPr>
+                    </a:p>
+                    <a:p>
+                      <a:pPr algn="ctr" indent="0" marL="0">
+                        <a:buNone/>
+                      </a:pPr>
+                      <a:r>
+                        <a:rPr lang="en-US" sz="1100" dirty="0">
+                          <a:solidFill>
+                            <a:srgbClr val="5B6576"/>
+                          </a:solidFill>
+                          <a:latin typeface="Calibri" pitchFamily="34" charset="0"/>
+                          <a:ea typeface="Calibri" pitchFamily="34" charset="-122"/>
+                          <a:cs typeface="Calibri" pitchFamily="34" charset="-120"/>
+                        </a:rPr>
+                        <a:t>(1.7k)</a:t>
+                      </a:r>
+                      <a:endParaRPr lang="en-US" sz="1250" dirty="0">
                         <a:latin typeface="Calibri" charset="0"/>
                         <a:ea typeface="Calibri" charset="0"/>
                         <a:cs typeface="Calibri" charset="0"/>
                       </a:endParaRPr>
                     </a:p>
                   </a:txBody>
-                  <a:tcPr marL="50800" marR="50800" marT="38100" marB="38100" anchor="ctr">
+                  <a:tcPr marL="38100" marR="38100" marT="25400" marB="25400" anchor="ctr">
+                    <a:lnL w="9525" cap="flat" cmpd="sng" algn="ctr">
+                      <a:solidFill>
+                        <a:srgbClr val="C9D3E0"/>
+                      </a:solidFill>
+                      <a:prstDash val="solid"/>
+                      <a:round/>
+                      <a:headEnd type="none" w="med" len="med"/>
+                      <a:tailEnd type="none" w="med" len="med"/>
+                    </a:lnL>
+                    <a:lnR w="9525" cap="flat" cmpd="sng" algn="ctr">
+                      <a:solidFill>
+                        <a:srgbClr val="C9D3E0"/>
+                      </a:solidFill>
+                      <a:prstDash val="solid"/>
+                      <a:round/>
+                      <a:headEnd type="none" w="med" len="med"/>
+                      <a:tailEnd type="none" w="med" len="med"/>
+                    </a:lnR>
+                    <a:lnT w="9525" cap="flat" cmpd="sng" algn="ctr">
+                      <a:solidFill>
+                        <a:srgbClr val="C9D3E0"/>
+                      </a:solidFill>
+                      <a:prstDash val="solid"/>
+                      <a:round/>
+                      <a:headEnd type="none" w="med" len="med"/>
+                      <a:tailEnd type="none" w="med" len="med"/>
+                    </a:lnT>
+                    <a:lnB w="9525" cap="flat" cmpd="sng" algn="ctr">
+                      <a:solidFill>
+                        <a:srgbClr val="C9D3E0"/>
+                      </a:solidFill>
+                      <a:prstDash val="solid"/>
+                      <a:round/>
+                      <a:headEnd type="none" w="med" len="med"/>
+                      <a:tailEnd type="none" w="med" len="med"/>
+                    </a:lnB>
+                  </a:tcPr>
+                </a:tc>
+              </a:tr>
+              <a:tr h="512064">
+                <a:tc>
+                  <a:txBody>
+                    <a:bodyPr/>
+                    <a:lstStyle/>
+                    <a:p>
+                      <a:pPr algn="ctr" indent="0" marL="0">
+                        <a:buNone/>
+                      </a:pPr>
+                      <a:r>
+                        <a:rPr lang="en-US" sz="1250" dirty="0">
+                          <a:solidFill>
+                            <a:srgbClr val="1F2937"/>
+                          </a:solidFill>
+                          <a:latin typeface="Calibri" pitchFamily="34" charset="0"/>
+                          <a:ea typeface="Calibri" pitchFamily="34" charset="-122"/>
+                          <a:cs typeface="Calibri" pitchFamily="34" charset="-120"/>
+                        </a:rPr>
+                        <a:t>protein</a:t>
+                      </a:r>
+                      <a:endParaRPr lang="en-US" sz="1250" dirty="0">
+                        <a:latin typeface="Calibri" charset="0"/>
+                        <a:ea typeface="Calibri" charset="0"/>
+                        <a:cs typeface="Calibri" charset="0"/>
+                      </a:endParaRPr>
+                    </a:p>
+                  </a:txBody>
+                  <a:tcPr marL="38100" marR="38100" marT="25400" marB="25400" anchor="ctr">
                     <a:lnL w="9525" cap="flat" cmpd="sng" algn="ctr">
                       <a:solidFill>
                         <a:srgbClr val="C9D3E0"/>
@@ -30480,28 +32745,49 @@
                     <a:bodyPr/>
                     <a:lstStyle/>
                     <a:p>
-                      <a:pPr indent="0" marL="0">
+                      <a:pPr algn="ctr" indent="0" marL="0">
                         <a:buNone/>
                       </a:pPr>
                       <a:r>
-                        <a:rPr lang="en-US" sz="1150" i="1" dirty="0">
+                        <a:rPr lang="en-US" sz="1250" b="1" dirty="0">
                           <a:solidFill>
-                            <a:srgbClr val="9AA5B4"/>
+                            <a:srgbClr val="1F2937"/>
                           </a:solidFill>
                           <a:latin typeface="Calibri" pitchFamily="34" charset="0"/>
                           <a:ea typeface="Calibri" pitchFamily="34" charset="-122"/>
                           <a:cs typeface="Calibri" pitchFamily="34" charset="-120"/>
                         </a:rPr>
-                        <a:t>tbd</a:t>
+                        <a:t>5.4k</a:t>
                       </a:r>
-                      <a:endParaRPr lang="en-US" sz="1150" dirty="0">
+                      <a:endParaRPr lang="en-US" sz="1250" dirty="0">
+                        <a:latin typeface="Calibri" charset="0"/>
+                        <a:ea typeface="Calibri" charset="0"/>
+                        <a:cs typeface="Calibri" charset="0"/>
+                      </a:endParaRPr>
+                    </a:p>
+                    <a:p>
+                      <a:pPr algn="ctr" indent="0" marL="0">
+                        <a:buNone/>
+                      </a:pPr>
+                      <a:r>
+                        <a:rPr lang="en-US" sz="1100" dirty="0">
+                          <a:solidFill>
+                            <a:srgbClr val="5B6576"/>
+                          </a:solidFill>
+                          <a:latin typeface="Calibri" pitchFamily="34" charset="0"/>
+                          <a:ea typeface="Calibri" pitchFamily="34" charset="-122"/>
+                          <a:cs typeface="Calibri" pitchFamily="34" charset="-120"/>
+                        </a:rPr>
+                        <a:t>(3.7k)</a:t>
+                      </a:r>
+                      <a:endParaRPr lang="en-US" sz="1250" dirty="0">
                         <a:latin typeface="Calibri" charset="0"/>
                         <a:ea typeface="Calibri" charset="0"/>
                         <a:cs typeface="Calibri" charset="0"/>
                       </a:endParaRPr>
                     </a:p>
                   </a:txBody>
-                  <a:tcPr marL="50800" marR="50800" marT="38100" marB="38100" anchor="ctr">
+                  <a:tcPr marL="38100" marR="38100" marT="25400" marB="25400" anchor="ctr">
                     <a:lnL w="9525" cap="flat" cmpd="sng" algn="ctr">
                       <a:solidFill>
                         <a:srgbClr val="C9D3E0"/>
@@ -30545,28 +32831,49 @@
                     <a:bodyPr/>
                     <a:lstStyle/>
                     <a:p>
-                      <a:pPr indent="0" marL="0">
+                      <a:pPr algn="ctr" indent="0" marL="0">
                         <a:buNone/>
                       </a:pPr>
                       <a:r>
-                        <a:rPr lang="en-US" sz="1150" i="1" dirty="0">
+                        <a:rPr lang="en-US" sz="1250" b="1" dirty="0">
                           <a:solidFill>
-                            <a:srgbClr val="9AA5B4"/>
+                            <a:srgbClr val="1F2937"/>
                           </a:solidFill>
                           <a:latin typeface="Calibri" pitchFamily="34" charset="0"/>
                           <a:ea typeface="Calibri" pitchFamily="34" charset="-122"/>
                           <a:cs typeface="Calibri" pitchFamily="34" charset="-120"/>
                         </a:rPr>
-                        <a:t>tbd</a:t>
+                        <a:t>2.8k</a:t>
                       </a:r>
-                      <a:endParaRPr lang="en-US" sz="1150" dirty="0">
+                      <a:endParaRPr lang="en-US" sz="1250" dirty="0">
+                        <a:latin typeface="Calibri" charset="0"/>
+                        <a:ea typeface="Calibri" charset="0"/>
+                        <a:cs typeface="Calibri" charset="0"/>
+                      </a:endParaRPr>
+                    </a:p>
+                    <a:p>
+                      <a:pPr algn="ctr" indent="0" marL="0">
+                        <a:buNone/>
+                      </a:pPr>
+                      <a:r>
+                        <a:rPr lang="en-US" sz="1100" dirty="0">
+                          <a:solidFill>
+                            <a:srgbClr val="5B6576"/>
+                          </a:solidFill>
+                          <a:latin typeface="Calibri" pitchFamily="34" charset="0"/>
+                          <a:ea typeface="Calibri" pitchFamily="34" charset="-122"/>
+                          <a:cs typeface="Calibri" pitchFamily="34" charset="-120"/>
+                        </a:rPr>
+                        <a:t>(1.7k)</a:t>
+                      </a:r>
+                      <a:endParaRPr lang="en-US" sz="1250" dirty="0">
                         <a:latin typeface="Calibri" charset="0"/>
                         <a:ea typeface="Calibri" charset="0"/>
                         <a:cs typeface="Calibri" charset="0"/>
                       </a:endParaRPr>
                     </a:p>
                   </a:txBody>
-                  <a:tcPr marL="50800" marR="50800" marT="38100" marB="38100" anchor="ctr">
+                  <a:tcPr marL="38100" marR="38100" marT="25400" marB="25400" anchor="ctr">
                     <a:lnL w="9525" cap="flat" cmpd="sng" algn="ctr">
                       <a:solidFill>
                         <a:srgbClr val="C9D3E0"/>
@@ -30610,78 +32917,11 @@
                     <a:bodyPr/>
                     <a:lstStyle/>
                     <a:p>
-                      <a:pPr indent="0" marL="0">
+                      <a:pPr algn="ctr" indent="0" marL="0">
                         <a:buNone/>
                       </a:pPr>
                       <a:r>
-                        <a:rPr lang="en-US" sz="1150" i="1" dirty="0">
-                          <a:solidFill>
-                            <a:srgbClr val="9AA5B4"/>
-                          </a:solidFill>
-                          <a:latin typeface="Calibri" pitchFamily="34" charset="0"/>
-                          <a:ea typeface="Calibri" pitchFamily="34" charset="-122"/>
-                          <a:cs typeface="Calibri" pitchFamily="34" charset="-120"/>
-                        </a:rPr>
-                        <a:t>tbd</a:t>
-                      </a:r>
-                      <a:endParaRPr lang="en-US" sz="1150" dirty="0">
-                        <a:latin typeface="Calibri" charset="0"/>
-                        <a:ea typeface="Calibri" charset="0"/>
-                        <a:cs typeface="Calibri" charset="0"/>
-                      </a:endParaRPr>
-                    </a:p>
-                  </a:txBody>
-                  <a:tcPr marL="50800" marR="50800" marT="38100" marB="38100" anchor="ctr">
-                    <a:lnL w="9525" cap="flat" cmpd="sng" algn="ctr">
-                      <a:solidFill>
-                        <a:srgbClr val="C9D3E0"/>
-                      </a:solidFill>
-                      <a:prstDash val="solid"/>
-                      <a:round/>
-                      <a:headEnd type="none" w="med" len="med"/>
-                      <a:tailEnd type="none" w="med" len="med"/>
-                    </a:lnL>
-                    <a:lnR w="9525" cap="flat" cmpd="sng" algn="ctr">
-                      <a:solidFill>
-                        <a:srgbClr val="C9D3E0"/>
-                      </a:solidFill>
-                      <a:prstDash val="solid"/>
-                      <a:round/>
-                      <a:headEnd type="none" w="med" len="med"/>
-                      <a:tailEnd type="none" w="med" len="med"/>
-                    </a:lnR>
-                    <a:lnT w="9525" cap="flat" cmpd="sng" algn="ctr">
-                      <a:solidFill>
-                        <a:srgbClr val="C9D3E0"/>
-                      </a:solidFill>
-                      <a:prstDash val="solid"/>
-                      <a:round/>
-                      <a:headEnd type="none" w="med" len="med"/>
-                      <a:tailEnd type="none" w="med" len="med"/>
-                    </a:lnT>
-                    <a:lnB w="9525" cap="flat" cmpd="sng" algn="ctr">
-                      <a:solidFill>
-                        <a:srgbClr val="C9D3E0"/>
-                      </a:solidFill>
-                      <a:prstDash val="solid"/>
-                      <a:round/>
-                      <a:headEnd type="none" w="med" len="med"/>
-                      <a:tailEnd type="none" w="med" len="med"/>
-                    </a:lnB>
-                  </a:tcPr>
-                </a:tc>
-              </a:tr>
-              <a:tr h="438912">
-                <a:tc>
-                  <a:txBody>
-                    <a:bodyPr/>
-                    <a:lstStyle/>
-                    <a:p>
-                      <a:pPr indent="0" marL="0">
-                        <a:buNone/>
-                      </a:pPr>
-                      <a:r>
-                        <a:rPr lang="en-US" sz="1150" dirty="0">
+                        <a:rPr lang="en-US" sz="1250" b="1" dirty="0">
                           <a:solidFill>
                             <a:srgbClr val="1F2937"/>
                           </a:solidFill>
@@ -30689,16 +32929,37 @@
                           <a:ea typeface="Calibri" pitchFamily="34" charset="-122"/>
                           <a:cs typeface="Calibri" pitchFamily="34" charset="-120"/>
                         </a:rPr>
-                        <a:t>10⁶ (chunked)</a:t>
+                        <a:t>1.4k</a:t>
                       </a:r>
-                      <a:endParaRPr lang="en-US" sz="1150" dirty="0">
+                      <a:endParaRPr lang="en-US" sz="1250" dirty="0">
+                        <a:latin typeface="Calibri" charset="0"/>
+                        <a:ea typeface="Calibri" charset="0"/>
+                        <a:cs typeface="Calibri" charset="0"/>
+                      </a:endParaRPr>
+                    </a:p>
+                    <a:p>
+                      <a:pPr algn="ctr" indent="0" marL="0">
+                        <a:buNone/>
+                      </a:pPr>
+                      <a:r>
+                        <a:rPr lang="en-US" sz="1100" dirty="0">
+                          <a:solidFill>
+                            <a:srgbClr val="5B6576"/>
+                          </a:solidFill>
+                          <a:latin typeface="Calibri" pitchFamily="34" charset="0"/>
+                          <a:ea typeface="Calibri" pitchFamily="34" charset="-122"/>
+                          <a:cs typeface="Calibri" pitchFamily="34" charset="-120"/>
+                        </a:rPr>
+                        <a:t>(784)</a:t>
+                      </a:r>
+                      <a:endParaRPr lang="en-US" sz="1250" dirty="0">
                         <a:latin typeface="Calibri" charset="0"/>
                         <a:ea typeface="Calibri" charset="0"/>
                         <a:cs typeface="Calibri" charset="0"/>
                       </a:endParaRPr>
                     </a:p>
                   </a:txBody>
-                  <a:tcPr marL="50800" marR="50800" marT="38100" marB="38100" anchor="ctr">
+                  <a:tcPr marL="38100" marR="38100" marT="25400" marB="25400" anchor="ctr">
                     <a:lnL w="9525" cap="flat" cmpd="sng" algn="ctr">
                       <a:solidFill>
                         <a:srgbClr val="C9D3E0"/>
@@ -30742,11 +33003,11 @@
                     <a:bodyPr/>
                     <a:lstStyle/>
                     <a:p>
-                      <a:pPr indent="0" marL="0">
+                      <a:pPr algn="ctr" indent="0" marL="0">
                         <a:buNone/>
                       </a:pPr>
                       <a:r>
-                        <a:rPr lang="en-US" sz="1150" dirty="0">
+                        <a:rPr lang="en-US" sz="1250" b="1" dirty="0">
                           <a:solidFill>
                             <a:srgbClr val="1F2937"/>
                           </a:solidFill>
@@ -30754,276 +33015,37 @@
                           <a:ea typeface="Calibri" pitchFamily="34" charset="-122"/>
                           <a:cs typeface="Calibri" pitchFamily="34" charset="-120"/>
                         </a:rPr>
-                        <a:t>20</a:t>
+                        <a:t>619</a:t>
                       </a:r>
-                      <a:endParaRPr lang="en-US" sz="1150" dirty="0">
+                      <a:endParaRPr lang="en-US" sz="1250" dirty="0">
+                        <a:latin typeface="Calibri" charset="0"/>
+                        <a:ea typeface="Calibri" charset="0"/>
+                        <a:cs typeface="Calibri" charset="0"/>
+                      </a:endParaRPr>
+                    </a:p>
+                    <a:p>
+                      <a:pPr algn="ctr" indent="0" marL="0">
+                        <a:buNone/>
+                      </a:pPr>
+                      <a:r>
+                        <a:rPr lang="en-US" sz="1100" dirty="0">
+                          <a:solidFill>
+                            <a:srgbClr val="5B6576"/>
+                          </a:solidFill>
+                          <a:latin typeface="Calibri" pitchFamily="34" charset="0"/>
+                          <a:ea typeface="Calibri" pitchFamily="34" charset="-122"/>
+                          <a:cs typeface="Calibri" pitchFamily="34" charset="-120"/>
+                        </a:rPr>
+                        <a:t>(295)</a:t>
+                      </a:r>
+                      <a:endParaRPr lang="en-US" sz="1250" dirty="0">
                         <a:latin typeface="Calibri" charset="0"/>
                         <a:ea typeface="Calibri" charset="0"/>
                         <a:cs typeface="Calibri" charset="0"/>
                       </a:endParaRPr>
                     </a:p>
                   </a:txBody>
-                  <a:tcPr marL="50800" marR="50800" marT="38100" marB="38100" anchor="ctr">
-                    <a:lnL w="9525" cap="flat" cmpd="sng" algn="ctr">
-                      <a:solidFill>
-                        <a:srgbClr val="C9D3E0"/>
-                      </a:solidFill>
-                      <a:prstDash val="solid"/>
-                      <a:round/>
-                      <a:headEnd type="none" w="med" len="med"/>
-                      <a:tailEnd type="none" w="med" len="med"/>
-                    </a:lnL>
-                    <a:lnR w="9525" cap="flat" cmpd="sng" algn="ctr">
-                      <a:solidFill>
-                        <a:srgbClr val="C9D3E0"/>
-                      </a:solidFill>
-                      <a:prstDash val="solid"/>
-                      <a:round/>
-                      <a:headEnd type="none" w="med" len="med"/>
-                      <a:tailEnd type="none" w="med" len="med"/>
-                    </a:lnR>
-                    <a:lnT w="9525" cap="flat" cmpd="sng" algn="ctr">
-                      <a:solidFill>
-                        <a:srgbClr val="C9D3E0"/>
-                      </a:solidFill>
-                      <a:prstDash val="solid"/>
-                      <a:round/>
-                      <a:headEnd type="none" w="med" len="med"/>
-                      <a:tailEnd type="none" w="med" len="med"/>
-                    </a:lnT>
-                    <a:lnB w="9525" cap="flat" cmpd="sng" algn="ctr">
-                      <a:solidFill>
-                        <a:srgbClr val="C9D3E0"/>
-                      </a:solidFill>
-                      <a:prstDash val="solid"/>
-                      <a:round/>
-                      <a:headEnd type="none" w="med" len="med"/>
-                      <a:tailEnd type="none" w="med" len="med"/>
-                    </a:lnB>
-                  </a:tcPr>
-                </a:tc>
-                <a:tc>
-                  <a:txBody>
-                    <a:bodyPr/>
-                    <a:lstStyle/>
-                    <a:p>
-                      <a:pPr indent="0" marL="0">
-                        <a:buNone/>
-                      </a:pPr>
-                      <a:r>
-                        <a:rPr lang="en-US" sz="1150" i="1" dirty="0">
-                          <a:solidFill>
-                            <a:srgbClr val="9AA5B4"/>
-                          </a:solidFill>
-                          <a:latin typeface="Calibri" pitchFamily="34" charset="0"/>
-                          <a:ea typeface="Calibri" pitchFamily="34" charset="-122"/>
-                          <a:cs typeface="Calibri" pitchFamily="34" charset="-120"/>
-                        </a:rPr>
-                        <a:t>tbd</a:t>
-                      </a:r>
-                      <a:endParaRPr lang="en-US" sz="1150" dirty="0">
-                        <a:latin typeface="Calibri" charset="0"/>
-                        <a:ea typeface="Calibri" charset="0"/>
-                        <a:cs typeface="Calibri" charset="0"/>
-                      </a:endParaRPr>
-                    </a:p>
-                  </a:txBody>
-                  <a:tcPr marL="50800" marR="50800" marT="38100" marB="38100" anchor="ctr">
-                    <a:lnL w="9525" cap="flat" cmpd="sng" algn="ctr">
-                      <a:solidFill>
-                        <a:srgbClr val="C9D3E0"/>
-                      </a:solidFill>
-                      <a:prstDash val="solid"/>
-                      <a:round/>
-                      <a:headEnd type="none" w="med" len="med"/>
-                      <a:tailEnd type="none" w="med" len="med"/>
-                    </a:lnL>
-                    <a:lnR w="9525" cap="flat" cmpd="sng" algn="ctr">
-                      <a:solidFill>
-                        <a:srgbClr val="C9D3E0"/>
-                      </a:solidFill>
-                      <a:prstDash val="solid"/>
-                      <a:round/>
-                      <a:headEnd type="none" w="med" len="med"/>
-                      <a:tailEnd type="none" w="med" len="med"/>
-                    </a:lnR>
-                    <a:lnT w="9525" cap="flat" cmpd="sng" algn="ctr">
-                      <a:solidFill>
-                        <a:srgbClr val="C9D3E0"/>
-                      </a:solidFill>
-                      <a:prstDash val="solid"/>
-                      <a:round/>
-                      <a:headEnd type="none" w="med" len="med"/>
-                      <a:tailEnd type="none" w="med" len="med"/>
-                    </a:lnT>
-                    <a:lnB w="9525" cap="flat" cmpd="sng" algn="ctr">
-                      <a:solidFill>
-                        <a:srgbClr val="C9D3E0"/>
-                      </a:solidFill>
-                      <a:prstDash val="solid"/>
-                      <a:round/>
-                      <a:headEnd type="none" w="med" len="med"/>
-                      <a:tailEnd type="none" w="med" len="med"/>
-                    </a:lnB>
-                  </a:tcPr>
-                </a:tc>
-                <a:tc>
-                  <a:txBody>
-                    <a:bodyPr/>
-                    <a:lstStyle/>
-                    <a:p>
-                      <a:pPr indent="0" marL="0">
-                        <a:buNone/>
-                      </a:pPr>
-                      <a:r>
-                        <a:rPr lang="en-US" sz="1150" i="1" dirty="0">
-                          <a:solidFill>
-                            <a:srgbClr val="9AA5B4"/>
-                          </a:solidFill>
-                          <a:latin typeface="Calibri" pitchFamily="34" charset="0"/>
-                          <a:ea typeface="Calibri" pitchFamily="34" charset="-122"/>
-                          <a:cs typeface="Calibri" pitchFamily="34" charset="-120"/>
-                        </a:rPr>
-                        <a:t>tbd</a:t>
-                      </a:r>
-                      <a:endParaRPr lang="en-US" sz="1150" dirty="0">
-                        <a:latin typeface="Calibri" charset="0"/>
-                        <a:ea typeface="Calibri" charset="0"/>
-                        <a:cs typeface="Calibri" charset="0"/>
-                      </a:endParaRPr>
-                    </a:p>
-                  </a:txBody>
-                  <a:tcPr marL="50800" marR="50800" marT="38100" marB="38100" anchor="ctr">
-                    <a:lnL w="9525" cap="flat" cmpd="sng" algn="ctr">
-                      <a:solidFill>
-                        <a:srgbClr val="C9D3E0"/>
-                      </a:solidFill>
-                      <a:prstDash val="solid"/>
-                      <a:round/>
-                      <a:headEnd type="none" w="med" len="med"/>
-                      <a:tailEnd type="none" w="med" len="med"/>
-                    </a:lnL>
-                    <a:lnR w="9525" cap="flat" cmpd="sng" algn="ctr">
-                      <a:solidFill>
-                        <a:srgbClr val="C9D3E0"/>
-                      </a:solidFill>
-                      <a:prstDash val="solid"/>
-                      <a:round/>
-                      <a:headEnd type="none" w="med" len="med"/>
-                      <a:tailEnd type="none" w="med" len="med"/>
-                    </a:lnR>
-                    <a:lnT w="9525" cap="flat" cmpd="sng" algn="ctr">
-                      <a:solidFill>
-                        <a:srgbClr val="C9D3E0"/>
-                      </a:solidFill>
-                      <a:prstDash val="solid"/>
-                      <a:round/>
-                      <a:headEnd type="none" w="med" len="med"/>
-                      <a:tailEnd type="none" w="med" len="med"/>
-                    </a:lnT>
-                    <a:lnB w="9525" cap="flat" cmpd="sng" algn="ctr">
-                      <a:solidFill>
-                        <a:srgbClr val="C9D3E0"/>
-                      </a:solidFill>
-                      <a:prstDash val="solid"/>
-                      <a:round/>
-                      <a:headEnd type="none" w="med" len="med"/>
-                      <a:tailEnd type="none" w="med" len="med"/>
-                    </a:lnB>
-                  </a:tcPr>
-                </a:tc>
-                <a:tc>
-                  <a:txBody>
-                    <a:bodyPr/>
-                    <a:lstStyle/>
-                    <a:p>
-                      <a:pPr indent="0" marL="0">
-                        <a:buNone/>
-                      </a:pPr>
-                      <a:r>
-                        <a:rPr lang="en-US" sz="1150" i="1" dirty="0">
-                          <a:solidFill>
-                            <a:srgbClr val="9AA5B4"/>
-                          </a:solidFill>
-                          <a:latin typeface="Calibri" pitchFamily="34" charset="0"/>
-                          <a:ea typeface="Calibri" pitchFamily="34" charset="-122"/>
-                          <a:cs typeface="Calibri" pitchFamily="34" charset="-120"/>
-                        </a:rPr>
-                        <a:t>tbd</a:t>
-                      </a:r>
-                      <a:endParaRPr lang="en-US" sz="1150" dirty="0">
-                        <a:latin typeface="Calibri" charset="0"/>
-                        <a:ea typeface="Calibri" charset="0"/>
-                        <a:cs typeface="Calibri" charset="0"/>
-                      </a:endParaRPr>
-                    </a:p>
-                  </a:txBody>
-                  <a:tcPr marL="50800" marR="50800" marT="38100" marB="38100" anchor="ctr">
-                    <a:lnL w="9525" cap="flat" cmpd="sng" algn="ctr">
-                      <a:solidFill>
-                        <a:srgbClr val="C9D3E0"/>
-                      </a:solidFill>
-                      <a:prstDash val="solid"/>
-                      <a:round/>
-                      <a:headEnd type="none" w="med" len="med"/>
-                      <a:tailEnd type="none" w="med" len="med"/>
-                    </a:lnL>
-                    <a:lnR w="9525" cap="flat" cmpd="sng" algn="ctr">
-                      <a:solidFill>
-                        <a:srgbClr val="C9D3E0"/>
-                      </a:solidFill>
-                      <a:prstDash val="solid"/>
-                      <a:round/>
-                      <a:headEnd type="none" w="med" len="med"/>
-                      <a:tailEnd type="none" w="med" len="med"/>
-                    </a:lnR>
-                    <a:lnT w="9525" cap="flat" cmpd="sng" algn="ctr">
-                      <a:solidFill>
-                        <a:srgbClr val="C9D3E0"/>
-                      </a:solidFill>
-                      <a:prstDash val="solid"/>
-                      <a:round/>
-                      <a:headEnd type="none" w="med" len="med"/>
-                      <a:tailEnd type="none" w="med" len="med"/>
-                    </a:lnT>
-                    <a:lnB w="9525" cap="flat" cmpd="sng" algn="ctr">
-                      <a:solidFill>
-                        <a:srgbClr val="C9D3E0"/>
-                      </a:solidFill>
-                      <a:prstDash val="solid"/>
-                      <a:round/>
-                      <a:headEnd type="none" w="med" len="med"/>
-                      <a:tailEnd type="none" w="med" len="med"/>
-                    </a:lnB>
-                  </a:tcPr>
-                </a:tc>
-                <a:tc>
-                  <a:txBody>
-                    <a:bodyPr/>
-                    <a:lstStyle/>
-                    <a:p>
-                      <a:pPr indent="0" marL="0">
-                        <a:buNone/>
-                      </a:pPr>
-                      <a:r>
-                        <a:rPr lang="en-US" sz="1150" i="1" dirty="0">
-                          <a:solidFill>
-                            <a:srgbClr val="9AA5B4"/>
-                          </a:solidFill>
-                          <a:latin typeface="Calibri" pitchFamily="34" charset="0"/>
-                          <a:ea typeface="Calibri" pitchFamily="34" charset="-122"/>
-                          <a:cs typeface="Calibri" pitchFamily="34" charset="-120"/>
-                        </a:rPr>
-                        <a:t>tbd</a:t>
-                      </a:r>
-                      <a:endParaRPr lang="en-US" sz="1150" dirty="0">
-                        <a:latin typeface="Calibri" charset="0"/>
-                        <a:ea typeface="Calibri" charset="0"/>
-                        <a:cs typeface="Calibri" charset="0"/>
-                      </a:endParaRPr>
-                    </a:p>
-                  </a:txBody>
-                  <a:tcPr marL="50800" marR="50800" marT="38100" marB="38100" anchor="ctr">
+                  <a:tcPr marL="38100" marR="38100" marT="25400" marB="25400" anchor="ctr">
                     <a:lnL w="9525" cap="flat" cmpd="sng" algn="ctr">
                       <a:solidFill>
                         <a:srgbClr val="C9D3E0"/>
@@ -31069,80 +33091,14 @@
       </p:graphicFrame>
       <p:sp>
         <p:nvSpPr>
-          <p:cNvPr id="10" name="Shape 6"/>
-          <p:cNvSpPr/>
-          <p:nvPr/>
-        </p:nvSpPr>
-        <p:spPr>
-          <a:xfrm>
-            <a:off x="6263640" y="4434840"/>
-            <a:ext cx="5349240" cy="1691640"/>
-          </a:xfrm>
-          <a:prstGeom prst="roundRect">
-            <a:avLst>
-              <a:gd name="adj" fmla="val 4324"/>
-            </a:avLst>
-          </a:prstGeom>
-          <a:solidFill>
-            <a:srgbClr val="F6E3D6"/>
-          </a:solidFill>
-          <a:ln w="12700">
-            <a:solidFill>
-              <a:srgbClr val="F6E3D6"/>
-            </a:solidFill>
-            <a:prstDash val="solid"/>
-          </a:ln>
-        </p:spPr>
-      </p:sp>
-      <p:sp>
-        <p:nvSpPr>
-          <p:cNvPr id="11" name="Text 7"/>
+          <p:cNvPr id="8" name="Text 4"/>
           <p:cNvSpPr txBox="1"/>
           <p:nvPr/>
         </p:nvSpPr>
         <p:spPr>
           <a:xfrm>
-            <a:off x="6492240" y="4553712"/>
-            <a:ext cx="4937760" cy="365760"/>
-          </a:xfrm>
-          <a:prstGeom prst="rect">
-            <a:avLst/>
-          </a:prstGeom>
-          <a:noFill/>
-          <a:ln/>
-        </p:spPr>
-        <p:txBody>
-          <a:bodyPr wrap="square" lIns="0" tIns="0" rIns="0" bIns="0" rtlCol="0" anchor="t"/>
-          <a:lstStyle/>
-          <a:p>
-            <a:pPr indent="0" marL="0">
-              <a:buNone/>
-            </a:pPr>
-            <a:r>
-              <a:rPr lang="en-US" sz="1500" b="1" dirty="0">
-                <a:solidFill>
-                  <a:srgbClr val="C45A0C"/>
-                </a:solidFill>
-                <a:latin typeface="Calibri" pitchFamily="34" charset="0"/>
-                <a:ea typeface="Calibri" pitchFamily="34" charset="-122"/>
-                <a:cs typeface="Calibri" pitchFamily="34" charset="-120"/>
-              </a:rPr>
-              <a:t>Also pending</a:t>
-            </a:r>
-            <a:endParaRPr lang="en-US" sz="1500" dirty="0"/>
-          </a:p>
-        </p:txBody>
-      </p:sp>
-      <p:sp>
-        <p:nvSpPr>
-          <p:cNvPr id="12" name="Text 8"/>
-          <p:cNvSpPr txBox="1"/>
-          <p:nvPr/>
-        </p:nvSpPr>
-        <p:spPr>
-          <a:xfrm>
-            <a:off x="6492240" y="4937760"/>
-            <a:ext cx="4937760" cy="1143000"/>
+            <a:off x="7360920" y="5029200"/>
+            <a:ext cx="4297680" cy="1371600"/>
           </a:xfrm>
           <a:prstGeom prst="rect">
             <a:avLst/>
@@ -31170,7 +33126,7 @@
                 <a:ea typeface="Calibri" pitchFamily="34" charset="-122"/>
                 <a:cs typeface="Calibri" pitchFamily="34" charset="-120"/>
               </a:rPr>
-              <a:t>Proof of the CKKS error-sensitivity bound S_err</a:t>
+              <a:t>Doubling ε roughly halves the records needed</a:t>
             </a:r>
             <a:endParaRPr lang="en-US" sz="1350" dirty="0"/>
           </a:p>
@@ -31191,7 +33147,7 @@
                 <a:ea typeface="Calibri" pitchFamily="34" charset="-122"/>
                 <a:cs typeface="Calibri" pitchFamily="34" charset="-120"/>
               </a:rPr>
-              <a:t>Finite-precision accounting for the discrete Gaussian</a:t>
+              <a:t>Ours needs about 1.5–2× the records AdaSSP needs for the same cost</a:t>
             </a:r>
             <a:endParaRPr lang="en-US" sz="1350" dirty="0"/>
           </a:p>
@@ -31212,7 +33168,7 @@
                 <a:ea typeface="Calibri" pitchFamily="34" charset="-122"/>
                 <a:cs typeface="Calibri" pitchFamily="34" charset="-120"/>
               </a:rPr>
-              <a:t>Standard errors for the ridge regime</a:t>
+              <a:t>elevators stays above 10% at every size available (up to 14.9k)</a:t>
             </a:r>
             <a:endParaRPr lang="en-US" sz="1350" dirty="0"/>
           </a:p>
@@ -32031,7 +33987,7 @@
                 <a:ea typeface="Calibri" pitchFamily="34" charset="-122"/>
                 <a:cs typeface="Calibri" pitchFamily="34" charset="-120"/>
               </a:rPr>
-              <a:t>Accuracy reaches 2× of non-private OLS at n ≈ 3k–100k, depending on ε</a:t>
+              <a:t>Within 2× of non-private OLS at n ≈ 3k–100k (simulation); within 10% at 1.4k–11k records for ε = 1–2 (real data)</a:t>
             </a:r>
             <a:endParaRPr lang="en-US" sz="1600" dirty="0"/>
           </a:p>
@@ -32134,7 +34090,7 @@
                 <a:ea typeface="Calibri" pitchFamily="34" charset="-122"/>
                 <a:cs typeface="Calibri" pitchFamily="34" charset="-120"/>
               </a:rPr>
-              <a:t>Against AdaSSP: ahead at small ε, behind at large ε; the gap shrinks as n grows</a:t>
+              <a:t>Against AdaSSP: ahead at small ε, behind at large ε, where it needs about 1.5–2× the matched records</a:t>
             </a:r>
             <a:endParaRPr lang="en-US" sz="1600" dirty="0"/>
           </a:p>
@@ -32329,27 +34285,6 @@
         <p:txBody>
           <a:bodyPr wrap="square" lIns="0" tIns="0" rIns="0" bIns="0" rtlCol="0" anchor="t"/>
           <a:lstStyle/>
-          <a:p>
-            <a:pPr marL="342900" indent="-342900">
-              <a:spcAft>
-                <a:spcPts val="1000"/>
-              </a:spcAft>
-              <a:buSzPct val="100000"/>
-              <a:buChar char="•"/>
-            </a:pPr>
-            <a:r>
-              <a:rPr lang="en-US" sz="1600" dirty="0">
-                <a:solidFill>
-                  <a:srgbClr val="FFFFFF"/>
-                </a:solidFill>
-                <a:latin typeface="Calibri" pitchFamily="34" charset="0"/>
-                <a:ea typeface="Calibri" pitchFamily="34" charset="-122"/>
-                <a:cs typeface="Calibri" pitchFamily="34" charset="-120"/>
-              </a:rPr>
-              <a:t>Real-data intersection-size sweeps</a:t>
-            </a:r>
-            <a:endParaRPr lang="en-US" sz="1600" dirty="0"/>
-          </a:p>
           <a:p>
             <a:pPr marL="342900" indent="-342900">
               <a:spcAft>

</xml_diff>

<commit_message>
Paper: add an empirical evaluation section with the new results
New Section 9 (Empirical Evaluation): exactness of the cryptographic layer,
coefficient accuracy vs intersection size in simulation, whether the
zero-budget correction matters, the AdaSSP benchmark on 29 UCI datasets
with paired tests, the real-data intersection-size sweep, and a diagnosis
of where utility is lost (ridge ablation, how well y fills its bound).
Tables are generated from the result CSVs. Abstract, contributions, the
ridge and correction subsections, next steps and references updated.

experiments/adassp/diagnostics.py reproduces the ablation and bound-fill
numbers (reports/adassp/diagnostics.md). Deck numbers aligned with the
paper (OpenFHE run ~13 s; correction effect under 4%).

Co-Authored-By: Claude Opus 5.5 <noreply@anthropic.com>
Claude-Session: https://claude.ai/code/session_01S5iva9x8cxUsdLiDVN39vQ
</commit_message>
<xml_diff>
--- a/slides/vfl_scenarioB_deck.pptx
+++ b/slides/vfl_scenarioB_deck.pptx
@@ -5524,7 +5524,7 @@
           <a:p>
             <a:r>
               <a:rPr lang="en-US" dirty="0"/>
-              <a:t>Native charts from reports/adassp/results.csv; paired verdicts from reports/adassp/all/compare.csv (all 29 datasets of Wang's published run, R = 50 draws per fold; a verdict needs the 95% CI of the paired fold difference to exclude 0). The bias correction changes test MSE by -2.8% to +2.3%: it helps at small eps and slightly hurts at large eps.</a:t>
+              <a:t>Native charts from reports/adassp/results.csv; paired verdicts from reports/adassp/all/compare.csv (all 29 datasets of Wang's published run, R = 50 draws per fold; a verdict needs the 95% CI of the paired fold difference to exclude 0). The bias correction changes test MSE by -3.7% to +2.3% across all eps: it helps at small eps and slightly hurts at large eps.</a:t>
             </a:r>
             <a:endParaRPr lang="en-US" dirty="0"/>
           </a:p>
@@ -16429,7 +16429,7 @@
                 <a:ea typeface="Cambria" pitchFamily="34" charset="-122"/>
                 <a:cs typeface="Cambria" pitchFamily="34" charset="-120"/>
               </a:rPr>
-              <a:t>13.8 s</a:t>
+              <a:t>≈13 s</a:t>
             </a:r>
             <a:endParaRPr lang="en-US" sz="3800" dirty="0"/>
           </a:p>
@@ -16507,7 +16507,7 @@
                 <a:ea typeface="Calibri" pitchFamily="34" charset="-122"/>
                 <a:cs typeface="Calibri" pitchFamily="34" charset="-120"/>
               </a:rPr>
-              <a:t>n_O = 4,000 records, n = 400 matched (plaintext backend: 3.2 s)</a:t>
+              <a:t>n = 400 matched out of n_O = 4,000 records (OpenFHE 1.5.1)</a:t>
             </a:r>
             <a:endParaRPr lang="en-US" sz="1300" dirty="0"/>
           </a:p>
@@ -34193,7 +34193,7 @@
                 <a:ea typeface="Calibri" pitchFamily="34" charset="-122"/>
                 <a:cs typeface="Calibri" pitchFamily="34" charset="-120"/>
               </a:rPr>
-              <a:t>The bias correction is a small effect (under 3% of test MSE); ridge shrinkage dominates when σ is large</a:t>
+              <a:t>The bias correction is a small effect (under 4% of test MSE); ridge shrinkage dominates when σ is large</a:t>
             </a:r>
             <a:endParaRPr lang="en-US" sz="1600" dirty="0"/>
           </a:p>

</xml_diff>